<commit_message>
Updaterad presentation enligt senaste program.
</commit_message>
<xml_diff>
--- a/marketplace_safety_slides.pptx
+++ b/marketplace_safety_slides.pptx
@@ -118,17 +118,64 @@
 </p:presentation>
 </file>
 
+<file path=ppt/revisionInfo.xml><?xml version="1.0" encoding="utf-8"?>
+<p1510:revInfo xmlns:a="http://schemas.openxmlformats.org/drawingml/2006/main" xmlns:r="http://schemas.openxmlformats.org/officeDocument/2006/relationships" xmlns:p1510="http://schemas.microsoft.com/office/powerpoint/2015/10/main">
+  <p1510:revLst>
+    <p1510:client id="{2D54AF1E-4C82-48AE-BAD0-2A999153E33B}" v="56" dt="2026-03-16T14:49:07.663"/>
+  </p1510:revLst>
+</p1510:revInfo>
+</file>
+
 <file path=ppt/changesInfos/changesInfo1.xml><?xml version="1.0" encoding="utf-8"?>
 <pc:chgInfo xmlns:a="http://schemas.openxmlformats.org/drawingml/2006/main" xmlns:r="http://schemas.openxmlformats.org/officeDocument/2006/relationships" xmlns:ac="http://schemas.microsoft.com/office/drawing/2013/main/command" xmlns:pc="http://schemas.microsoft.com/office/powerpoint/2013/main/command">
   <pc:docChgLst>
     <pc:chgData name="Yunus Emre Capar" userId="6e34af16be8e7db1" providerId="LiveId" clId="{1A4E8B3D-71E9-45CB-9AC9-58DE4384F4B0}"/>
-    <pc:docChg chg="modSld">
-      <pc:chgData name="Yunus Emre Capar" userId="6e34af16be8e7db1" providerId="LiveId" clId="{1A4E8B3D-71E9-45CB-9AC9-58DE4384F4B0}" dt="2026-03-11T12:48:11.610" v="7" actId="14100"/>
+    <pc:docChg chg="undo custSel modSld">
+      <pc:chgData name="Yunus Emre Capar" userId="6e34af16be8e7db1" providerId="LiveId" clId="{1A4E8B3D-71E9-45CB-9AC9-58DE4384F4B0}" dt="2026-03-16T14:49:07.663" v="190"/>
       <pc:docMkLst>
         <pc:docMk/>
       </pc:docMkLst>
       <pc:sldChg chg="modSp mod">
-        <pc:chgData name="Yunus Emre Capar" userId="6e34af16be8e7db1" providerId="LiveId" clId="{1A4E8B3D-71E9-45CB-9AC9-58DE4384F4B0}" dt="2026-03-11T12:48:11.610" v="7" actId="14100"/>
+        <pc:chgData name="Yunus Emre Capar" userId="6e34af16be8e7db1" providerId="LiveId" clId="{1A4E8B3D-71E9-45CB-9AC9-58DE4384F4B0}" dt="2026-03-16T14:10:55.303" v="29"/>
+        <pc:sldMkLst>
+          <pc:docMk/>
+          <pc:sldMk cId="0" sldId="258"/>
+        </pc:sldMkLst>
+        <pc:spChg chg="mod">
+          <ac:chgData name="Yunus Emre Capar" userId="6e34af16be8e7db1" providerId="LiveId" clId="{1A4E8B3D-71E9-45CB-9AC9-58DE4384F4B0}" dt="2026-03-16T14:08:48.581" v="16" actId="120"/>
+          <ac:spMkLst>
+            <pc:docMk/>
+            <pc:sldMk cId="0" sldId="258"/>
+            <ac:spMk id="4" creationId="{00000000-0000-0000-0000-000000000000}"/>
+          </ac:spMkLst>
+        </pc:spChg>
+        <pc:spChg chg="mod">
+          <ac:chgData name="Yunus Emre Capar" userId="6e34af16be8e7db1" providerId="LiveId" clId="{1A4E8B3D-71E9-45CB-9AC9-58DE4384F4B0}" dt="2026-03-16T14:10:23.279" v="28" actId="20577"/>
+          <ac:spMkLst>
+            <pc:docMk/>
+            <pc:sldMk cId="0" sldId="258"/>
+            <ac:spMk id="15" creationId="{00000000-0000-0000-0000-000000000000}"/>
+          </ac:spMkLst>
+        </pc:spChg>
+        <pc:spChg chg="mod">
+          <ac:chgData name="Yunus Emre Capar" userId="6e34af16be8e7db1" providerId="LiveId" clId="{1A4E8B3D-71E9-45CB-9AC9-58DE4384F4B0}" dt="2026-03-16T14:03:10.812" v="9"/>
+          <ac:spMkLst>
+            <pc:docMk/>
+            <pc:sldMk cId="0" sldId="258"/>
+            <ac:spMk id="20" creationId="{00000000-0000-0000-0000-000000000000}"/>
+          </ac:spMkLst>
+        </pc:spChg>
+        <pc:spChg chg="mod">
+          <ac:chgData name="Yunus Emre Capar" userId="6e34af16be8e7db1" providerId="LiveId" clId="{1A4E8B3D-71E9-45CB-9AC9-58DE4384F4B0}" dt="2026-03-16T14:10:55.303" v="29"/>
+          <ac:spMkLst>
+            <pc:docMk/>
+            <pc:sldMk cId="0" sldId="258"/>
+            <ac:spMk id="21" creationId="{00000000-0000-0000-0000-000000000000}"/>
+          </ac:spMkLst>
+        </pc:spChg>
+      </pc:sldChg>
+      <pc:sldChg chg="modSp mod">
+        <pc:chgData name="Yunus Emre Capar" userId="6e34af16be8e7db1" providerId="LiveId" clId="{1A4E8B3D-71E9-45CB-9AC9-58DE4384F4B0}" dt="2026-03-16T14:19:57.217" v="52" actId="20577"/>
         <pc:sldMkLst>
           <pc:docMk/>
           <pc:sldMk cId="0" sldId="259"/>
@@ -149,14 +196,219 @@
             <ac:spMk id="4" creationId="{00000000-0000-0000-0000-000000000000}"/>
           </ac:spMkLst>
         </pc:spChg>
+        <pc:spChg chg="mod">
+          <ac:chgData name="Yunus Emre Capar" userId="6e34af16be8e7db1" providerId="LiveId" clId="{1A4E8B3D-71E9-45CB-9AC9-58DE4384F4B0}" dt="2026-03-16T14:19:57.217" v="52" actId="20577"/>
+          <ac:spMkLst>
+            <pc:docMk/>
+            <pc:sldMk cId="0" sldId="259"/>
+            <ac:spMk id="40" creationId="{00000000-0000-0000-0000-000000000000}"/>
+          </ac:spMkLst>
+        </pc:spChg>
         <pc:graphicFrameChg chg="modGraphic">
-          <ac:chgData name="Yunus Emre Capar" userId="6e34af16be8e7db1" providerId="LiveId" clId="{1A4E8B3D-71E9-45CB-9AC9-58DE4384F4B0}" dt="2026-03-11T12:47:52.077" v="5" actId="20577"/>
+          <ac:chgData name="Yunus Emre Capar" userId="6e34af16be8e7db1" providerId="LiveId" clId="{1A4E8B3D-71E9-45CB-9AC9-58DE4384F4B0}" dt="2026-03-16T14:16:54.157" v="35" actId="20577"/>
           <ac:graphicFrameMkLst>
             <pc:docMk/>
             <pc:sldMk cId="0" sldId="259"/>
             <ac:graphicFrameMk id="43" creationId="{72C8AFF7-0E47-2678-2A01-53551B3BFD4D}"/>
           </ac:graphicFrameMkLst>
         </pc:graphicFrameChg>
+      </pc:sldChg>
+      <pc:sldChg chg="addSp modSp mod">
+        <pc:chgData name="Yunus Emre Capar" userId="6e34af16be8e7db1" providerId="LiveId" clId="{1A4E8B3D-71E9-45CB-9AC9-58DE4384F4B0}" dt="2026-03-16T14:35:12.892" v="120" actId="1076"/>
+        <pc:sldMkLst>
+          <pc:docMk/>
+          <pc:sldMk cId="0" sldId="260"/>
+        </pc:sldMkLst>
+        <pc:spChg chg="mod">
+          <ac:chgData name="Yunus Emre Capar" userId="6e34af16be8e7db1" providerId="LiveId" clId="{1A4E8B3D-71E9-45CB-9AC9-58DE4384F4B0}" dt="2026-03-16T14:21:53.047" v="57" actId="113"/>
+          <ac:spMkLst>
+            <pc:docMk/>
+            <pc:sldMk cId="0" sldId="260"/>
+            <ac:spMk id="4" creationId="{00000000-0000-0000-0000-000000000000}"/>
+          </ac:spMkLst>
+        </pc:spChg>
+        <pc:spChg chg="mod">
+          <ac:chgData name="Yunus Emre Capar" userId="6e34af16be8e7db1" providerId="LiveId" clId="{1A4E8B3D-71E9-45CB-9AC9-58DE4384F4B0}" dt="2026-03-16T14:22:18.328" v="61" actId="113"/>
+          <ac:spMkLst>
+            <pc:docMk/>
+            <pc:sldMk cId="0" sldId="260"/>
+            <ac:spMk id="6" creationId="{00000000-0000-0000-0000-000000000000}"/>
+          </ac:spMkLst>
+        </pc:spChg>
+        <pc:spChg chg="mod">
+          <ac:chgData name="Yunus Emre Capar" userId="6e34af16be8e7db1" providerId="LiveId" clId="{1A4E8B3D-71E9-45CB-9AC9-58DE4384F4B0}" dt="2026-03-16T14:22:43.560" v="67" actId="114"/>
+          <ac:spMkLst>
+            <pc:docMk/>
+            <pc:sldMk cId="0" sldId="260"/>
+            <ac:spMk id="7" creationId="{00000000-0000-0000-0000-000000000000}"/>
+          </ac:spMkLst>
+        </pc:spChg>
+        <pc:spChg chg="mod">
+          <ac:chgData name="Yunus Emre Capar" userId="6e34af16be8e7db1" providerId="LiveId" clId="{1A4E8B3D-71E9-45CB-9AC9-58DE4384F4B0}" dt="2026-03-16T14:23:02.738" v="71" actId="113"/>
+          <ac:spMkLst>
+            <pc:docMk/>
+            <pc:sldMk cId="0" sldId="260"/>
+            <ac:spMk id="8" creationId="{00000000-0000-0000-0000-000000000000}"/>
+          </ac:spMkLst>
+        </pc:spChg>
+        <pc:spChg chg="add">
+          <ac:chgData name="Yunus Emre Capar" userId="6e34af16be8e7db1" providerId="LiveId" clId="{1A4E8B3D-71E9-45CB-9AC9-58DE4384F4B0}" dt="2026-03-16T14:33:20.357" v="100"/>
+          <ac:spMkLst>
+            <pc:docMk/>
+            <pc:sldMk cId="0" sldId="260"/>
+            <ac:spMk id="9" creationId="{716DB9BF-E61B-0B72-971D-0E4362D36838}"/>
+          </ac:spMkLst>
+        </pc:spChg>
+        <pc:spChg chg="add mod">
+          <ac:chgData name="Yunus Emre Capar" userId="6e34af16be8e7db1" providerId="LiveId" clId="{1A4E8B3D-71E9-45CB-9AC9-58DE4384F4B0}" dt="2026-03-16T14:35:12.892" v="120" actId="1076"/>
+          <ac:spMkLst>
+            <pc:docMk/>
+            <pc:sldMk cId="0" sldId="260"/>
+            <ac:spMk id="10" creationId="{79CD0458-E099-CD06-A7F2-682930136BD9}"/>
+          </ac:spMkLst>
+        </pc:spChg>
+        <pc:spChg chg="add">
+          <ac:chgData name="Yunus Emre Capar" userId="6e34af16be8e7db1" providerId="LiveId" clId="{1A4E8B3D-71E9-45CB-9AC9-58DE4384F4B0}" dt="2026-03-16T14:34:02.880" v="107"/>
+          <ac:spMkLst>
+            <pc:docMk/>
+            <pc:sldMk cId="0" sldId="260"/>
+            <ac:spMk id="11" creationId="{32969947-47A5-C9DF-5601-FB78E71F78E2}"/>
+          </ac:spMkLst>
+        </pc:spChg>
+        <pc:spChg chg="add">
+          <ac:chgData name="Yunus Emre Capar" userId="6e34af16be8e7db1" providerId="LiveId" clId="{1A4E8B3D-71E9-45CB-9AC9-58DE4384F4B0}" dt="2026-03-16T14:34:08.112" v="108"/>
+          <ac:spMkLst>
+            <pc:docMk/>
+            <pc:sldMk cId="0" sldId="260"/>
+            <ac:spMk id="12" creationId="{C3D9BE1C-158E-064B-B65B-3FA22143984E}"/>
+          </ac:spMkLst>
+        </pc:spChg>
+        <pc:spChg chg="add">
+          <ac:chgData name="Yunus Emre Capar" userId="6e34af16be8e7db1" providerId="LiveId" clId="{1A4E8B3D-71E9-45CB-9AC9-58DE4384F4B0}" dt="2026-03-16T14:34:13.434" v="109"/>
+          <ac:spMkLst>
+            <pc:docMk/>
+            <pc:sldMk cId="0" sldId="260"/>
+            <ac:spMk id="13" creationId="{17C30343-4885-0C2C-7DC8-393DEB5F6AD4}"/>
+          </ac:spMkLst>
+        </pc:spChg>
+        <pc:spChg chg="add">
+          <ac:chgData name="Yunus Emre Capar" userId="6e34af16be8e7db1" providerId="LiveId" clId="{1A4E8B3D-71E9-45CB-9AC9-58DE4384F4B0}" dt="2026-03-16T14:34:17.971" v="111"/>
+          <ac:spMkLst>
+            <pc:docMk/>
+            <pc:sldMk cId="0" sldId="260"/>
+            <ac:spMk id="14" creationId="{34E41B34-0DEF-8CC8-52CB-0DE21030A91A}"/>
+          </ac:spMkLst>
+        </pc:spChg>
+        <pc:spChg chg="mod">
+          <ac:chgData name="Yunus Emre Capar" userId="6e34af16be8e7db1" providerId="LiveId" clId="{1A4E8B3D-71E9-45CB-9AC9-58DE4384F4B0}" dt="2026-03-16T14:31:31.243" v="89" actId="1076"/>
+          <ac:spMkLst>
+            <pc:docMk/>
+            <pc:sldMk cId="0" sldId="260"/>
+            <ac:spMk id="27" creationId="{00000000-0000-0000-0000-000000000000}"/>
+          </ac:spMkLst>
+        </pc:spChg>
+        <pc:graphicFrameChg chg="mod modGraphic">
+          <ac:chgData name="Yunus Emre Capar" userId="6e34af16be8e7db1" providerId="LiveId" clId="{1A4E8B3D-71E9-45CB-9AC9-58DE4384F4B0}" dt="2026-03-16T14:32:38.686" v="99"/>
+          <ac:graphicFrameMkLst>
+            <pc:docMk/>
+            <pc:sldMk cId="0" sldId="260"/>
+            <ac:graphicFrameMk id="29" creationId="{0258630A-265A-7FF7-9963-CB58F53B409B}"/>
+          </ac:graphicFrameMkLst>
+        </pc:graphicFrameChg>
+      </pc:sldChg>
+      <pc:sldChg chg="delSp modSp mod">
+        <pc:chgData name="Yunus Emre Capar" userId="6e34af16be8e7db1" providerId="LiveId" clId="{1A4E8B3D-71E9-45CB-9AC9-58DE4384F4B0}" dt="2026-03-16T14:44:30.449" v="179" actId="478"/>
+        <pc:sldMkLst>
+          <pc:docMk/>
+          <pc:sldMk cId="0" sldId="261"/>
+        </pc:sldMkLst>
+        <pc:spChg chg="mod">
+          <ac:chgData name="Yunus Emre Capar" userId="6e34af16be8e7db1" providerId="LiveId" clId="{1A4E8B3D-71E9-45CB-9AC9-58DE4384F4B0}" dt="2026-03-16T14:43:22.605" v="173" actId="255"/>
+          <ac:spMkLst>
+            <pc:docMk/>
+            <pc:sldMk cId="0" sldId="261"/>
+            <ac:spMk id="5" creationId="{00000000-0000-0000-0000-000000000000}"/>
+          </ac:spMkLst>
+        </pc:spChg>
+        <pc:spChg chg="mod">
+          <ac:chgData name="Yunus Emre Capar" userId="6e34af16be8e7db1" providerId="LiveId" clId="{1A4E8B3D-71E9-45CB-9AC9-58DE4384F4B0}" dt="2026-03-16T14:39:50.258" v="165"/>
+          <ac:spMkLst>
+            <pc:docMk/>
+            <pc:sldMk cId="0" sldId="261"/>
+            <ac:spMk id="33" creationId="{00000000-0000-0000-0000-000000000000}"/>
+          </ac:spMkLst>
+        </pc:spChg>
+        <pc:spChg chg="del mod">
+          <ac:chgData name="Yunus Emre Capar" userId="6e34af16be8e7db1" providerId="LiveId" clId="{1A4E8B3D-71E9-45CB-9AC9-58DE4384F4B0}" dt="2026-03-16T14:44:30.449" v="179" actId="478"/>
+          <ac:spMkLst>
+            <pc:docMk/>
+            <pc:sldMk cId="0" sldId="261"/>
+            <ac:spMk id="34" creationId="{00000000-0000-0000-0000-000000000000}"/>
+          </ac:spMkLst>
+        </pc:spChg>
+        <pc:spChg chg="mod">
+          <ac:chgData name="Yunus Emre Capar" userId="6e34af16be8e7db1" providerId="LiveId" clId="{1A4E8B3D-71E9-45CB-9AC9-58DE4384F4B0}" dt="2026-03-16T14:44:18.859" v="175"/>
+          <ac:spMkLst>
+            <pc:docMk/>
+            <pc:sldMk cId="0" sldId="261"/>
+            <ac:spMk id="35" creationId="{00000000-0000-0000-0000-000000000000}"/>
+          </ac:spMkLst>
+        </pc:spChg>
+        <pc:spChg chg="del mod">
+          <ac:chgData name="Yunus Emre Capar" userId="6e34af16be8e7db1" providerId="LiveId" clId="{1A4E8B3D-71E9-45CB-9AC9-58DE4384F4B0}" dt="2026-03-16T14:44:26.576" v="177" actId="478"/>
+          <ac:spMkLst>
+            <pc:docMk/>
+            <pc:sldMk cId="0" sldId="261"/>
+            <ac:spMk id="36" creationId="{00000000-0000-0000-0000-000000000000}"/>
+          </ac:spMkLst>
+        </pc:spChg>
+        <pc:graphicFrameChg chg="mod modGraphic">
+          <ac:chgData name="Yunus Emre Capar" userId="6e34af16be8e7db1" providerId="LiveId" clId="{1A4E8B3D-71E9-45CB-9AC9-58DE4384F4B0}" dt="2026-03-16T14:38:48.159" v="145" actId="122"/>
+          <ac:graphicFrameMkLst>
+            <pc:docMk/>
+            <pc:sldMk cId="0" sldId="261"/>
+            <ac:graphicFrameMk id="39" creationId="{5F474FA4-EF3E-A05F-CCCF-75A825666D37}"/>
+          </ac:graphicFrameMkLst>
+        </pc:graphicFrameChg>
+      </pc:sldChg>
+      <pc:sldChg chg="modSp mod">
+        <pc:chgData name="Yunus Emre Capar" userId="6e34af16be8e7db1" providerId="LiveId" clId="{1A4E8B3D-71E9-45CB-9AC9-58DE4384F4B0}" dt="2026-03-16T14:49:07.663" v="190"/>
+        <pc:sldMkLst>
+          <pc:docMk/>
+          <pc:sldMk cId="0" sldId="262"/>
+        </pc:sldMkLst>
+        <pc:spChg chg="mod">
+          <ac:chgData name="Yunus Emre Capar" userId="6e34af16be8e7db1" providerId="LiveId" clId="{1A4E8B3D-71E9-45CB-9AC9-58DE4384F4B0}" dt="2026-03-16T14:46:17.680" v="181" actId="20577"/>
+          <ac:spMkLst>
+            <pc:docMk/>
+            <pc:sldMk cId="0" sldId="262"/>
+            <ac:spMk id="5" creationId="{00000000-0000-0000-0000-000000000000}"/>
+          </ac:spMkLst>
+        </pc:spChg>
+        <pc:spChg chg="mod">
+          <ac:chgData name="Yunus Emre Capar" userId="6e34af16be8e7db1" providerId="LiveId" clId="{1A4E8B3D-71E9-45CB-9AC9-58DE4384F4B0}" dt="2026-03-16T14:46:30.943" v="188" actId="20577"/>
+          <ac:spMkLst>
+            <pc:docMk/>
+            <pc:sldMk cId="0" sldId="262"/>
+            <ac:spMk id="7" creationId="{00000000-0000-0000-0000-000000000000}"/>
+          </ac:spMkLst>
+        </pc:spChg>
+        <pc:spChg chg="mod">
+          <ac:chgData name="Yunus Emre Capar" userId="6e34af16be8e7db1" providerId="LiveId" clId="{1A4E8B3D-71E9-45CB-9AC9-58DE4384F4B0}" dt="2026-03-16T14:48:50.683" v="189"/>
+          <ac:spMkLst>
+            <pc:docMk/>
+            <pc:sldMk cId="0" sldId="262"/>
+            <ac:spMk id="8" creationId="{00000000-0000-0000-0000-000000000000}"/>
+          </ac:spMkLst>
+        </pc:spChg>
+        <pc:spChg chg="mod">
+          <ac:chgData name="Yunus Emre Capar" userId="6e34af16be8e7db1" providerId="LiveId" clId="{1A4E8B3D-71E9-45CB-9AC9-58DE4384F4B0}" dt="2026-03-16T14:49:07.663" v="190"/>
+          <ac:spMkLst>
+            <pc:docMk/>
+            <pc:sldMk cId="0" sldId="262"/>
+            <ac:spMk id="11" creationId="{00000000-0000-0000-0000-000000000000}"/>
+          </ac:spMkLst>
+        </pc:spChg>
       </pc:sldChg>
     </pc:docChg>
   </pc:docChgLst>
@@ -3579,23 +3831,12 @@
           <a:bodyPr wrap="square" lIns="0" tIns="0" rIns="0" bIns="0" rtlCol="0" anchor="ctr"/>
           <a:lstStyle/>
           <a:p>
-            <a:pPr marL="0" indent="0">
-              <a:buNone/>
-            </a:pPr>
-            <a:r>
-              <a:rPr lang="en-US" sz="2300" b="1" dirty="0">
-                <a:solidFill>
-                  <a:srgbClr val="24323A"/>
-                </a:solidFill>
-              </a:rPr>
-              <a:t>Samma flöde används i träning, validering, test och senare på </a:t>
-            </a:r>
-            <a:r>
-              <a:rPr lang="en-US" sz="2300" b="1" dirty="0" err="1">
-                <a:solidFill>
-                  <a:srgbClr val="24323A"/>
-                </a:solidFill>
-              </a:rPr>
+            <a:r>
+              <a:rPr lang="sv-SE" sz="2400" b="1" dirty="0"/>
+              <a:t>Samma pipeline används i CV, test och när vi kör </a:t>
+            </a:r>
+            <a:r>
+              <a:rPr lang="sv-SE" sz="2400" b="1" dirty="0" err="1"/>
               <a:t>new_data</a:t>
             </a:r>
             <a:r>
@@ -4093,7 +4334,7 @@
           <a:bodyPr/>
           <a:lstStyle/>
           <a:p>
-            <a:endParaRPr lang="en-SE"/>
+            <a:endParaRPr lang="en-SE" dirty="0"/>
           </a:p>
         </p:txBody>
       </p:sp>
@@ -4241,7 +4482,7 @@
                   <a:srgbClr val="24323A"/>
                 </a:solidFill>
               </a:rPr>
-              <a:t>+ CV/Test</a:t>
+              <a:t>+ (CV/Test)</a:t>
             </a:r>
             <a:endParaRPr lang="en-US" sz="1800" dirty="0"/>
           </a:p>
@@ -4424,6 +4665,17 @@
               <a:buChar char="•"/>
             </a:pPr>
             <a:r>
+              <a:rPr lang="en-US" sz="1600" dirty="0" err="1">
+                <a:solidFill>
+                  <a:srgbClr val="24323A"/>
+                </a:solidFill>
+                <a:latin typeface="Arial" pitchFamily="34" charset="0"/>
+                <a:ea typeface="Arial" pitchFamily="34" charset="-122"/>
+                <a:cs typeface="Arial" pitchFamily="34" charset="-120"/>
+              </a:rPr>
+              <a:t>Gör</a:t>
+            </a:r>
+            <a:r>
               <a:rPr lang="en-US" sz="1600" dirty="0">
                 <a:solidFill>
                   <a:srgbClr val="24323A"/>
@@ -4432,7 +4684,51 @@
                 <a:ea typeface="Arial" pitchFamily="34" charset="-122"/>
                 <a:cs typeface="Arial" pitchFamily="34" charset="-120"/>
               </a:rPr>
-              <a:t>Gör lösningen reproducerbar.</a:t>
+              <a:t> </a:t>
+            </a:r>
+            <a:r>
+              <a:rPr lang="en-US" sz="1600" dirty="0" err="1">
+                <a:solidFill>
+                  <a:srgbClr val="24323A"/>
+                </a:solidFill>
+                <a:latin typeface="Arial" pitchFamily="34" charset="0"/>
+                <a:ea typeface="Arial" pitchFamily="34" charset="-122"/>
+                <a:cs typeface="Arial" pitchFamily="34" charset="-120"/>
+              </a:rPr>
+              <a:t>lösningen</a:t>
+            </a:r>
+            <a:r>
+              <a:rPr lang="en-US" sz="1600" dirty="0">
+                <a:solidFill>
+                  <a:srgbClr val="24323A"/>
+                </a:solidFill>
+                <a:latin typeface="Arial" pitchFamily="34" charset="0"/>
+                <a:ea typeface="Arial" pitchFamily="34" charset="-122"/>
+                <a:cs typeface="Arial" pitchFamily="34" charset="-120"/>
+              </a:rPr>
+              <a:t> </a:t>
+            </a:r>
+            <a:r>
+              <a:rPr lang="en-US" sz="1600" dirty="0" err="1">
+                <a:solidFill>
+                  <a:srgbClr val="24323A"/>
+                </a:solidFill>
+                <a:latin typeface="Arial" pitchFamily="34" charset="0"/>
+                <a:ea typeface="Arial" pitchFamily="34" charset="-122"/>
+                <a:cs typeface="Arial" pitchFamily="34" charset="-120"/>
+              </a:rPr>
+              <a:t>reproducerbar</a:t>
+            </a:r>
+            <a:r>
+              <a:rPr lang="en-US" sz="1600" dirty="0">
+                <a:solidFill>
+                  <a:srgbClr val="24323A"/>
+                </a:solidFill>
+                <a:latin typeface="Arial" pitchFamily="34" charset="0"/>
+                <a:ea typeface="Arial" pitchFamily="34" charset="-122"/>
+                <a:cs typeface="Arial" pitchFamily="34" charset="-120"/>
+              </a:rPr>
+              <a:t>.</a:t>
             </a:r>
             <a:endParaRPr lang="en-US" sz="1600" dirty="0"/>
           </a:p>
@@ -4472,9 +4768,12 @@
                 <a:ea typeface="Arial" pitchFamily="34" charset="-122"/>
                 <a:cs typeface="Arial" pitchFamily="34" charset="-120"/>
               </a:rPr>
-              <a:t>Gör det enkelt att köra exakt samma flöde på new_data.</a:t>
-            </a:r>
-            <a:endParaRPr lang="en-US" sz="1600" dirty="0"/>
+              <a:t>Gör det enkelt att köra exakt samma flöde på </a:t>
+            </a:r>
+            <a:r>
+              <a:rPr lang="en-US" sz="1600" dirty="0"/>
+              <a:t>new_data.csv</a:t>
+            </a:r>
           </a:p>
         </p:txBody>
       </p:sp>
@@ -4946,7 +5245,7 @@
         <p:spPr>
           <a:xfrm>
             <a:off x="4315968" y="5038344"/>
-            <a:ext cx="5120640" cy="164592"/>
+            <a:ext cx="5120640" cy="398360"/>
           </a:xfrm>
           <a:prstGeom prst="rect">
             <a:avLst/>
@@ -4958,8 +5257,20 @@
           <a:bodyPr wrap="square" lIns="0" tIns="0" rIns="0" bIns="0" rtlCol="0" anchor="ctr"/>
           <a:lstStyle/>
           <a:p>
-            <a:pPr marL="0" indent="0">
-              <a:buNone/>
+            <a:pPr marL="171450" indent="-171450">
+              <a:buFont typeface="Arial" panose="020B0604020202020204" pitchFamily="34" charset="0"/>
+              <a:buChar char="•"/>
+            </a:pPr>
+            <a:endParaRPr lang="en-US" sz="1100" dirty="0">
+              <a:solidFill>
+                <a:srgbClr val="5F7078"/>
+              </a:solidFill>
+            </a:endParaRPr>
+          </a:p>
+          <a:p>
+            <a:pPr marL="171450" indent="-171450">
+              <a:buFont typeface="Arial" panose="020B0604020202020204" pitchFamily="34" charset="0"/>
+              <a:buChar char="•"/>
             </a:pPr>
             <a:r>
               <a:rPr lang="en-US" sz="1100" dirty="0">
@@ -4967,7 +5278,7 @@
                   <a:srgbClr val="5F7078"/>
                 </a:solidFill>
               </a:rPr>
-              <a:t>* Precision beror på vald threshold. I drift använder vi Top-X.</a:t>
+              <a:t>Precision beror på vald threshold. I drift använder vi Top-X</a:t>
             </a:r>
             <a:endParaRPr lang="en-US" sz="1100" dirty="0"/>
           </a:p>
@@ -5024,7 +5335,7 @@
           <p:nvPr>
             <p:extLst>
               <p:ext uri="{D42A27DB-BD31-4B8C-83A1-F6EECF244321}">
-                <p14:modId xmlns:p14="http://schemas.microsoft.com/office/powerpoint/2010/main" val="908140104"/>
+                <p14:modId xmlns:p14="http://schemas.microsoft.com/office/powerpoint/2010/main" val="1437058490"/>
               </p:ext>
             </p:extLst>
           </p:nvPr>
@@ -5382,10 +5693,9 @@
                             <a:srgbClr val="24323A"/>
                           </a:solidFill>
                           <a:latin typeface="Arial" pitchFamily="34" charset="0"/>
-                          <a:ea typeface="Arial" pitchFamily="34" charset="-122"/>
                           <a:cs typeface="Arial" pitchFamily="34" charset="-120"/>
                         </a:rPr>
-                        <a:t>–</a:t>
+                        <a:t>0.102</a:t>
                       </a:r>
                       <a:endParaRPr lang="en-US" sz="1800" dirty="0"/>
                     </a:p>
@@ -5941,18 +6251,27 @@
           <a:bodyPr wrap="square" lIns="0" tIns="0" rIns="0" bIns="0" rtlCol="0" anchor="ctr"/>
           <a:lstStyle/>
           <a:p>
-            <a:pPr marL="0" indent="0">
-              <a:buNone/>
-            </a:pPr>
+            <a:r>
+              <a:rPr lang="sv-SE" sz="2400" b="1" dirty="0"/>
+              <a:t>Vi finjusterade den valda modellen (</a:t>
+            </a:r>
+            <a:r>
+              <a:rPr lang="sv-SE" sz="2400" b="1" dirty="0" err="1"/>
+              <a:t>tuning</a:t>
+            </a:r>
+            <a:r>
+              <a:rPr lang="sv-SE" sz="2400" b="1" dirty="0"/>
+              <a:t>) utan att göra driften svår</a:t>
+            </a:r>
             <a:r>
               <a:rPr lang="en-US" sz="2200" b="1" dirty="0">
                 <a:solidFill>
                   <a:srgbClr val="24323A"/>
                 </a:solidFill>
               </a:rPr>
-              <a:t>Nästa steg är att finjustera den valda modellen utan att göra lösningen svår att drifta.</a:t>
-            </a:r>
-            <a:endParaRPr lang="en-US" sz="2200" dirty="0"/>
+              <a:t>.</a:t>
+            </a:r>
+            <a:endParaRPr lang="en-US" sz="2200" b="1" dirty="0"/>
           </a:p>
         </p:txBody>
       </p:sp>
@@ -6022,15 +6341,24 @@
               <a:buChar char="•"/>
             </a:pPr>
             <a:r>
-              <a:rPr lang="en-US" sz="1700" dirty="0">
-                <a:solidFill>
-                  <a:srgbClr val="24323A"/>
-                </a:solidFill>
-                <a:latin typeface="Arial" pitchFamily="34" charset="0"/>
-                <a:ea typeface="Arial" pitchFamily="34" charset="-122"/>
-                <a:cs typeface="Arial" pitchFamily="34" charset="-120"/>
-              </a:rPr>
-              <a:t>Tuning med GridSearchCV på 1–2 parametrar.</a:t>
+              <a:rPr lang="en-US" sz="1600" dirty="0"/>
+              <a:t>Tuning: </a:t>
+            </a:r>
+            <a:r>
+              <a:rPr lang="en-US" sz="1600" dirty="0" err="1"/>
+              <a:t>GridSearchCV</a:t>
+            </a:r>
+            <a:r>
+              <a:rPr lang="en-US" sz="1600" dirty="0"/>
+              <a:t> (</a:t>
+            </a:r>
+            <a:r>
+              <a:rPr lang="en-US" sz="1600" dirty="0" err="1"/>
+              <a:t>mål</a:t>
+            </a:r>
+            <a:r>
+              <a:rPr lang="en-US" sz="1600" dirty="0"/>
+              <a:t>: Average Precision / AP)</a:t>
             </a:r>
             <a:endParaRPr lang="en-US" sz="1700" dirty="0"/>
           </a:p>
@@ -6062,15 +6390,40 @@
               <a:buChar char="•"/>
             </a:pPr>
             <a:r>
-              <a:rPr lang="en-US" sz="1700" dirty="0">
-                <a:solidFill>
-                  <a:srgbClr val="24323A"/>
-                </a:solidFill>
-                <a:latin typeface="Arial" pitchFamily="34" charset="0"/>
-                <a:ea typeface="Arial" pitchFamily="34" charset="-122"/>
-                <a:cs typeface="Arial" pitchFamily="34" charset="-120"/>
-              </a:rPr>
-              <a:t>Planerade parametrar: C och eventuellt class_weight.</a:t>
+              <a:rPr lang="en-US" sz="1600" dirty="0" err="1"/>
+              <a:t>Bästa</a:t>
+            </a:r>
+            <a:r>
+              <a:rPr lang="en-US" sz="1600" dirty="0"/>
+              <a:t> </a:t>
+            </a:r>
+            <a:r>
+              <a:rPr lang="en-US" sz="1600" dirty="0" err="1"/>
+              <a:t>parametrar</a:t>
+            </a:r>
+            <a:r>
+              <a:rPr lang="en-US" sz="1600" dirty="0"/>
+              <a:t>: </a:t>
+            </a:r>
+            <a:r>
+              <a:rPr lang="en-US" dirty="0"/>
+              <a:t>C = 10</a:t>
+            </a:r>
+            <a:r>
+              <a:rPr lang="en-US" sz="1600" dirty="0"/>
+              <a:t>, </a:t>
+            </a:r>
+            <a:r>
+              <a:rPr lang="en-US" i="1" dirty="0" err="1"/>
+              <a:t>class_weight</a:t>
+            </a:r>
+            <a:r>
+              <a:rPr lang="en-US" i="1" dirty="0"/>
+              <a:t> </a:t>
+            </a:r>
+            <a:r>
+              <a:rPr lang="en-US" dirty="0"/>
+              <a:t>= None</a:t>
             </a:r>
             <a:endParaRPr lang="en-US" sz="1700" dirty="0"/>
           </a:p>
@@ -6102,15 +6455,12 @@
               <a:buChar char="•"/>
             </a:pPr>
             <a:r>
-              <a:rPr lang="en-US" sz="1700" dirty="0">
-                <a:solidFill>
-                  <a:srgbClr val="24323A"/>
-                </a:solidFill>
-                <a:latin typeface="Arial" pitchFamily="34" charset="0"/>
-                <a:ea typeface="Arial" pitchFamily="34" charset="-122"/>
-                <a:cs typeface="Arial" pitchFamily="34" charset="-120"/>
-              </a:rPr>
-              <a:t>Målet är bättre ranking och mer stabil kvalitet.</a:t>
+              <a:rPr lang="en-US" sz="1600" dirty="0" err="1"/>
+              <a:t>Resultat</a:t>
+            </a:r>
+            <a:r>
+              <a:rPr lang="en-US" sz="1600" dirty="0"/>
+              <a:t>: Best CV AP 0.284 → Test AP 0.276, Test ROC-AUC 0.740</a:t>
             </a:r>
             <a:endParaRPr lang="en-US" sz="1700" dirty="0"/>
           </a:p>
@@ -6124,8 +6474,8 @@
         </p:nvSpPr>
         <p:spPr>
           <a:xfrm>
-            <a:off x="4251960" y="5440680"/>
-            <a:ext cx="5943600" cy="201168"/>
+            <a:off x="4292301" y="6096069"/>
+            <a:ext cx="5897880" cy="496755"/>
           </a:xfrm>
           <a:prstGeom prst="rect">
             <a:avLst/>
@@ -6137,18 +6487,43 @@
           <a:bodyPr wrap="square" lIns="0" tIns="0" rIns="0" bIns="0" rtlCol="0" anchor="ctr"/>
           <a:lstStyle/>
           <a:p>
-            <a:pPr marL="0" indent="0">
-              <a:buNone/>
-            </a:pPr>
-            <a:r>
-              <a:rPr lang="en-US" sz="1250" i="1" dirty="0">
-                <a:solidFill>
-                  <a:srgbClr val="8A6A00"/>
-                </a:solidFill>
-              </a:rPr>
-              <a:t>Uppdatera denna slide med slutliga tuning-resultat innan redovisningen.</a:t>
-            </a:r>
-            <a:endParaRPr lang="en-US" sz="1250" dirty="0"/>
+            <a:r>
+              <a:rPr lang="sv-SE" sz="1100" dirty="0">
+                <a:solidFill>
+                  <a:schemeClr val="bg2">
+                    <a:lumMod val="25000"/>
+                  </a:schemeClr>
+                </a:solidFill>
+              </a:rPr>
+              <a:t>Vi </a:t>
+            </a:r>
+            <a:r>
+              <a:rPr lang="sv-SE" sz="1100" dirty="0" err="1">
+                <a:solidFill>
+                  <a:schemeClr val="bg2">
+                    <a:lumMod val="25000"/>
+                  </a:schemeClr>
+                </a:solidFill>
+              </a:rPr>
+              <a:t>tunade</a:t>
+            </a:r>
+            <a:r>
+              <a:rPr lang="sv-SE" sz="1100" dirty="0">
+                <a:solidFill>
+                  <a:schemeClr val="bg2">
+                    <a:lumMod val="25000"/>
+                  </a:schemeClr>
+                </a:solidFill>
+              </a:rPr>
+              <a:t> få parametrar för att hålla lösningen enkel att underhålla.</a:t>
+            </a:r>
+            <a:endParaRPr lang="en-US" sz="1100" dirty="0">
+              <a:solidFill>
+                <a:schemeClr val="bg2">
+                  <a:lumMod val="25000"/>
+                </a:schemeClr>
+              </a:solidFill>
+            </a:endParaRPr>
           </a:p>
         </p:txBody>
       </p:sp>
@@ -6203,14 +6578,14 @@
           <p:nvPr>
             <p:extLst>
               <p:ext uri="{D42A27DB-BD31-4B8C-83A1-F6EECF244321}">
-                <p14:modId xmlns:p14="http://schemas.microsoft.com/office/powerpoint/2010/main" val="1622214019"/>
+                <p14:modId xmlns:p14="http://schemas.microsoft.com/office/powerpoint/2010/main" val="696348534"/>
               </p:ext>
             </p:extLst>
           </p:nvPr>
         </p:nvGraphicFramePr>
         <p:xfrm>
-          <a:off x="4251961" y="3474721"/>
-          <a:ext cx="7660089" cy="1887440"/>
+          <a:off x="4297680" y="3528447"/>
+          <a:ext cx="6661207" cy="2539595"/>
         </p:xfrm>
         <a:graphic>
           <a:graphicData uri="http://schemas.openxmlformats.org/drawingml/2006/table">
@@ -6219,7 +6594,7 @@
                 <a:tableStyleId>{073A0DAA-6AF3-43AB-8588-CEC1D06C72B9}</a:tableStyleId>
               </a:tblPr>
               <a:tblGrid>
-                <a:gridCol w="2553363">
+                <a:gridCol w="1554481">
                   <a:extLst>
                     <a:ext uri="{9D8B030D-6E8A-4147-A177-3AD203B41FA5}">
                       <a16:colId xmlns:a16="http://schemas.microsoft.com/office/drawing/2014/main" val="1635972392"/>
@@ -6241,7 +6616,7 @@
                   </a:extLst>
                 </a:gridCol>
               </a:tblGrid>
-              <a:tr h="423948">
+              <a:tr h="422115">
                 <a:tc>
                   <a:txBody>
                     <a:bodyPr/>
@@ -6265,7 +6640,7 @@
                         <a:defRPr/>
                       </a:pPr>
                       <a:r>
-                        <a:rPr lang="en-US" sz="1800" b="1" dirty="0">
+                        <a:rPr lang="en-US" sz="1800" b="1">
                           <a:solidFill>
                             <a:srgbClr val="FFFFFF"/>
                           </a:solidFill>
@@ -6303,7 +6678,7 @@
                         <a:defRPr/>
                       </a:pPr>
                       <a:r>
-                        <a:rPr lang="en-US" sz="1800" b="1" dirty="0" err="1">
+                        <a:rPr lang="en-US" sz="1800" b="1">
                           <a:solidFill>
                             <a:srgbClr val="FFFFFF"/>
                           </a:solidFill>
@@ -6311,40 +6686,7 @@
                           <a:ea typeface="Arial" pitchFamily="34" charset="-122"/>
                           <a:cs typeface="Arial" pitchFamily="34" charset="-120"/>
                         </a:rPr>
-                        <a:t>Varför</a:t>
-                      </a:r>
-                      <a:r>
-                        <a:rPr lang="en-US" sz="1800" b="1" dirty="0">
-                          <a:solidFill>
-                            <a:srgbClr val="FFFFFF"/>
-                          </a:solidFill>
-                          <a:latin typeface="Arial" pitchFamily="34" charset="0"/>
-                          <a:ea typeface="Arial" pitchFamily="34" charset="-122"/>
-                          <a:cs typeface="Arial" pitchFamily="34" charset="-120"/>
-                        </a:rPr>
-                        <a:t> </a:t>
-                      </a:r>
-                      <a:r>
-                        <a:rPr lang="en-US" sz="1800" b="1" dirty="0" err="1">
-                          <a:solidFill>
-                            <a:srgbClr val="FFFFFF"/>
-                          </a:solidFill>
-                          <a:latin typeface="Arial" pitchFamily="34" charset="0"/>
-                          <a:ea typeface="Arial" pitchFamily="34" charset="-122"/>
-                          <a:cs typeface="Arial" pitchFamily="34" charset="-120"/>
-                        </a:rPr>
-                        <a:t>testas</a:t>
-                      </a:r>
-                      <a:r>
-                        <a:rPr lang="en-US" sz="1800" b="1" dirty="0">
-                          <a:solidFill>
-                            <a:srgbClr val="FFFFFF"/>
-                          </a:solidFill>
-                          <a:latin typeface="Arial" pitchFamily="34" charset="0"/>
-                          <a:ea typeface="Arial" pitchFamily="34" charset="-122"/>
-                          <a:cs typeface="Arial" pitchFamily="34" charset="-120"/>
-                        </a:rPr>
-                        <a:t> den?</a:t>
+                        <a:t>Varför testas den?</a:t>
                       </a:r>
                       <a:endParaRPr lang="en-US" sz="1800" dirty="0"/>
                     </a:p>
@@ -6374,15 +6716,8 @@
                         <a:defRPr/>
                       </a:pPr>
                       <a:r>
-                        <a:rPr lang="en-US" sz="1800" b="1" dirty="0">
-                          <a:solidFill>
-                            <a:srgbClr val="FFFFFF"/>
-                          </a:solidFill>
-                          <a:latin typeface="Arial" pitchFamily="34" charset="0"/>
-                          <a:ea typeface="Arial" pitchFamily="34" charset="-122"/>
-                          <a:cs typeface="Arial" pitchFamily="34" charset="-120"/>
-                        </a:rPr>
-                        <a:t>Status</a:t>
+                        <a:rPr lang="en-US" dirty="0"/>
+                        <a:t>Vald</a:t>
                       </a:r>
                       <a:endParaRPr lang="en-US" sz="1800" dirty="0"/>
                     </a:p>
@@ -6395,7 +6730,7 @@
                   </a:ext>
                 </a:extLst>
               </a:tr>
-              <a:tr h="731746">
+              <a:tr h="738700">
                 <a:tc>
                   <a:txBody>
                     <a:bodyPr/>
@@ -6419,7 +6754,7 @@
                         <a:defRPr/>
                       </a:pPr>
                       <a:r>
-                        <a:rPr lang="en-US" sz="1800" dirty="0">
+                        <a:rPr lang="en-US" sz="1800">
                           <a:solidFill>
                             <a:srgbClr val="24323A"/>
                           </a:solidFill>
@@ -6457,7 +6792,7 @@
                         <a:defRPr/>
                       </a:pPr>
                       <a:r>
-                        <a:rPr lang="en-US" sz="1800" dirty="0">
+                        <a:rPr lang="en-US" sz="1800">
                           <a:solidFill>
                             <a:srgbClr val="24323A"/>
                           </a:solidFill>
@@ -6465,95 +6800,7 @@
                           <a:ea typeface="Arial" pitchFamily="34" charset="-122"/>
                           <a:cs typeface="Arial" pitchFamily="34" charset="-120"/>
                         </a:rPr>
-                        <a:t>Styr </a:t>
-                      </a:r>
-                      <a:r>
-                        <a:rPr lang="en-US" sz="1800" dirty="0" err="1">
-                          <a:solidFill>
-                            <a:srgbClr val="24323A"/>
-                          </a:solidFill>
-                          <a:latin typeface="Arial" pitchFamily="34" charset="0"/>
-                          <a:ea typeface="Arial" pitchFamily="34" charset="-122"/>
-                          <a:cs typeface="Arial" pitchFamily="34" charset="-120"/>
-                        </a:rPr>
-                        <a:t>regularisering</a:t>
-                      </a:r>
-                      <a:r>
-                        <a:rPr lang="en-US" sz="1800" dirty="0">
-                          <a:solidFill>
-                            <a:srgbClr val="24323A"/>
-                          </a:solidFill>
-                          <a:latin typeface="Arial" pitchFamily="34" charset="0"/>
-                          <a:ea typeface="Arial" pitchFamily="34" charset="-122"/>
-                          <a:cs typeface="Arial" pitchFamily="34" charset="-120"/>
-                        </a:rPr>
-                        <a:t> / </a:t>
-                      </a:r>
-                      <a:r>
-                        <a:rPr lang="en-US" sz="1800" dirty="0" err="1">
-                          <a:solidFill>
-                            <a:srgbClr val="24323A"/>
-                          </a:solidFill>
-                          <a:latin typeface="Arial" pitchFamily="34" charset="0"/>
-                          <a:ea typeface="Arial" pitchFamily="34" charset="-122"/>
-                          <a:cs typeface="Arial" pitchFamily="34" charset="-120"/>
-                        </a:rPr>
-                        <a:t>hur</a:t>
-                      </a:r>
-                      <a:r>
-                        <a:rPr lang="en-US" sz="1800" dirty="0">
-                          <a:solidFill>
-                            <a:srgbClr val="24323A"/>
-                          </a:solidFill>
-                          <a:latin typeface="Arial" pitchFamily="34" charset="0"/>
-                          <a:ea typeface="Arial" pitchFamily="34" charset="-122"/>
-                          <a:cs typeface="Arial" pitchFamily="34" charset="-120"/>
-                        </a:rPr>
-                        <a:t> </a:t>
-                      </a:r>
-                      <a:r>
-                        <a:rPr lang="en-US" sz="1800" dirty="0" err="1">
-                          <a:solidFill>
-                            <a:srgbClr val="24323A"/>
-                          </a:solidFill>
-                          <a:latin typeface="Arial" pitchFamily="34" charset="0"/>
-                          <a:ea typeface="Arial" pitchFamily="34" charset="-122"/>
-                          <a:cs typeface="Arial" pitchFamily="34" charset="-120"/>
-                        </a:rPr>
-                        <a:t>flexibel</a:t>
-                      </a:r>
-                      <a:r>
-                        <a:rPr lang="en-US" sz="1800" dirty="0">
-                          <a:solidFill>
-                            <a:srgbClr val="24323A"/>
-                          </a:solidFill>
-                          <a:latin typeface="Arial" pitchFamily="34" charset="0"/>
-                          <a:ea typeface="Arial" pitchFamily="34" charset="-122"/>
-                          <a:cs typeface="Arial" pitchFamily="34" charset="-120"/>
-                        </a:rPr>
-                        <a:t> </a:t>
-                      </a:r>
-                      <a:r>
-                        <a:rPr lang="en-US" sz="1800" dirty="0" err="1">
-                          <a:solidFill>
-                            <a:srgbClr val="24323A"/>
-                          </a:solidFill>
-                          <a:latin typeface="Arial" pitchFamily="34" charset="0"/>
-                          <a:ea typeface="Arial" pitchFamily="34" charset="-122"/>
-                          <a:cs typeface="Arial" pitchFamily="34" charset="-120"/>
-                        </a:rPr>
-                        <a:t>modellen</a:t>
-                      </a:r>
-                      <a:r>
-                        <a:rPr lang="en-US" sz="1800" dirty="0">
-                          <a:solidFill>
-                            <a:srgbClr val="24323A"/>
-                          </a:solidFill>
-                          <a:latin typeface="Arial" pitchFamily="34" charset="0"/>
-                          <a:ea typeface="Arial" pitchFamily="34" charset="-122"/>
-                          <a:cs typeface="Arial" pitchFamily="34" charset="-120"/>
-                        </a:rPr>
-                        <a:t> är</a:t>
+                        <a:t>Styr regularisering / hur flexibel modellen är</a:t>
                       </a:r>
                       <a:endParaRPr lang="en-US" sz="1800" dirty="0"/>
                     </a:p>
@@ -6583,83 +6830,9 @@
                         <a:defRPr/>
                       </a:pPr>
                       <a:r>
-                        <a:rPr lang="en-US" sz="1800" dirty="0" err="1">
-                          <a:solidFill>
-                            <a:srgbClr val="24323A"/>
-                          </a:solidFill>
-                          <a:latin typeface="Arial" pitchFamily="34" charset="0"/>
-                          <a:ea typeface="Arial" pitchFamily="34" charset="-122"/>
-                          <a:cs typeface="Arial" pitchFamily="34" charset="-120"/>
-                        </a:rPr>
-                        <a:t>Fylls</a:t>
+                        <a:rPr lang="en-US" sz="1800" dirty="0"/>
+                        <a:t>10</a:t>
                       </a:r>
-                      <a:r>
-                        <a:rPr lang="en-US" sz="1800" dirty="0">
-                          <a:solidFill>
-                            <a:srgbClr val="24323A"/>
-                          </a:solidFill>
-                          <a:latin typeface="Arial" pitchFamily="34" charset="0"/>
-                          <a:ea typeface="Arial" pitchFamily="34" charset="-122"/>
-                          <a:cs typeface="Arial" pitchFamily="34" charset="-120"/>
-                        </a:rPr>
-                        <a:t> </a:t>
-                      </a:r>
-                      <a:r>
-                        <a:rPr lang="en-US" sz="1800" dirty="0" err="1">
-                          <a:solidFill>
-                            <a:srgbClr val="24323A"/>
-                          </a:solidFill>
-                          <a:latin typeface="Arial" pitchFamily="34" charset="0"/>
-                          <a:ea typeface="Arial" pitchFamily="34" charset="-122"/>
-                          <a:cs typeface="Arial" pitchFamily="34" charset="-120"/>
-                        </a:rPr>
-                        <a:t>i</a:t>
-                      </a:r>
-                      <a:r>
-                        <a:rPr lang="en-US" sz="1800" dirty="0">
-                          <a:solidFill>
-                            <a:srgbClr val="24323A"/>
-                          </a:solidFill>
-                          <a:latin typeface="Arial" pitchFamily="34" charset="0"/>
-                          <a:ea typeface="Arial" pitchFamily="34" charset="-122"/>
-                          <a:cs typeface="Arial" pitchFamily="34" charset="-120"/>
-                        </a:rPr>
-                        <a:t> </a:t>
-                      </a:r>
-                      <a:r>
-                        <a:rPr lang="en-US" sz="1800" dirty="0" err="1">
-                          <a:solidFill>
-                            <a:srgbClr val="24323A"/>
-                          </a:solidFill>
-                          <a:latin typeface="Arial" pitchFamily="34" charset="0"/>
-                          <a:ea typeface="Arial" pitchFamily="34" charset="-122"/>
-                          <a:cs typeface="Arial" pitchFamily="34" charset="-120"/>
-                        </a:rPr>
-                        <a:t>när</a:t>
-                      </a:r>
-                      <a:r>
-                        <a:rPr lang="en-US" sz="1800" dirty="0">
-                          <a:solidFill>
-                            <a:srgbClr val="24323A"/>
-                          </a:solidFill>
-                          <a:latin typeface="Arial" pitchFamily="34" charset="0"/>
-                          <a:ea typeface="Arial" pitchFamily="34" charset="-122"/>
-                          <a:cs typeface="Arial" pitchFamily="34" charset="-120"/>
-                        </a:rPr>
-                        <a:t> notebook 3 är </a:t>
-                      </a:r>
-                      <a:r>
-                        <a:rPr lang="en-US" sz="1800" dirty="0" err="1">
-                          <a:solidFill>
-                            <a:srgbClr val="24323A"/>
-                          </a:solidFill>
-                          <a:latin typeface="Arial" pitchFamily="34" charset="0"/>
-                          <a:ea typeface="Arial" pitchFamily="34" charset="-122"/>
-                          <a:cs typeface="Arial" pitchFamily="34" charset="-120"/>
-                        </a:rPr>
-                        <a:t>klar</a:t>
-                      </a:r>
-                      <a:endParaRPr lang="en-US" sz="1800" dirty="0"/>
                     </a:p>
                   </a:txBody>
                   <a:tcPr/>
@@ -6670,7 +6843,7 @@
                   </a:ext>
                 </a:extLst>
               </a:tr>
-              <a:tr h="731746">
+              <a:tr h="738700">
                 <a:tc>
                   <a:txBody>
                     <a:bodyPr/>
@@ -6694,7 +6867,7 @@
                         <a:defRPr/>
                       </a:pPr>
                       <a:r>
-                        <a:rPr lang="en-US" sz="1800" dirty="0" err="1">
+                        <a:rPr lang="en-US" sz="1800">
                           <a:solidFill>
                             <a:srgbClr val="24323A"/>
                           </a:solidFill>
@@ -6732,7 +6905,7 @@
                         <a:defRPr/>
                       </a:pPr>
                       <a:r>
-                        <a:rPr lang="en-US" sz="1800" dirty="0">
+                        <a:rPr lang="en-US" sz="1800">
                           <a:solidFill>
                             <a:srgbClr val="24323A"/>
                           </a:solidFill>
@@ -6740,51 +6913,7 @@
                           <a:ea typeface="Arial" pitchFamily="34" charset="-122"/>
                           <a:cs typeface="Arial" pitchFamily="34" charset="-120"/>
                         </a:rPr>
-                        <a:t>Kan </a:t>
-                      </a:r>
-                      <a:r>
-                        <a:rPr lang="en-US" sz="1800" dirty="0" err="1">
-                          <a:solidFill>
-                            <a:srgbClr val="24323A"/>
-                          </a:solidFill>
-                          <a:latin typeface="Arial" pitchFamily="34" charset="0"/>
-                          <a:ea typeface="Arial" pitchFamily="34" charset="-122"/>
-                          <a:cs typeface="Arial" pitchFamily="34" charset="-120"/>
-                        </a:rPr>
-                        <a:t>hjälpa</a:t>
-                      </a:r>
-                      <a:r>
-                        <a:rPr lang="en-US" sz="1800" dirty="0">
-                          <a:solidFill>
-                            <a:srgbClr val="24323A"/>
-                          </a:solidFill>
-                          <a:latin typeface="Arial" pitchFamily="34" charset="0"/>
-                          <a:ea typeface="Arial" pitchFamily="34" charset="-122"/>
-                          <a:cs typeface="Arial" pitchFamily="34" charset="-120"/>
-                        </a:rPr>
-                        <a:t> vid </a:t>
-                      </a:r>
-                      <a:r>
-                        <a:rPr lang="en-US" sz="1800" dirty="0" err="1">
-                          <a:solidFill>
-                            <a:srgbClr val="24323A"/>
-                          </a:solidFill>
-                          <a:latin typeface="Arial" pitchFamily="34" charset="0"/>
-                          <a:ea typeface="Arial" pitchFamily="34" charset="-122"/>
-                          <a:cs typeface="Arial" pitchFamily="34" charset="-120"/>
-                        </a:rPr>
-                        <a:t>obalanserad</a:t>
-                      </a:r>
-                      <a:r>
-                        <a:rPr lang="en-US" sz="1800" dirty="0">
-                          <a:solidFill>
-                            <a:srgbClr val="24323A"/>
-                          </a:solidFill>
-                          <a:latin typeface="Arial" pitchFamily="34" charset="0"/>
-                          <a:ea typeface="Arial" pitchFamily="34" charset="-122"/>
-                          <a:cs typeface="Arial" pitchFamily="34" charset="-120"/>
-                        </a:rPr>
-                        <a:t> target</a:t>
+                        <a:t>Kan hjälpa vid obalanserad target</a:t>
                       </a:r>
                       <a:endParaRPr lang="en-US" sz="1800" dirty="0"/>
                     </a:p>
@@ -6814,81 +6943,8 @@
                         <a:defRPr/>
                       </a:pPr>
                       <a:r>
-                        <a:rPr lang="en-US" sz="1800" dirty="0" err="1">
-                          <a:solidFill>
-                            <a:srgbClr val="24323A"/>
-                          </a:solidFill>
-                          <a:latin typeface="Arial" pitchFamily="34" charset="0"/>
-                          <a:ea typeface="Arial" pitchFamily="34" charset="-122"/>
-                          <a:cs typeface="Arial" pitchFamily="34" charset="-120"/>
-                        </a:rPr>
-                        <a:t>Fylls</a:t>
-                      </a:r>
-                      <a:r>
-                        <a:rPr lang="en-US" sz="1800" dirty="0">
-                          <a:solidFill>
-                            <a:srgbClr val="24323A"/>
-                          </a:solidFill>
-                          <a:latin typeface="Arial" pitchFamily="34" charset="0"/>
-                          <a:ea typeface="Arial" pitchFamily="34" charset="-122"/>
-                          <a:cs typeface="Arial" pitchFamily="34" charset="-120"/>
-                        </a:rPr>
-                        <a:t> </a:t>
-                      </a:r>
-                      <a:r>
-                        <a:rPr lang="en-US" sz="1800" dirty="0" err="1">
-                          <a:solidFill>
-                            <a:srgbClr val="24323A"/>
-                          </a:solidFill>
-                          <a:latin typeface="Arial" pitchFamily="34" charset="0"/>
-                          <a:ea typeface="Arial" pitchFamily="34" charset="-122"/>
-                          <a:cs typeface="Arial" pitchFamily="34" charset="-120"/>
-                        </a:rPr>
-                        <a:t>i</a:t>
-                      </a:r>
-                      <a:r>
-                        <a:rPr lang="en-US" sz="1800" dirty="0">
-                          <a:solidFill>
-                            <a:srgbClr val="24323A"/>
-                          </a:solidFill>
-                          <a:latin typeface="Arial" pitchFamily="34" charset="0"/>
-                          <a:ea typeface="Arial" pitchFamily="34" charset="-122"/>
-                          <a:cs typeface="Arial" pitchFamily="34" charset="-120"/>
-                        </a:rPr>
-                        <a:t> </a:t>
-                      </a:r>
-                      <a:r>
-                        <a:rPr lang="en-US" sz="1800" dirty="0" err="1">
-                          <a:solidFill>
-                            <a:srgbClr val="24323A"/>
-                          </a:solidFill>
-                          <a:latin typeface="Arial" pitchFamily="34" charset="0"/>
-                          <a:ea typeface="Arial" pitchFamily="34" charset="-122"/>
-                          <a:cs typeface="Arial" pitchFamily="34" charset="-120"/>
-                        </a:rPr>
-                        <a:t>när</a:t>
-                      </a:r>
-                      <a:r>
-                        <a:rPr lang="en-US" sz="1800" dirty="0">
-                          <a:solidFill>
-                            <a:srgbClr val="24323A"/>
-                          </a:solidFill>
-                          <a:latin typeface="Arial" pitchFamily="34" charset="0"/>
-                          <a:ea typeface="Arial" pitchFamily="34" charset="-122"/>
-                          <a:cs typeface="Arial" pitchFamily="34" charset="-120"/>
-                        </a:rPr>
-                        <a:t> notebook 3 är </a:t>
-                      </a:r>
-                      <a:r>
-                        <a:rPr lang="en-US" sz="1800" dirty="0" err="1">
-                          <a:solidFill>
-                            <a:srgbClr val="24323A"/>
-                          </a:solidFill>
-                          <a:latin typeface="Arial" pitchFamily="34" charset="0"/>
-                          <a:ea typeface="Arial" pitchFamily="34" charset="-122"/>
-                          <a:cs typeface="Arial" pitchFamily="34" charset="-120"/>
-                        </a:rPr>
-                        <a:t>klar</a:t>
+                        <a:rPr lang="en-US" dirty="0"/>
+                        <a:t>None</a:t>
                       </a:r>
                       <a:endParaRPr lang="en-US" sz="1800" dirty="0"/>
                     </a:p>
@@ -6901,10 +6957,173 @@
                   </a:ext>
                 </a:extLst>
               </a:tr>
+              <a:tr h="602296">
+                <a:tc>
+                  <a:txBody>
+                    <a:bodyPr/>
+                    <a:lstStyle/>
+                    <a:p>
+                      <a:pPr marL="0" marR="0" lvl="0" indent="0" algn="l" defTabSz="914400" rtl="0" eaLnBrk="1" fontAlgn="auto" latinLnBrk="0" hangingPunct="1">
+                        <a:lnSpc>
+                          <a:spcPct val="100000"/>
+                        </a:lnSpc>
+                        <a:spcBef>
+                          <a:spcPts val="0"/>
+                        </a:spcBef>
+                        <a:spcAft>
+                          <a:spcPts val="0"/>
+                        </a:spcAft>
+                        <a:buClrTx/>
+                        <a:buSzTx/>
+                        <a:buFontTx/>
+                        <a:buNone/>
+                        <a:tabLst/>
+                        <a:defRPr/>
+                      </a:pPr>
+                      <a:r>
+                        <a:rPr lang="en-US"/>
+                        <a:t>Metric</a:t>
+                      </a:r>
+                      <a:endParaRPr lang="en-US" sz="1800" dirty="0"/>
+                    </a:p>
+                  </a:txBody>
+                  <a:tcPr/>
+                </a:tc>
+                <a:tc>
+                  <a:txBody>
+                    <a:bodyPr/>
+                    <a:lstStyle/>
+                    <a:p>
+                      <a:pPr marL="0" marR="0" lvl="0" indent="0" algn="l" defTabSz="914400" rtl="0" eaLnBrk="1" fontAlgn="auto" latinLnBrk="0" hangingPunct="1">
+                        <a:lnSpc>
+                          <a:spcPct val="100000"/>
+                        </a:lnSpc>
+                        <a:spcBef>
+                          <a:spcPts val="0"/>
+                        </a:spcBef>
+                        <a:spcAft>
+                          <a:spcPts val="0"/>
+                        </a:spcAft>
+                        <a:buClrTx/>
+                        <a:buSzTx/>
+                        <a:buFontTx/>
+                        <a:buNone/>
+                        <a:tabLst/>
+                        <a:defRPr/>
+                      </a:pPr>
+                      <a:r>
+                        <a:rPr lang="sv-SE"/>
+                        <a:t>Vad vi optimerar i GridSearchCV</a:t>
+                      </a:r>
+                      <a:endParaRPr lang="en-US" sz="1800" dirty="0"/>
+                    </a:p>
+                  </a:txBody>
+                  <a:tcPr/>
+                </a:tc>
+                <a:tc>
+                  <a:txBody>
+                    <a:bodyPr/>
+                    <a:lstStyle/>
+                    <a:p>
+                      <a:pPr marL="0" marR="0" lvl="0" indent="0" algn="l" defTabSz="914400" rtl="0" eaLnBrk="1" fontAlgn="auto" latinLnBrk="0" hangingPunct="1">
+                        <a:lnSpc>
+                          <a:spcPct val="100000"/>
+                        </a:lnSpc>
+                        <a:spcBef>
+                          <a:spcPts val="0"/>
+                        </a:spcBef>
+                        <a:spcAft>
+                          <a:spcPts val="0"/>
+                        </a:spcAft>
+                        <a:buClrTx/>
+                        <a:buSzTx/>
+                        <a:buFontTx/>
+                        <a:buNone/>
+                        <a:tabLst/>
+                        <a:defRPr/>
+                      </a:pPr>
+                      <a:r>
+                        <a:rPr lang="en-US" dirty="0"/>
+                        <a:t>Average Precision (AP)</a:t>
+                      </a:r>
+                      <a:endParaRPr lang="en-US" sz="1800" dirty="0"/>
+                    </a:p>
+                  </a:txBody>
+                  <a:tcPr/>
+                </a:tc>
+                <a:extLst>
+                  <a:ext uri="{0D108BD9-81ED-4DB2-BD59-A6C34878D82A}">
+                    <a16:rowId xmlns:a16="http://schemas.microsoft.com/office/drawing/2014/main" val="2229036348"/>
+                  </a:ext>
+                </a:extLst>
+              </a:tr>
             </a:tbl>
           </a:graphicData>
         </a:graphic>
       </p:graphicFrame>
+      <p:sp>
+        <p:nvSpPr>
+          <p:cNvPr id="10" name="Text 25">
+            <a:extLst>
+              <a:ext uri="{FF2B5EF4-FFF2-40B4-BE49-F238E27FC236}">
+                <a16:creationId xmlns:a16="http://schemas.microsoft.com/office/drawing/2014/main" id="{79CD0458-E099-CD06-A7F2-682930136BD9}"/>
+              </a:ext>
+            </a:extLst>
+          </p:cNvPr>
+          <p:cNvSpPr/>
+          <p:nvPr/>
+        </p:nvSpPr>
+        <p:spPr>
+          <a:xfrm>
+            <a:off x="430306" y="3528447"/>
+            <a:ext cx="3246120" cy="985417"/>
+          </a:xfrm>
+          <a:prstGeom prst="rect">
+            <a:avLst/>
+          </a:prstGeom>
+          <a:noFill/>
+          <a:ln/>
+        </p:spPr>
+        <p:txBody>
+          <a:bodyPr wrap="square" lIns="0" tIns="0" rIns="0" bIns="0" rtlCol="0" anchor="ctr"/>
+          <a:lstStyle/>
+          <a:p>
+            <a:pPr marL="171450" indent="-171450">
+              <a:buFont typeface="Arial" panose="020B0604020202020204" pitchFamily="34" charset="0"/>
+              <a:buChar char="•"/>
+            </a:pPr>
+            <a:r>
+              <a:rPr lang="en-US" sz="1400" b="1" dirty="0"/>
+              <a:t>Best CV AP:</a:t>
+            </a:r>
+            <a:r>
+              <a:rPr lang="en-US" sz="1400" dirty="0"/>
+              <a:t> 0.284</a:t>
+            </a:r>
+          </a:p>
+          <a:p>
+            <a:pPr marL="171450" indent="-171450">
+              <a:buFont typeface="Arial" panose="020B0604020202020204" pitchFamily="34" charset="0"/>
+              <a:buChar char="•"/>
+            </a:pPr>
+            <a:r>
+              <a:rPr lang="en-US" sz="1400" b="1" dirty="0"/>
+              <a:t>Test AP / ROC-AUC:</a:t>
+            </a:r>
+            <a:r>
+              <a:rPr lang="en-US" sz="1400" dirty="0"/>
+              <a:t> 0.276 / 0.740</a:t>
+            </a:r>
+            <a:endParaRPr lang="en-US" sz="1400" dirty="0">
+              <a:solidFill>
+                <a:schemeClr val="bg2">
+                  <a:lumMod val="25000"/>
+                </a:schemeClr>
+              </a:solidFill>
+            </a:endParaRPr>
+          </a:p>
+        </p:txBody>
+      </p:sp>
     </p:spTree>
   </p:cSld>
   <p:clrMapOvr>
@@ -7097,33 +7316,30 @@
               <a:buChar char="•"/>
             </a:pPr>
             <a:r>
-              <a:rPr lang="en-US" sz="1550" dirty="0">
-                <a:solidFill>
-                  <a:srgbClr val="24323A"/>
-                </a:solidFill>
-                <a:latin typeface="Arial" pitchFamily="34" charset="0"/>
+              <a:rPr lang="en-US" sz="1400" dirty="0">
+                <a:solidFill>
+                  <a:srgbClr val="24323A"/>
+                </a:solidFill>
                 <a:ea typeface="Arial" pitchFamily="34" charset="-122"/>
                 <a:cs typeface="Arial" pitchFamily="34" charset="-120"/>
               </a:rPr>
               <a:t>Ali vill ha en hanterbar mängd som är värd att </a:t>
             </a:r>
             <a:r>
-              <a:rPr lang="en-US" sz="1550" dirty="0" err="1">
-                <a:solidFill>
-                  <a:srgbClr val="24323A"/>
-                </a:solidFill>
-                <a:latin typeface="Arial" pitchFamily="34" charset="0"/>
+              <a:rPr lang="en-US" sz="1400" dirty="0" err="1">
+                <a:solidFill>
+                  <a:srgbClr val="24323A"/>
+                </a:solidFill>
                 <a:ea typeface="Arial" pitchFamily="34" charset="-122"/>
                 <a:cs typeface="Arial" pitchFamily="34" charset="-120"/>
               </a:rPr>
               <a:t>granska</a:t>
             </a:r>
             <a:r>
-              <a:rPr lang="en-US" sz="1550" dirty="0">
-                <a:solidFill>
-                  <a:srgbClr val="24323A"/>
-                </a:solidFill>
-                <a:latin typeface="Arial" pitchFamily="34" charset="0"/>
+              <a:rPr lang="en-US" sz="1400" dirty="0">
+                <a:solidFill>
+                  <a:srgbClr val="24323A"/>
+                </a:solidFill>
                 <a:ea typeface="Arial" pitchFamily="34" charset="-122"/>
                 <a:cs typeface="Arial" pitchFamily="34" charset="-120"/>
               </a:rPr>
@@ -7135,11 +7351,10 @@
               <a:buSzPct val="100000"/>
               <a:buChar char="•"/>
             </a:pPr>
-            <a:endParaRPr lang="en-US" sz="1550" dirty="0">
+            <a:endParaRPr lang="en-US" sz="1400" dirty="0">
               <a:solidFill>
                 <a:srgbClr val="24323A"/>
               </a:solidFill>
-              <a:latin typeface="Arial" pitchFamily="34" charset="0"/>
               <a:ea typeface="Arial" pitchFamily="34" charset="-122"/>
               <a:cs typeface="Arial" pitchFamily="34" charset="-120"/>
             </a:endParaRPr>
@@ -7151,143 +7366,130 @@
               <a:buChar char="•"/>
             </a:pPr>
             <a:r>
-              <a:rPr lang="en-US" sz="1550" dirty="0">
-                <a:solidFill>
-                  <a:srgbClr val="24323A"/>
-                </a:solidFill>
-                <a:latin typeface="Arial" pitchFamily="34" charset="0"/>
+              <a:rPr lang="en-US" sz="1400" dirty="0">
+                <a:solidFill>
+                  <a:srgbClr val="24323A"/>
+                </a:solidFill>
                 <a:ea typeface="Arial" pitchFamily="34" charset="-122"/>
                 <a:cs typeface="Arial" pitchFamily="34" charset="-120"/>
               </a:rPr>
               <a:t>Vi </a:t>
             </a:r>
             <a:r>
-              <a:rPr lang="en-US" sz="1550" dirty="0" err="1">
-                <a:solidFill>
-                  <a:srgbClr val="24323A"/>
-                </a:solidFill>
-                <a:latin typeface="Arial" pitchFamily="34" charset="0"/>
+              <a:rPr lang="en-US" sz="1400" dirty="0" err="1">
+                <a:solidFill>
+                  <a:srgbClr val="24323A"/>
+                </a:solidFill>
                 <a:ea typeface="Arial" pitchFamily="34" charset="-122"/>
                 <a:cs typeface="Arial" pitchFamily="34" charset="-120"/>
               </a:rPr>
               <a:t>sorterar</a:t>
             </a:r>
             <a:r>
-              <a:rPr lang="en-US" sz="1550" dirty="0">
-                <a:solidFill>
-                  <a:srgbClr val="24323A"/>
-                </a:solidFill>
-                <a:latin typeface="Arial" pitchFamily="34" charset="0"/>
+              <a:rPr lang="en-US" sz="1400" dirty="0">
+                <a:solidFill>
+                  <a:srgbClr val="24323A"/>
+                </a:solidFill>
                 <a:ea typeface="Arial" pitchFamily="34" charset="-122"/>
                 <a:cs typeface="Arial" pitchFamily="34" charset="-120"/>
               </a:rPr>
               <a:t> </a:t>
             </a:r>
             <a:r>
-              <a:rPr lang="en-US" sz="1550" dirty="0" err="1">
-                <a:solidFill>
-                  <a:srgbClr val="24323A"/>
-                </a:solidFill>
-                <a:latin typeface="Arial" pitchFamily="34" charset="0"/>
+              <a:rPr lang="en-US" sz="1400" dirty="0" err="1">
+                <a:solidFill>
+                  <a:srgbClr val="24323A"/>
+                </a:solidFill>
                 <a:ea typeface="Arial" pitchFamily="34" charset="-122"/>
                 <a:cs typeface="Arial" pitchFamily="34" charset="-120"/>
               </a:rPr>
               <a:t>efter</a:t>
             </a:r>
             <a:r>
-              <a:rPr lang="en-US" sz="1550" dirty="0">
-                <a:solidFill>
-                  <a:srgbClr val="24323A"/>
-                </a:solidFill>
-                <a:latin typeface="Arial" pitchFamily="34" charset="0"/>
+              <a:rPr lang="en-US" sz="1400" dirty="0">
+                <a:solidFill>
+                  <a:srgbClr val="24323A"/>
+                </a:solidFill>
                 <a:ea typeface="Arial" pitchFamily="34" charset="-122"/>
                 <a:cs typeface="Arial" pitchFamily="34" charset="-120"/>
               </a:rPr>
               <a:t> </a:t>
             </a:r>
             <a:r>
-              <a:rPr lang="en-US" sz="1550" dirty="0" err="1">
-                <a:solidFill>
-                  <a:srgbClr val="24323A"/>
-                </a:solidFill>
-                <a:latin typeface="Arial" pitchFamily="34" charset="0"/>
+              <a:rPr lang="en-US" sz="1400" dirty="0" err="1">
+                <a:solidFill>
+                  <a:srgbClr val="24323A"/>
+                </a:solidFill>
                 <a:ea typeface="Arial" pitchFamily="34" charset="-122"/>
                 <a:cs typeface="Arial" pitchFamily="34" charset="-120"/>
               </a:rPr>
               <a:t>riskpoäng</a:t>
             </a:r>
             <a:r>
-              <a:rPr lang="en-US" sz="1550" dirty="0">
-                <a:solidFill>
-                  <a:srgbClr val="24323A"/>
-                </a:solidFill>
-                <a:latin typeface="Arial" pitchFamily="34" charset="0"/>
+              <a:rPr lang="en-US" sz="1400" dirty="0">
+                <a:solidFill>
+                  <a:srgbClr val="24323A"/>
+                </a:solidFill>
                 <a:ea typeface="Arial" pitchFamily="34" charset="-122"/>
                 <a:cs typeface="Arial" pitchFamily="34" charset="-120"/>
               </a:rPr>
               <a:t> och </a:t>
             </a:r>
             <a:r>
-              <a:rPr lang="en-US" sz="1550" dirty="0" err="1">
-                <a:solidFill>
-                  <a:srgbClr val="24323A"/>
-                </a:solidFill>
-                <a:latin typeface="Arial" pitchFamily="34" charset="0"/>
+              <a:rPr lang="en-US" sz="1400" dirty="0" err="1">
+                <a:solidFill>
+                  <a:srgbClr val="24323A"/>
+                </a:solidFill>
                 <a:ea typeface="Arial" pitchFamily="34" charset="-122"/>
                 <a:cs typeface="Arial" pitchFamily="34" charset="-120"/>
               </a:rPr>
               <a:t>skickar</a:t>
             </a:r>
             <a:r>
-              <a:rPr lang="en-US" sz="1550" dirty="0">
-                <a:solidFill>
-                  <a:srgbClr val="24323A"/>
-                </a:solidFill>
-                <a:latin typeface="Arial" pitchFamily="34" charset="0"/>
+              <a:rPr lang="en-US" sz="1400" dirty="0">
+                <a:solidFill>
+                  <a:srgbClr val="24323A"/>
+                </a:solidFill>
                 <a:ea typeface="Arial" pitchFamily="34" charset="-122"/>
                 <a:cs typeface="Arial" pitchFamily="34" charset="-120"/>
               </a:rPr>
               <a:t> bara de X% </a:t>
             </a:r>
             <a:r>
-              <a:rPr lang="en-US" sz="1550" dirty="0" err="1">
-                <a:solidFill>
-                  <a:srgbClr val="24323A"/>
-                </a:solidFill>
-                <a:latin typeface="Arial" pitchFamily="34" charset="0"/>
+              <a:rPr lang="en-US" sz="1400" dirty="0" err="1">
+                <a:solidFill>
+                  <a:srgbClr val="24323A"/>
+                </a:solidFill>
                 <a:ea typeface="Arial" pitchFamily="34" charset="-122"/>
                 <a:cs typeface="Arial" pitchFamily="34" charset="-120"/>
               </a:rPr>
               <a:t>högst</a:t>
             </a:r>
             <a:r>
-              <a:rPr lang="en-US" sz="1550" dirty="0">
-                <a:solidFill>
-                  <a:srgbClr val="24323A"/>
-                </a:solidFill>
-                <a:latin typeface="Arial" pitchFamily="34" charset="0"/>
+              <a:rPr lang="en-US" sz="1400" dirty="0">
+                <a:solidFill>
+                  <a:srgbClr val="24323A"/>
+                </a:solidFill>
                 <a:ea typeface="Arial" pitchFamily="34" charset="-122"/>
                 <a:cs typeface="Arial" pitchFamily="34" charset="-120"/>
               </a:rPr>
               <a:t> risk till </a:t>
             </a:r>
             <a:r>
-              <a:rPr lang="en-US" sz="1550" dirty="0" err="1">
-                <a:solidFill>
-                  <a:srgbClr val="24323A"/>
-                </a:solidFill>
-                <a:latin typeface="Arial" pitchFamily="34" charset="0"/>
+              <a:rPr lang="en-US" sz="1400" dirty="0" err="1">
+                <a:solidFill>
+                  <a:srgbClr val="24323A"/>
+                </a:solidFill>
                 <a:ea typeface="Arial" pitchFamily="34" charset="-122"/>
                 <a:cs typeface="Arial" pitchFamily="34" charset="-120"/>
               </a:rPr>
               <a:t>granskning</a:t>
             </a:r>
             <a:r>
-              <a:rPr lang="en-US" sz="1550" dirty="0">
-                <a:solidFill>
-                  <a:srgbClr val="24323A"/>
-                </a:solidFill>
-                <a:latin typeface="Arial" pitchFamily="34" charset="0"/>
+              <a:rPr lang="en-US" sz="1400" dirty="0">
+                <a:solidFill>
+                  <a:srgbClr val="24323A"/>
+                </a:solidFill>
                 <a:ea typeface="Arial" pitchFamily="34" charset="-122"/>
                 <a:cs typeface="Arial" pitchFamily="34" charset="-120"/>
               </a:rPr>
@@ -7300,11 +7502,10 @@
               <a:buFontTx/>
               <a:buChar char="•"/>
             </a:pPr>
-            <a:endParaRPr lang="en-US" sz="1550" dirty="0">
+            <a:endParaRPr lang="en-US" sz="1400" dirty="0">
               <a:solidFill>
                 <a:srgbClr val="24323A"/>
               </a:solidFill>
-              <a:latin typeface="Arial" pitchFamily="34" charset="0"/>
               <a:ea typeface="Arial" pitchFamily="34" charset="-122"/>
               <a:cs typeface="Arial" pitchFamily="34" charset="-120"/>
             </a:endParaRPr>
@@ -7316,99 +7517,90 @@
               <a:buChar char="•"/>
             </a:pPr>
             <a:r>
-              <a:rPr lang="en-US" sz="1550" dirty="0">
-                <a:solidFill>
-                  <a:srgbClr val="24323A"/>
-                </a:solidFill>
-                <a:latin typeface="Arial" pitchFamily="34" charset="0"/>
+              <a:rPr lang="en-US" sz="1400" dirty="0">
+                <a:solidFill>
+                  <a:srgbClr val="24323A"/>
+                </a:solidFill>
                 <a:ea typeface="Arial" pitchFamily="34" charset="-122"/>
                 <a:cs typeface="Arial" pitchFamily="34" charset="-120"/>
               </a:rPr>
               <a:t>Vi </a:t>
             </a:r>
             <a:r>
-              <a:rPr lang="en-US" sz="1550" dirty="0" err="1">
-                <a:solidFill>
-                  <a:srgbClr val="24323A"/>
-                </a:solidFill>
-                <a:latin typeface="Arial" pitchFamily="34" charset="0"/>
+              <a:rPr lang="en-US" sz="1400" dirty="0" err="1">
+                <a:solidFill>
+                  <a:srgbClr val="24323A"/>
+                </a:solidFill>
                 <a:ea typeface="Arial" pitchFamily="34" charset="-122"/>
                 <a:cs typeface="Arial" pitchFamily="34" charset="-120"/>
               </a:rPr>
               <a:t>jämför</a:t>
             </a:r>
             <a:r>
-              <a:rPr lang="en-US" sz="1550" dirty="0">
-                <a:solidFill>
-                  <a:srgbClr val="24323A"/>
-                </a:solidFill>
-                <a:latin typeface="Arial" pitchFamily="34" charset="0"/>
+              <a:rPr lang="en-US" sz="1400" dirty="0">
+                <a:solidFill>
+                  <a:srgbClr val="24323A"/>
+                </a:solidFill>
                 <a:ea typeface="Arial" pitchFamily="34" charset="-122"/>
                 <a:cs typeface="Arial" pitchFamily="34" charset="-120"/>
               </a:rPr>
               <a:t> top 3%, 5% och 10% </a:t>
             </a:r>
             <a:r>
-              <a:rPr lang="en-US" sz="1550" dirty="0" err="1">
-                <a:solidFill>
-                  <a:srgbClr val="24323A"/>
-                </a:solidFill>
-                <a:latin typeface="Arial" pitchFamily="34" charset="0"/>
+              <a:rPr lang="en-US" sz="1400" dirty="0" err="1">
+                <a:solidFill>
+                  <a:srgbClr val="24323A"/>
+                </a:solidFill>
                 <a:ea typeface="Arial" pitchFamily="34" charset="-122"/>
                 <a:cs typeface="Arial" pitchFamily="34" charset="-120"/>
               </a:rPr>
               <a:t>utifrån</a:t>
             </a:r>
             <a:r>
-              <a:rPr lang="en-US" sz="1550" dirty="0">
-                <a:solidFill>
-                  <a:srgbClr val="24323A"/>
-                </a:solidFill>
-                <a:latin typeface="Arial" pitchFamily="34" charset="0"/>
+              <a:rPr lang="en-US" sz="1400" dirty="0">
+                <a:solidFill>
+                  <a:srgbClr val="24323A"/>
+                </a:solidFill>
                 <a:ea typeface="Arial" pitchFamily="34" charset="-122"/>
                 <a:cs typeface="Arial" pitchFamily="34" charset="-120"/>
               </a:rPr>
               <a:t> </a:t>
             </a:r>
             <a:r>
-              <a:rPr lang="en-US" sz="1550" dirty="0" err="1">
-                <a:solidFill>
-                  <a:srgbClr val="24323A"/>
-                </a:solidFill>
-                <a:latin typeface="Arial" pitchFamily="34" charset="0"/>
+              <a:rPr lang="en-US" sz="1400" dirty="0" err="1">
+                <a:solidFill>
+                  <a:srgbClr val="24323A"/>
+                </a:solidFill>
                 <a:ea typeface="Arial" pitchFamily="34" charset="-122"/>
                 <a:cs typeface="Arial" pitchFamily="34" charset="-120"/>
               </a:rPr>
               <a:t>antal</a:t>
             </a:r>
             <a:r>
-              <a:rPr lang="en-US" sz="1550" dirty="0">
-                <a:solidFill>
-                  <a:srgbClr val="24323A"/>
-                </a:solidFill>
-                <a:latin typeface="Arial" pitchFamily="34" charset="0"/>
+              <a:rPr lang="en-US" sz="1400" dirty="0">
+                <a:solidFill>
+                  <a:srgbClr val="24323A"/>
+                </a:solidFill>
                 <a:ea typeface="Arial" pitchFamily="34" charset="-122"/>
                 <a:cs typeface="Arial" pitchFamily="34" charset="-120"/>
               </a:rPr>
               <a:t> </a:t>
             </a:r>
             <a:r>
-              <a:rPr lang="en-US" sz="1550" dirty="0" err="1">
-                <a:solidFill>
-                  <a:srgbClr val="24323A"/>
-                </a:solidFill>
-                <a:latin typeface="Arial" pitchFamily="34" charset="0"/>
+              <a:rPr lang="en-US" sz="1400" dirty="0" err="1">
+                <a:solidFill>
+                  <a:srgbClr val="24323A"/>
+                </a:solidFill>
                 <a:ea typeface="Arial" pitchFamily="34" charset="-122"/>
                 <a:cs typeface="Arial" pitchFamily="34" charset="-120"/>
               </a:rPr>
               <a:t>flaggade</a:t>
             </a:r>
             <a:r>
-              <a:rPr lang="en-US" sz="1550" dirty="0">
-                <a:solidFill>
-                  <a:srgbClr val="24323A"/>
-                </a:solidFill>
-                <a:latin typeface="Arial" pitchFamily="34" charset="0"/>
+              <a:rPr lang="en-US" sz="1400" dirty="0">
+                <a:solidFill>
+                  <a:srgbClr val="24323A"/>
+                </a:solidFill>
                 <a:ea typeface="Arial" pitchFamily="34" charset="-122"/>
                 <a:cs typeface="Arial" pitchFamily="34" charset="-120"/>
               </a:rPr>
@@ -7421,11 +7613,10 @@
               <a:buFontTx/>
               <a:buChar char="•"/>
             </a:pPr>
-            <a:endParaRPr lang="en-US" sz="1550" dirty="0">
+            <a:endParaRPr lang="en-US" sz="1400" dirty="0">
               <a:solidFill>
                 <a:srgbClr val="24323A"/>
               </a:solidFill>
-              <a:latin typeface="Arial" pitchFamily="34" charset="0"/>
               <a:ea typeface="Arial" pitchFamily="34" charset="-122"/>
               <a:cs typeface="Arial" pitchFamily="34" charset="-120"/>
             </a:endParaRPr>
@@ -7437,105 +7628,20 @@
               <a:buChar char="•"/>
             </a:pPr>
             <a:r>
-              <a:rPr lang="en-US" sz="1550" dirty="0">
-                <a:solidFill>
-                  <a:srgbClr val="24323A"/>
-                </a:solidFill>
-                <a:latin typeface="Arial" pitchFamily="34" charset="0"/>
-                <a:ea typeface="Arial" pitchFamily="34" charset="-122"/>
-                <a:cs typeface="Arial" pitchFamily="34" charset="-120"/>
-              </a:rPr>
-              <a:t>Detta </a:t>
-            </a:r>
-            <a:r>
-              <a:rPr lang="en-US" sz="1550" dirty="0" err="1">
-                <a:solidFill>
-                  <a:srgbClr val="24323A"/>
-                </a:solidFill>
-                <a:latin typeface="Arial" pitchFamily="34" charset="0"/>
-                <a:ea typeface="Arial" pitchFamily="34" charset="-122"/>
-                <a:cs typeface="Arial" pitchFamily="34" charset="-120"/>
-              </a:rPr>
-              <a:t>hjälper</a:t>
-            </a:r>
-            <a:r>
-              <a:rPr lang="en-US" sz="1550" dirty="0">
-                <a:solidFill>
-                  <a:srgbClr val="24323A"/>
-                </a:solidFill>
-                <a:latin typeface="Arial" pitchFamily="34" charset="0"/>
-                <a:ea typeface="Arial" pitchFamily="34" charset="-122"/>
-                <a:cs typeface="Arial" pitchFamily="34" charset="-120"/>
-              </a:rPr>
-              <a:t> </a:t>
-            </a:r>
-            <a:r>
-              <a:rPr lang="en-US" sz="1550" dirty="0" err="1">
-                <a:solidFill>
-                  <a:srgbClr val="24323A"/>
-                </a:solidFill>
-                <a:latin typeface="Arial" pitchFamily="34" charset="0"/>
-                <a:ea typeface="Arial" pitchFamily="34" charset="-122"/>
-                <a:cs typeface="Arial" pitchFamily="34" charset="-120"/>
-              </a:rPr>
-              <a:t>planering</a:t>
-            </a:r>
-            <a:r>
-              <a:rPr lang="en-US" sz="1550" dirty="0">
-                <a:solidFill>
-                  <a:srgbClr val="24323A"/>
-                </a:solidFill>
-                <a:latin typeface="Arial" pitchFamily="34" charset="0"/>
-                <a:ea typeface="Arial" pitchFamily="34" charset="-122"/>
-                <a:cs typeface="Arial" pitchFamily="34" charset="-120"/>
-              </a:rPr>
-              <a:t> av </a:t>
-            </a:r>
-            <a:r>
-              <a:rPr lang="en-US" sz="1550" dirty="0" err="1">
-                <a:solidFill>
-                  <a:srgbClr val="24323A"/>
-                </a:solidFill>
-                <a:latin typeface="Arial" pitchFamily="34" charset="0"/>
-                <a:ea typeface="Arial" pitchFamily="34" charset="-122"/>
-                <a:cs typeface="Arial" pitchFamily="34" charset="-120"/>
-              </a:rPr>
-              <a:t>arbetsbelastning</a:t>
-            </a:r>
-            <a:r>
-              <a:rPr lang="en-US" sz="1550" dirty="0">
-                <a:solidFill>
-                  <a:srgbClr val="24323A"/>
-                </a:solidFill>
-                <a:latin typeface="Arial" pitchFamily="34" charset="0"/>
-                <a:ea typeface="Arial" pitchFamily="34" charset="-122"/>
-                <a:cs typeface="Arial" pitchFamily="34" charset="-120"/>
-              </a:rPr>
-              <a:t> och </a:t>
-            </a:r>
-            <a:r>
-              <a:rPr lang="en-US" sz="1550" dirty="0" err="1">
-                <a:solidFill>
-                  <a:srgbClr val="24323A"/>
-                </a:solidFill>
-                <a:latin typeface="Arial" pitchFamily="34" charset="0"/>
-                <a:ea typeface="Arial" pitchFamily="34" charset="-122"/>
-                <a:cs typeface="Arial" pitchFamily="34" charset="-120"/>
-              </a:rPr>
-              <a:t>bemanning</a:t>
-            </a:r>
-            <a:r>
-              <a:rPr lang="en-US" sz="1550" dirty="0">
-                <a:solidFill>
-                  <a:srgbClr val="24323A"/>
-                </a:solidFill>
-                <a:latin typeface="Arial" pitchFamily="34" charset="0"/>
+              <a:rPr lang="sv-SE" sz="1400" dirty="0"/>
+              <a:t>Top-X ger stabil volym → lättare planera arbetsbelastning och bemanning</a:t>
+            </a:r>
+            <a:r>
+              <a:rPr lang="en-US" sz="1400" dirty="0">
+                <a:solidFill>
+                  <a:srgbClr val="24323A"/>
+                </a:solidFill>
                 <a:ea typeface="Arial" pitchFamily="34" charset="-122"/>
                 <a:cs typeface="Arial" pitchFamily="34" charset="-120"/>
               </a:rPr>
               <a:t>.</a:t>
             </a:r>
-            <a:endParaRPr lang="en-US" sz="1550" dirty="0"/>
+            <a:endParaRPr lang="en-US" sz="1400" dirty="0"/>
           </a:p>
           <a:p>
             <a:pPr marL="228600" indent="-228600">
@@ -7593,9 +7699,6 @@
             </a:endParaRPr>
           </a:p>
           <a:p>
-            <a:pPr marL="0" indent="0">
-              <a:buNone/>
-            </a:pPr>
             <a:r>
               <a:rPr lang="en-US" sz="1800" b="1" dirty="0" err="1">
                 <a:solidFill>
@@ -7610,63 +7713,65 @@
                   <a:srgbClr val="24323A"/>
                 </a:solidFill>
               </a:rPr>
-              <a:t>: Vi väljer Top ___% eftersom det ger ___ flaggningar och precision ___.</a:t>
+              <a:t>: Vi väljer Top </a:t>
+            </a:r>
+            <a:r>
+              <a:rPr lang="en-US" b="1" dirty="0">
+                <a:solidFill>
+                  <a:srgbClr val="24323A"/>
+                </a:solidFill>
+              </a:rPr>
+              <a:t>5</a:t>
+            </a:r>
+            <a:r>
+              <a:rPr lang="en-US" sz="1800" b="1" dirty="0">
+                <a:solidFill>
+                  <a:srgbClr val="24323A"/>
+                </a:solidFill>
+              </a:rPr>
+              <a:t>% eftersom det ger </a:t>
+            </a:r>
+            <a:r>
+              <a:rPr lang="en-US" b="1" dirty="0">
+                <a:solidFill>
+                  <a:srgbClr val="24323A"/>
+                </a:solidFill>
+              </a:rPr>
+              <a:t>ca 120</a:t>
+            </a:r>
+            <a:r>
+              <a:rPr lang="en-US" sz="1800" b="1" dirty="0">
+                <a:solidFill>
+                  <a:srgbClr val="24323A"/>
+                </a:solidFill>
+              </a:rPr>
+              <a:t> flaggningar och precision </a:t>
+            </a:r>
+            <a:r>
+              <a:rPr lang="en-SE" b="1" dirty="0"/>
+              <a:t>0.375</a:t>
+            </a:r>
+            <a:r>
+              <a:rPr lang="en-SE" dirty="0"/>
+              <a:t> (≈ </a:t>
+            </a:r>
+            <a:r>
+              <a:rPr lang="en-SE" b="1" dirty="0"/>
+              <a:t>38%</a:t>
+            </a:r>
+            <a:r>
+              <a:rPr lang="en-SE" dirty="0"/>
+              <a:t>)</a:t>
+            </a:r>
+            <a:r>
+              <a:rPr lang="en-US" sz="1800" b="1" dirty="0">
+                <a:solidFill>
+                  <a:srgbClr val="24323A"/>
+                </a:solidFill>
+              </a:rPr>
+              <a:t>.</a:t>
             </a:r>
             <a:endParaRPr lang="en-US" sz="1800" dirty="0"/>
-          </a:p>
-        </p:txBody>
-      </p:sp>
-      <p:sp>
-        <p:nvSpPr>
-          <p:cNvPr id="34" name="Text 32"/>
-          <p:cNvSpPr/>
-          <p:nvPr/>
-        </p:nvSpPr>
-        <p:spPr>
-          <a:xfrm>
-            <a:off x="4251960" y="4224528"/>
-            <a:ext cx="6583680" cy="310896"/>
-          </a:xfrm>
-          <a:prstGeom prst="rect">
-            <a:avLst/>
-          </a:prstGeom>
-          <a:noFill/>
-          <a:ln/>
-        </p:spPr>
-        <p:txBody>
-          <a:bodyPr wrap="square" lIns="254" tIns="254" rIns="254" bIns="254" rtlCol="0" anchor="ctr"/>
-          <a:lstStyle/>
-          <a:p>
-            <a:pPr marL="228600" indent="-228600">
-              <a:buSzPct val="100000"/>
-              <a:buChar char="•"/>
-            </a:pPr>
-            <a:endParaRPr lang="en-US" sz="1600" dirty="0">
-              <a:solidFill>
-                <a:srgbClr val="24323A"/>
-              </a:solidFill>
-              <a:latin typeface="Arial" pitchFamily="34" charset="0"/>
-              <a:ea typeface="Arial" pitchFamily="34" charset="-122"/>
-              <a:cs typeface="Arial" pitchFamily="34" charset="-120"/>
-            </a:endParaRPr>
-          </a:p>
-          <a:p>
-            <a:pPr marL="228600" indent="-228600">
-              <a:buSzPct val="100000"/>
-              <a:buChar char="•"/>
-            </a:pPr>
-            <a:r>
-              <a:rPr lang="en-US" sz="1600" dirty="0">
-                <a:solidFill>
-                  <a:srgbClr val="24323A"/>
-                </a:solidFill>
-                <a:latin typeface="Arial" pitchFamily="34" charset="0"/>
-                <a:ea typeface="Arial" pitchFamily="34" charset="-122"/>
-                <a:cs typeface="Arial" pitchFamily="34" charset="-120"/>
-              </a:rPr>
-              <a:t>FP: onödiga granskningar och mer kö.</a:t>
-            </a:r>
-            <a:endParaRPr lang="en-US" sz="1600" dirty="0"/>
           </a:p>
         </p:txBody>
       </p:sp>
@@ -7695,84 +7800,13 @@
               <a:buSzPct val="100000"/>
               <a:buChar char="•"/>
             </a:pPr>
-            <a:endParaRPr lang="en-US" sz="1600" dirty="0">
-              <a:solidFill>
-                <a:srgbClr val="24323A"/>
-              </a:solidFill>
-              <a:latin typeface="Arial" pitchFamily="34" charset="0"/>
-              <a:ea typeface="Arial" pitchFamily="34" charset="-122"/>
-              <a:cs typeface="Arial" pitchFamily="34" charset="-120"/>
-            </a:endParaRPr>
-          </a:p>
-          <a:p>
-            <a:pPr marL="228600" indent="-228600">
-              <a:buSzPct val="100000"/>
-              <a:buChar char="•"/>
-            </a:pPr>
-            <a:r>
-              <a:rPr lang="en-US" sz="1600" dirty="0">
-                <a:solidFill>
-                  <a:srgbClr val="24323A"/>
-                </a:solidFill>
-                <a:latin typeface="Arial" pitchFamily="34" charset="0"/>
-                <a:ea typeface="Arial" pitchFamily="34" charset="-122"/>
-                <a:cs typeface="Arial" pitchFamily="34" charset="-120"/>
-              </a:rPr>
-              <a:t>FN: vissa misstänkta fall missas.</a:t>
-            </a:r>
-            <a:endParaRPr lang="en-US" sz="1600" dirty="0"/>
-          </a:p>
-        </p:txBody>
-      </p:sp>
-      <p:sp>
-        <p:nvSpPr>
-          <p:cNvPr id="36" name="Text 34"/>
-          <p:cNvSpPr/>
-          <p:nvPr/>
-        </p:nvSpPr>
-        <p:spPr>
-          <a:xfrm>
-            <a:off x="4251960" y="4992624"/>
-            <a:ext cx="6583680" cy="310896"/>
-          </a:xfrm>
-          <a:prstGeom prst="rect">
-            <a:avLst/>
-          </a:prstGeom>
-          <a:noFill/>
-          <a:ln/>
-        </p:spPr>
-        <p:txBody>
-          <a:bodyPr wrap="square" lIns="254" tIns="254" rIns="254" bIns="254" rtlCol="0" anchor="ctr"/>
-          <a:lstStyle/>
-          <a:p>
-            <a:pPr marL="228600" indent="-228600">
-              <a:buSzPct val="100000"/>
-              <a:buChar char="•"/>
-            </a:pPr>
-            <a:endParaRPr lang="en-US" sz="1600" dirty="0">
-              <a:solidFill>
-                <a:srgbClr val="24323A"/>
-              </a:solidFill>
-              <a:latin typeface="Arial" pitchFamily="34" charset="0"/>
-              <a:ea typeface="Arial" pitchFamily="34" charset="-122"/>
-              <a:cs typeface="Arial" pitchFamily="34" charset="-120"/>
-            </a:endParaRPr>
-          </a:p>
-          <a:p>
-            <a:pPr marL="228600" indent="-228600">
-              <a:buSzPct val="100000"/>
-              <a:buChar char="•"/>
-            </a:pPr>
-            <a:r>
-              <a:rPr lang="en-US" sz="1600" dirty="0">
-                <a:solidFill>
-                  <a:srgbClr val="24323A"/>
-                </a:solidFill>
-                <a:latin typeface="Arial" pitchFamily="34" charset="0"/>
-                <a:ea typeface="Arial" pitchFamily="34" charset="-122"/>
-                <a:cs typeface="Arial" pitchFamily="34" charset="-120"/>
-              </a:rPr>
-              <a:t>För Operations är det viktigast att hålla volymen hanterbar.</a:t>
+            <a:r>
+              <a:rPr lang="sv-SE" sz="1600" dirty="0" err="1"/>
+              <a:t>Trade</a:t>
+            </a:r>
+            <a:r>
+              <a:rPr lang="sv-SE" sz="1600" dirty="0"/>
+              <a:t>-off: vi missar vissa fall (FN) men kön hålls hanterbar.</a:t>
             </a:r>
             <a:endParaRPr lang="en-US" sz="1600" dirty="0"/>
           </a:p>
@@ -7829,7 +7863,7 @@
           <p:nvPr>
             <p:extLst>
               <p:ext uri="{D42A27DB-BD31-4B8C-83A1-F6EECF244321}">
-                <p14:modId xmlns:p14="http://schemas.microsoft.com/office/powerpoint/2010/main" val="15418493"/>
+                <p14:modId xmlns:p14="http://schemas.microsoft.com/office/powerpoint/2010/main" val="3889306615"/>
               </p:ext>
             </p:extLst>
           </p:nvPr>
@@ -7972,6 +8006,10 @@
                     <a:lstStyle/>
                     <a:p>
                       <a:pPr algn="ctr"/>
+                      <a:r>
+                        <a:rPr lang="sv-SE" dirty="0"/>
+                        <a:t>72</a:t>
+                      </a:r>
                       <a:endParaRPr lang="en-SE" dirty="0"/>
                     </a:p>
                   </a:txBody>
@@ -7983,7 +8021,10 @@
                     <a:lstStyle/>
                     <a:p>
                       <a:pPr algn="ctr"/>
-                      <a:endParaRPr lang="en-SE" dirty="0"/>
+                      <a:r>
+                        <a:rPr lang="en-SE" dirty="0"/>
+                        <a:t>43%</a:t>
+                      </a:r>
                     </a:p>
                   </a:txBody>
                   <a:tcPr/>
@@ -8039,7 +8080,11 @@
                     <a:lstStyle/>
                     <a:p>
                       <a:pPr algn="ctr"/>
-                      <a:endParaRPr lang="en-SE"/>
+                      <a:r>
+                        <a:rPr lang="sv-SE" dirty="0"/>
+                        <a:t>120</a:t>
+                      </a:r>
+                      <a:endParaRPr lang="en-SE" dirty="0"/>
                     </a:p>
                   </a:txBody>
                   <a:tcPr/>
@@ -8050,7 +8095,10 @@
                     <a:lstStyle/>
                     <a:p>
                       <a:pPr algn="ctr"/>
-                      <a:endParaRPr lang="en-SE" dirty="0"/>
+                      <a:r>
+                        <a:rPr lang="en-SE" dirty="0"/>
+                        <a:t>38%</a:t>
+                      </a:r>
                     </a:p>
                   </a:txBody>
                   <a:tcPr/>
@@ -8106,7 +8154,11 @@
                     <a:lstStyle/>
                     <a:p>
                       <a:pPr algn="ctr"/>
-                      <a:endParaRPr lang="en-SE" dirty="0"/>
+                      <a:r>
+                        <a:rPr lang="sv-SE" b="0" dirty="0"/>
+                        <a:t>240</a:t>
+                      </a:r>
+                      <a:endParaRPr lang="en-SE" b="0" dirty="0"/>
                     </a:p>
                   </a:txBody>
                   <a:tcPr/>
@@ -8117,7 +8169,10 @@
                     <a:lstStyle/>
                     <a:p>
                       <a:pPr algn="ctr"/>
-                      <a:endParaRPr lang="en-SE" dirty="0"/>
+                      <a:r>
+                        <a:rPr lang="en-SE" b="0" dirty="0"/>
+                        <a:t>30%</a:t>
+                      </a:r>
                     </a:p>
                   </a:txBody>
                   <a:tcPr/>
@@ -8323,6 +8378,17 @@
               <a:buNone/>
             </a:pPr>
             <a:r>
+              <a:rPr lang="en-US" sz="1600" b="1" dirty="0" err="1">
+                <a:solidFill>
+                  <a:srgbClr val="24323A"/>
+                </a:solidFill>
+                <a:latin typeface="Arial" pitchFamily="34" charset="0"/>
+                <a:ea typeface="Arial" pitchFamily="34" charset="-122"/>
+                <a:cs typeface="Arial" pitchFamily="34" charset="-120"/>
+              </a:rPr>
+              <a:t>När</a:t>
+            </a:r>
+            <a:r>
               <a:rPr lang="en-US" sz="1600" b="1" dirty="0">
                 <a:solidFill>
                   <a:srgbClr val="24323A"/>
@@ -8331,7 +8397,7 @@
                 <a:ea typeface="Arial" pitchFamily="34" charset="-122"/>
                 <a:cs typeface="Arial" pitchFamily="34" charset="-120"/>
               </a:rPr>
-              <a:t>När new_data kommer</a:t>
+              <a:t> new data kommer</a:t>
             </a:r>
             <a:endParaRPr lang="en-US" sz="1600" dirty="0"/>
           </a:p>
@@ -8411,7 +8477,7 @@
                 <a:ea typeface="Arial" pitchFamily="34" charset="-122"/>
                 <a:cs typeface="Arial" pitchFamily="34" charset="-120"/>
               </a:rPr>
-              <a:t>Vi flaggar Top ___% → ___ ärenden till granskning.</a:t>
+              <a:t>Vi flaggar Top  5% → ___ ärenden till granskning.</a:t>
             </a:r>
             <a:endParaRPr lang="en-US" sz="1580" dirty="0"/>
           </a:p>
@@ -8443,15 +8509,8 @@
               <a:buChar char="•"/>
             </a:pPr>
             <a:r>
-              <a:rPr lang="en-US" sz="1580" dirty="0">
-                <a:solidFill>
-                  <a:srgbClr val="24323A"/>
-                </a:solidFill>
-                <a:latin typeface="Arial" pitchFamily="34" charset="0"/>
-                <a:ea typeface="Arial" pitchFamily="34" charset="-122"/>
-                <a:cs typeface="Arial" pitchFamily="34" charset="-120"/>
-              </a:rPr>
-              <a:t>Reflektion: volymen ska kännas hanterbar och ge en tydlig kö.</a:t>
+              <a:rPr lang="sv-SE" sz="1600" dirty="0"/>
+              <a:t>Reflektion: Top-5% ska ge en tydlig och hanterbar kö för teamet</a:t>
             </a:r>
             <a:endParaRPr lang="en-US" sz="1580" dirty="0"/>
           </a:p>
@@ -8562,15 +8621,8 @@
               <a:buChar char="•"/>
             </a:pPr>
             <a:r>
-              <a:rPr lang="en-US" sz="1580" dirty="0">
-                <a:solidFill>
-                  <a:srgbClr val="24323A"/>
-                </a:solidFill>
-                <a:latin typeface="Arial" pitchFamily="34" charset="0"/>
-                <a:ea typeface="Arial" pitchFamily="34" charset="-122"/>
-                <a:cs typeface="Arial" pitchFamily="34" charset="-120"/>
-              </a:rPr>
-              <a:t>Beteenden kan ändras över tid (drift).</a:t>
+              <a:rPr lang="sv-SE" sz="1600"/>
+              <a:t>Beteenden kan ändras över tid (drift) → kvalitet kan sjunka</a:t>
             </a:r>
             <a:endParaRPr lang="en-US" sz="1580" dirty="0"/>
           </a:p>

</xml_diff>

<commit_message>
Update slides to latest version
</commit_message>
<xml_diff>
--- a/marketplace_safety_slides.pptx
+++ b/marketplace_safety_slides.pptx
@@ -118,17 +118,64 @@
 </p:presentation>
 </file>
 
+<file path=ppt/revisionInfo.xml><?xml version="1.0" encoding="utf-8"?>
+<p1510:revInfo xmlns:a="http://schemas.openxmlformats.org/drawingml/2006/main" xmlns:r="http://schemas.openxmlformats.org/officeDocument/2006/relationships" xmlns:p1510="http://schemas.microsoft.com/office/powerpoint/2015/10/main">
+  <p1510:revLst>
+    <p1510:client id="{2D54AF1E-4C82-48AE-BAD0-2A999153E33B}" v="56" dt="2026-03-16T14:49:07.663"/>
+  </p1510:revLst>
+</p1510:revInfo>
+</file>
+
 <file path=ppt/changesInfos/changesInfo1.xml><?xml version="1.0" encoding="utf-8"?>
 <pc:chgInfo xmlns:a="http://schemas.openxmlformats.org/drawingml/2006/main" xmlns:r="http://schemas.openxmlformats.org/officeDocument/2006/relationships" xmlns:ac="http://schemas.microsoft.com/office/drawing/2013/main/command" xmlns:pc="http://schemas.microsoft.com/office/powerpoint/2013/main/command">
   <pc:docChgLst>
     <pc:chgData name="Yunus Emre Capar" userId="6e34af16be8e7db1" providerId="LiveId" clId="{1A4E8B3D-71E9-45CB-9AC9-58DE4384F4B0}"/>
-    <pc:docChg chg="modSld">
-      <pc:chgData name="Yunus Emre Capar" userId="6e34af16be8e7db1" providerId="LiveId" clId="{1A4E8B3D-71E9-45CB-9AC9-58DE4384F4B0}" dt="2026-03-11T12:48:11.610" v="7" actId="14100"/>
+    <pc:docChg chg="undo custSel modSld">
+      <pc:chgData name="Yunus Emre Capar" userId="6e34af16be8e7db1" providerId="LiveId" clId="{1A4E8B3D-71E9-45CB-9AC9-58DE4384F4B0}" dt="2026-03-16T14:49:07.663" v="190"/>
       <pc:docMkLst>
         <pc:docMk/>
       </pc:docMkLst>
       <pc:sldChg chg="modSp mod">
-        <pc:chgData name="Yunus Emre Capar" userId="6e34af16be8e7db1" providerId="LiveId" clId="{1A4E8B3D-71E9-45CB-9AC9-58DE4384F4B0}" dt="2026-03-11T12:48:11.610" v="7" actId="14100"/>
+        <pc:chgData name="Yunus Emre Capar" userId="6e34af16be8e7db1" providerId="LiveId" clId="{1A4E8B3D-71E9-45CB-9AC9-58DE4384F4B0}" dt="2026-03-16T14:10:55.303" v="29"/>
+        <pc:sldMkLst>
+          <pc:docMk/>
+          <pc:sldMk cId="0" sldId="258"/>
+        </pc:sldMkLst>
+        <pc:spChg chg="mod">
+          <ac:chgData name="Yunus Emre Capar" userId="6e34af16be8e7db1" providerId="LiveId" clId="{1A4E8B3D-71E9-45CB-9AC9-58DE4384F4B0}" dt="2026-03-16T14:08:48.581" v="16" actId="120"/>
+          <ac:spMkLst>
+            <pc:docMk/>
+            <pc:sldMk cId="0" sldId="258"/>
+            <ac:spMk id="4" creationId="{00000000-0000-0000-0000-000000000000}"/>
+          </ac:spMkLst>
+        </pc:spChg>
+        <pc:spChg chg="mod">
+          <ac:chgData name="Yunus Emre Capar" userId="6e34af16be8e7db1" providerId="LiveId" clId="{1A4E8B3D-71E9-45CB-9AC9-58DE4384F4B0}" dt="2026-03-16T14:10:23.279" v="28" actId="20577"/>
+          <ac:spMkLst>
+            <pc:docMk/>
+            <pc:sldMk cId="0" sldId="258"/>
+            <ac:spMk id="15" creationId="{00000000-0000-0000-0000-000000000000}"/>
+          </ac:spMkLst>
+        </pc:spChg>
+        <pc:spChg chg="mod">
+          <ac:chgData name="Yunus Emre Capar" userId="6e34af16be8e7db1" providerId="LiveId" clId="{1A4E8B3D-71E9-45CB-9AC9-58DE4384F4B0}" dt="2026-03-16T14:03:10.812" v="9"/>
+          <ac:spMkLst>
+            <pc:docMk/>
+            <pc:sldMk cId="0" sldId="258"/>
+            <ac:spMk id="20" creationId="{00000000-0000-0000-0000-000000000000}"/>
+          </ac:spMkLst>
+        </pc:spChg>
+        <pc:spChg chg="mod">
+          <ac:chgData name="Yunus Emre Capar" userId="6e34af16be8e7db1" providerId="LiveId" clId="{1A4E8B3D-71E9-45CB-9AC9-58DE4384F4B0}" dt="2026-03-16T14:10:55.303" v="29"/>
+          <ac:spMkLst>
+            <pc:docMk/>
+            <pc:sldMk cId="0" sldId="258"/>
+            <ac:spMk id="21" creationId="{00000000-0000-0000-0000-000000000000}"/>
+          </ac:spMkLst>
+        </pc:spChg>
+      </pc:sldChg>
+      <pc:sldChg chg="modSp mod">
+        <pc:chgData name="Yunus Emre Capar" userId="6e34af16be8e7db1" providerId="LiveId" clId="{1A4E8B3D-71E9-45CB-9AC9-58DE4384F4B0}" dt="2026-03-16T14:19:57.217" v="52" actId="20577"/>
         <pc:sldMkLst>
           <pc:docMk/>
           <pc:sldMk cId="0" sldId="259"/>
@@ -149,14 +196,219 @@
             <ac:spMk id="4" creationId="{00000000-0000-0000-0000-000000000000}"/>
           </ac:spMkLst>
         </pc:spChg>
+        <pc:spChg chg="mod">
+          <ac:chgData name="Yunus Emre Capar" userId="6e34af16be8e7db1" providerId="LiveId" clId="{1A4E8B3D-71E9-45CB-9AC9-58DE4384F4B0}" dt="2026-03-16T14:19:57.217" v="52" actId="20577"/>
+          <ac:spMkLst>
+            <pc:docMk/>
+            <pc:sldMk cId="0" sldId="259"/>
+            <ac:spMk id="40" creationId="{00000000-0000-0000-0000-000000000000}"/>
+          </ac:spMkLst>
+        </pc:spChg>
         <pc:graphicFrameChg chg="modGraphic">
-          <ac:chgData name="Yunus Emre Capar" userId="6e34af16be8e7db1" providerId="LiveId" clId="{1A4E8B3D-71E9-45CB-9AC9-58DE4384F4B0}" dt="2026-03-11T12:47:52.077" v="5" actId="20577"/>
+          <ac:chgData name="Yunus Emre Capar" userId="6e34af16be8e7db1" providerId="LiveId" clId="{1A4E8B3D-71E9-45CB-9AC9-58DE4384F4B0}" dt="2026-03-16T14:16:54.157" v="35" actId="20577"/>
           <ac:graphicFrameMkLst>
             <pc:docMk/>
             <pc:sldMk cId="0" sldId="259"/>
             <ac:graphicFrameMk id="43" creationId="{72C8AFF7-0E47-2678-2A01-53551B3BFD4D}"/>
           </ac:graphicFrameMkLst>
         </pc:graphicFrameChg>
+      </pc:sldChg>
+      <pc:sldChg chg="addSp modSp mod">
+        <pc:chgData name="Yunus Emre Capar" userId="6e34af16be8e7db1" providerId="LiveId" clId="{1A4E8B3D-71E9-45CB-9AC9-58DE4384F4B0}" dt="2026-03-16T14:35:12.892" v="120" actId="1076"/>
+        <pc:sldMkLst>
+          <pc:docMk/>
+          <pc:sldMk cId="0" sldId="260"/>
+        </pc:sldMkLst>
+        <pc:spChg chg="mod">
+          <ac:chgData name="Yunus Emre Capar" userId="6e34af16be8e7db1" providerId="LiveId" clId="{1A4E8B3D-71E9-45CB-9AC9-58DE4384F4B0}" dt="2026-03-16T14:21:53.047" v="57" actId="113"/>
+          <ac:spMkLst>
+            <pc:docMk/>
+            <pc:sldMk cId="0" sldId="260"/>
+            <ac:spMk id="4" creationId="{00000000-0000-0000-0000-000000000000}"/>
+          </ac:spMkLst>
+        </pc:spChg>
+        <pc:spChg chg="mod">
+          <ac:chgData name="Yunus Emre Capar" userId="6e34af16be8e7db1" providerId="LiveId" clId="{1A4E8B3D-71E9-45CB-9AC9-58DE4384F4B0}" dt="2026-03-16T14:22:18.328" v="61" actId="113"/>
+          <ac:spMkLst>
+            <pc:docMk/>
+            <pc:sldMk cId="0" sldId="260"/>
+            <ac:spMk id="6" creationId="{00000000-0000-0000-0000-000000000000}"/>
+          </ac:spMkLst>
+        </pc:spChg>
+        <pc:spChg chg="mod">
+          <ac:chgData name="Yunus Emre Capar" userId="6e34af16be8e7db1" providerId="LiveId" clId="{1A4E8B3D-71E9-45CB-9AC9-58DE4384F4B0}" dt="2026-03-16T14:22:43.560" v="67" actId="114"/>
+          <ac:spMkLst>
+            <pc:docMk/>
+            <pc:sldMk cId="0" sldId="260"/>
+            <ac:spMk id="7" creationId="{00000000-0000-0000-0000-000000000000}"/>
+          </ac:spMkLst>
+        </pc:spChg>
+        <pc:spChg chg="mod">
+          <ac:chgData name="Yunus Emre Capar" userId="6e34af16be8e7db1" providerId="LiveId" clId="{1A4E8B3D-71E9-45CB-9AC9-58DE4384F4B0}" dt="2026-03-16T14:23:02.738" v="71" actId="113"/>
+          <ac:spMkLst>
+            <pc:docMk/>
+            <pc:sldMk cId="0" sldId="260"/>
+            <ac:spMk id="8" creationId="{00000000-0000-0000-0000-000000000000}"/>
+          </ac:spMkLst>
+        </pc:spChg>
+        <pc:spChg chg="add">
+          <ac:chgData name="Yunus Emre Capar" userId="6e34af16be8e7db1" providerId="LiveId" clId="{1A4E8B3D-71E9-45CB-9AC9-58DE4384F4B0}" dt="2026-03-16T14:33:20.357" v="100"/>
+          <ac:spMkLst>
+            <pc:docMk/>
+            <pc:sldMk cId="0" sldId="260"/>
+            <ac:spMk id="9" creationId="{716DB9BF-E61B-0B72-971D-0E4362D36838}"/>
+          </ac:spMkLst>
+        </pc:spChg>
+        <pc:spChg chg="add mod">
+          <ac:chgData name="Yunus Emre Capar" userId="6e34af16be8e7db1" providerId="LiveId" clId="{1A4E8B3D-71E9-45CB-9AC9-58DE4384F4B0}" dt="2026-03-16T14:35:12.892" v="120" actId="1076"/>
+          <ac:spMkLst>
+            <pc:docMk/>
+            <pc:sldMk cId="0" sldId="260"/>
+            <ac:spMk id="10" creationId="{79CD0458-E099-CD06-A7F2-682930136BD9}"/>
+          </ac:spMkLst>
+        </pc:spChg>
+        <pc:spChg chg="add">
+          <ac:chgData name="Yunus Emre Capar" userId="6e34af16be8e7db1" providerId="LiveId" clId="{1A4E8B3D-71E9-45CB-9AC9-58DE4384F4B0}" dt="2026-03-16T14:34:02.880" v="107"/>
+          <ac:spMkLst>
+            <pc:docMk/>
+            <pc:sldMk cId="0" sldId="260"/>
+            <ac:spMk id="11" creationId="{32969947-47A5-C9DF-5601-FB78E71F78E2}"/>
+          </ac:spMkLst>
+        </pc:spChg>
+        <pc:spChg chg="add">
+          <ac:chgData name="Yunus Emre Capar" userId="6e34af16be8e7db1" providerId="LiveId" clId="{1A4E8B3D-71E9-45CB-9AC9-58DE4384F4B0}" dt="2026-03-16T14:34:08.112" v="108"/>
+          <ac:spMkLst>
+            <pc:docMk/>
+            <pc:sldMk cId="0" sldId="260"/>
+            <ac:spMk id="12" creationId="{C3D9BE1C-158E-064B-B65B-3FA22143984E}"/>
+          </ac:spMkLst>
+        </pc:spChg>
+        <pc:spChg chg="add">
+          <ac:chgData name="Yunus Emre Capar" userId="6e34af16be8e7db1" providerId="LiveId" clId="{1A4E8B3D-71E9-45CB-9AC9-58DE4384F4B0}" dt="2026-03-16T14:34:13.434" v="109"/>
+          <ac:spMkLst>
+            <pc:docMk/>
+            <pc:sldMk cId="0" sldId="260"/>
+            <ac:spMk id="13" creationId="{17C30343-4885-0C2C-7DC8-393DEB5F6AD4}"/>
+          </ac:spMkLst>
+        </pc:spChg>
+        <pc:spChg chg="add">
+          <ac:chgData name="Yunus Emre Capar" userId="6e34af16be8e7db1" providerId="LiveId" clId="{1A4E8B3D-71E9-45CB-9AC9-58DE4384F4B0}" dt="2026-03-16T14:34:17.971" v="111"/>
+          <ac:spMkLst>
+            <pc:docMk/>
+            <pc:sldMk cId="0" sldId="260"/>
+            <ac:spMk id="14" creationId="{34E41B34-0DEF-8CC8-52CB-0DE21030A91A}"/>
+          </ac:spMkLst>
+        </pc:spChg>
+        <pc:spChg chg="mod">
+          <ac:chgData name="Yunus Emre Capar" userId="6e34af16be8e7db1" providerId="LiveId" clId="{1A4E8B3D-71E9-45CB-9AC9-58DE4384F4B0}" dt="2026-03-16T14:31:31.243" v="89" actId="1076"/>
+          <ac:spMkLst>
+            <pc:docMk/>
+            <pc:sldMk cId="0" sldId="260"/>
+            <ac:spMk id="27" creationId="{00000000-0000-0000-0000-000000000000}"/>
+          </ac:spMkLst>
+        </pc:spChg>
+        <pc:graphicFrameChg chg="mod modGraphic">
+          <ac:chgData name="Yunus Emre Capar" userId="6e34af16be8e7db1" providerId="LiveId" clId="{1A4E8B3D-71E9-45CB-9AC9-58DE4384F4B0}" dt="2026-03-16T14:32:38.686" v="99"/>
+          <ac:graphicFrameMkLst>
+            <pc:docMk/>
+            <pc:sldMk cId="0" sldId="260"/>
+            <ac:graphicFrameMk id="29" creationId="{0258630A-265A-7FF7-9963-CB58F53B409B}"/>
+          </ac:graphicFrameMkLst>
+        </pc:graphicFrameChg>
+      </pc:sldChg>
+      <pc:sldChg chg="delSp modSp mod">
+        <pc:chgData name="Yunus Emre Capar" userId="6e34af16be8e7db1" providerId="LiveId" clId="{1A4E8B3D-71E9-45CB-9AC9-58DE4384F4B0}" dt="2026-03-16T14:44:30.449" v="179" actId="478"/>
+        <pc:sldMkLst>
+          <pc:docMk/>
+          <pc:sldMk cId="0" sldId="261"/>
+        </pc:sldMkLst>
+        <pc:spChg chg="mod">
+          <ac:chgData name="Yunus Emre Capar" userId="6e34af16be8e7db1" providerId="LiveId" clId="{1A4E8B3D-71E9-45CB-9AC9-58DE4384F4B0}" dt="2026-03-16T14:43:22.605" v="173" actId="255"/>
+          <ac:spMkLst>
+            <pc:docMk/>
+            <pc:sldMk cId="0" sldId="261"/>
+            <ac:spMk id="5" creationId="{00000000-0000-0000-0000-000000000000}"/>
+          </ac:spMkLst>
+        </pc:spChg>
+        <pc:spChg chg="mod">
+          <ac:chgData name="Yunus Emre Capar" userId="6e34af16be8e7db1" providerId="LiveId" clId="{1A4E8B3D-71E9-45CB-9AC9-58DE4384F4B0}" dt="2026-03-16T14:39:50.258" v="165"/>
+          <ac:spMkLst>
+            <pc:docMk/>
+            <pc:sldMk cId="0" sldId="261"/>
+            <ac:spMk id="33" creationId="{00000000-0000-0000-0000-000000000000}"/>
+          </ac:spMkLst>
+        </pc:spChg>
+        <pc:spChg chg="del mod">
+          <ac:chgData name="Yunus Emre Capar" userId="6e34af16be8e7db1" providerId="LiveId" clId="{1A4E8B3D-71E9-45CB-9AC9-58DE4384F4B0}" dt="2026-03-16T14:44:30.449" v="179" actId="478"/>
+          <ac:spMkLst>
+            <pc:docMk/>
+            <pc:sldMk cId="0" sldId="261"/>
+            <ac:spMk id="34" creationId="{00000000-0000-0000-0000-000000000000}"/>
+          </ac:spMkLst>
+        </pc:spChg>
+        <pc:spChg chg="mod">
+          <ac:chgData name="Yunus Emre Capar" userId="6e34af16be8e7db1" providerId="LiveId" clId="{1A4E8B3D-71E9-45CB-9AC9-58DE4384F4B0}" dt="2026-03-16T14:44:18.859" v="175"/>
+          <ac:spMkLst>
+            <pc:docMk/>
+            <pc:sldMk cId="0" sldId="261"/>
+            <ac:spMk id="35" creationId="{00000000-0000-0000-0000-000000000000}"/>
+          </ac:spMkLst>
+        </pc:spChg>
+        <pc:spChg chg="del mod">
+          <ac:chgData name="Yunus Emre Capar" userId="6e34af16be8e7db1" providerId="LiveId" clId="{1A4E8B3D-71E9-45CB-9AC9-58DE4384F4B0}" dt="2026-03-16T14:44:26.576" v="177" actId="478"/>
+          <ac:spMkLst>
+            <pc:docMk/>
+            <pc:sldMk cId="0" sldId="261"/>
+            <ac:spMk id="36" creationId="{00000000-0000-0000-0000-000000000000}"/>
+          </ac:spMkLst>
+        </pc:spChg>
+        <pc:graphicFrameChg chg="mod modGraphic">
+          <ac:chgData name="Yunus Emre Capar" userId="6e34af16be8e7db1" providerId="LiveId" clId="{1A4E8B3D-71E9-45CB-9AC9-58DE4384F4B0}" dt="2026-03-16T14:38:48.159" v="145" actId="122"/>
+          <ac:graphicFrameMkLst>
+            <pc:docMk/>
+            <pc:sldMk cId="0" sldId="261"/>
+            <ac:graphicFrameMk id="39" creationId="{5F474FA4-EF3E-A05F-CCCF-75A825666D37}"/>
+          </ac:graphicFrameMkLst>
+        </pc:graphicFrameChg>
+      </pc:sldChg>
+      <pc:sldChg chg="modSp mod">
+        <pc:chgData name="Yunus Emre Capar" userId="6e34af16be8e7db1" providerId="LiveId" clId="{1A4E8B3D-71E9-45CB-9AC9-58DE4384F4B0}" dt="2026-03-16T14:49:07.663" v="190"/>
+        <pc:sldMkLst>
+          <pc:docMk/>
+          <pc:sldMk cId="0" sldId="262"/>
+        </pc:sldMkLst>
+        <pc:spChg chg="mod">
+          <ac:chgData name="Yunus Emre Capar" userId="6e34af16be8e7db1" providerId="LiveId" clId="{1A4E8B3D-71E9-45CB-9AC9-58DE4384F4B0}" dt="2026-03-16T14:46:17.680" v="181" actId="20577"/>
+          <ac:spMkLst>
+            <pc:docMk/>
+            <pc:sldMk cId="0" sldId="262"/>
+            <ac:spMk id="5" creationId="{00000000-0000-0000-0000-000000000000}"/>
+          </ac:spMkLst>
+        </pc:spChg>
+        <pc:spChg chg="mod">
+          <ac:chgData name="Yunus Emre Capar" userId="6e34af16be8e7db1" providerId="LiveId" clId="{1A4E8B3D-71E9-45CB-9AC9-58DE4384F4B0}" dt="2026-03-16T14:46:30.943" v="188" actId="20577"/>
+          <ac:spMkLst>
+            <pc:docMk/>
+            <pc:sldMk cId="0" sldId="262"/>
+            <ac:spMk id="7" creationId="{00000000-0000-0000-0000-000000000000}"/>
+          </ac:spMkLst>
+        </pc:spChg>
+        <pc:spChg chg="mod">
+          <ac:chgData name="Yunus Emre Capar" userId="6e34af16be8e7db1" providerId="LiveId" clId="{1A4E8B3D-71E9-45CB-9AC9-58DE4384F4B0}" dt="2026-03-16T14:48:50.683" v="189"/>
+          <ac:spMkLst>
+            <pc:docMk/>
+            <pc:sldMk cId="0" sldId="262"/>
+            <ac:spMk id="8" creationId="{00000000-0000-0000-0000-000000000000}"/>
+          </ac:spMkLst>
+        </pc:spChg>
+        <pc:spChg chg="mod">
+          <ac:chgData name="Yunus Emre Capar" userId="6e34af16be8e7db1" providerId="LiveId" clId="{1A4E8B3D-71E9-45CB-9AC9-58DE4384F4B0}" dt="2026-03-16T14:49:07.663" v="190"/>
+          <ac:spMkLst>
+            <pc:docMk/>
+            <pc:sldMk cId="0" sldId="262"/>
+            <ac:spMk id="11" creationId="{00000000-0000-0000-0000-000000000000}"/>
+          </ac:spMkLst>
+        </pc:spChg>
       </pc:sldChg>
     </pc:docChg>
   </pc:docChgLst>
@@ -3579,23 +3831,12 @@
           <a:bodyPr wrap="square" lIns="0" tIns="0" rIns="0" bIns="0" rtlCol="0" anchor="ctr"/>
           <a:lstStyle/>
           <a:p>
-            <a:pPr marL="0" indent="0">
-              <a:buNone/>
-            </a:pPr>
-            <a:r>
-              <a:rPr lang="en-US" sz="2300" b="1" dirty="0">
-                <a:solidFill>
-                  <a:srgbClr val="24323A"/>
-                </a:solidFill>
-              </a:rPr>
-              <a:t>Samma flöde används i träning, validering, test och senare på </a:t>
-            </a:r>
-            <a:r>
-              <a:rPr lang="en-US" sz="2300" b="1" dirty="0" err="1">
-                <a:solidFill>
-                  <a:srgbClr val="24323A"/>
-                </a:solidFill>
-              </a:rPr>
+            <a:r>
+              <a:rPr lang="sv-SE" sz="2400" b="1" dirty="0"/>
+              <a:t>Samma pipeline används i CV, test och när vi kör </a:t>
+            </a:r>
+            <a:r>
+              <a:rPr lang="sv-SE" sz="2400" b="1" dirty="0" err="1"/>
               <a:t>new_data</a:t>
             </a:r>
             <a:r>
@@ -4093,7 +4334,7 @@
           <a:bodyPr/>
           <a:lstStyle/>
           <a:p>
-            <a:endParaRPr lang="en-SE"/>
+            <a:endParaRPr lang="en-SE" dirty="0"/>
           </a:p>
         </p:txBody>
       </p:sp>
@@ -4241,7 +4482,7 @@
                   <a:srgbClr val="24323A"/>
                 </a:solidFill>
               </a:rPr>
-              <a:t>+ CV/Test</a:t>
+              <a:t>+ (CV/Test)</a:t>
             </a:r>
             <a:endParaRPr lang="en-US" sz="1800" dirty="0"/>
           </a:p>
@@ -4424,6 +4665,17 @@
               <a:buChar char="•"/>
             </a:pPr>
             <a:r>
+              <a:rPr lang="en-US" sz="1600" dirty="0" err="1">
+                <a:solidFill>
+                  <a:srgbClr val="24323A"/>
+                </a:solidFill>
+                <a:latin typeface="Arial" pitchFamily="34" charset="0"/>
+                <a:ea typeface="Arial" pitchFamily="34" charset="-122"/>
+                <a:cs typeface="Arial" pitchFamily="34" charset="-120"/>
+              </a:rPr>
+              <a:t>Gör</a:t>
+            </a:r>
+            <a:r>
               <a:rPr lang="en-US" sz="1600" dirty="0">
                 <a:solidFill>
                   <a:srgbClr val="24323A"/>
@@ -4432,7 +4684,51 @@
                 <a:ea typeface="Arial" pitchFamily="34" charset="-122"/>
                 <a:cs typeface="Arial" pitchFamily="34" charset="-120"/>
               </a:rPr>
-              <a:t>Gör lösningen reproducerbar.</a:t>
+              <a:t> </a:t>
+            </a:r>
+            <a:r>
+              <a:rPr lang="en-US" sz="1600" dirty="0" err="1">
+                <a:solidFill>
+                  <a:srgbClr val="24323A"/>
+                </a:solidFill>
+                <a:latin typeface="Arial" pitchFamily="34" charset="0"/>
+                <a:ea typeface="Arial" pitchFamily="34" charset="-122"/>
+                <a:cs typeface="Arial" pitchFamily="34" charset="-120"/>
+              </a:rPr>
+              <a:t>lösningen</a:t>
+            </a:r>
+            <a:r>
+              <a:rPr lang="en-US" sz="1600" dirty="0">
+                <a:solidFill>
+                  <a:srgbClr val="24323A"/>
+                </a:solidFill>
+                <a:latin typeface="Arial" pitchFamily="34" charset="0"/>
+                <a:ea typeface="Arial" pitchFamily="34" charset="-122"/>
+                <a:cs typeface="Arial" pitchFamily="34" charset="-120"/>
+              </a:rPr>
+              <a:t> </a:t>
+            </a:r>
+            <a:r>
+              <a:rPr lang="en-US" sz="1600" dirty="0" err="1">
+                <a:solidFill>
+                  <a:srgbClr val="24323A"/>
+                </a:solidFill>
+                <a:latin typeface="Arial" pitchFamily="34" charset="0"/>
+                <a:ea typeface="Arial" pitchFamily="34" charset="-122"/>
+                <a:cs typeface="Arial" pitchFamily="34" charset="-120"/>
+              </a:rPr>
+              <a:t>reproducerbar</a:t>
+            </a:r>
+            <a:r>
+              <a:rPr lang="en-US" sz="1600" dirty="0">
+                <a:solidFill>
+                  <a:srgbClr val="24323A"/>
+                </a:solidFill>
+                <a:latin typeface="Arial" pitchFamily="34" charset="0"/>
+                <a:ea typeface="Arial" pitchFamily="34" charset="-122"/>
+                <a:cs typeface="Arial" pitchFamily="34" charset="-120"/>
+              </a:rPr>
+              <a:t>.</a:t>
             </a:r>
             <a:endParaRPr lang="en-US" sz="1600" dirty="0"/>
           </a:p>
@@ -4472,9 +4768,12 @@
                 <a:ea typeface="Arial" pitchFamily="34" charset="-122"/>
                 <a:cs typeface="Arial" pitchFamily="34" charset="-120"/>
               </a:rPr>
-              <a:t>Gör det enkelt att köra exakt samma flöde på new_data.</a:t>
-            </a:r>
-            <a:endParaRPr lang="en-US" sz="1600" dirty="0"/>
+              <a:t>Gör det enkelt att köra exakt samma flöde på </a:t>
+            </a:r>
+            <a:r>
+              <a:rPr lang="en-US" sz="1600" dirty="0"/>
+              <a:t>new_data.csv</a:t>
+            </a:r>
           </a:p>
         </p:txBody>
       </p:sp>
@@ -4946,7 +5245,7 @@
         <p:spPr>
           <a:xfrm>
             <a:off x="4315968" y="5038344"/>
-            <a:ext cx="5120640" cy="164592"/>
+            <a:ext cx="5120640" cy="398360"/>
           </a:xfrm>
           <a:prstGeom prst="rect">
             <a:avLst/>
@@ -4958,8 +5257,20 @@
           <a:bodyPr wrap="square" lIns="0" tIns="0" rIns="0" bIns="0" rtlCol="0" anchor="ctr"/>
           <a:lstStyle/>
           <a:p>
-            <a:pPr marL="0" indent="0">
-              <a:buNone/>
+            <a:pPr marL="171450" indent="-171450">
+              <a:buFont typeface="Arial" panose="020B0604020202020204" pitchFamily="34" charset="0"/>
+              <a:buChar char="•"/>
+            </a:pPr>
+            <a:endParaRPr lang="en-US" sz="1100" dirty="0">
+              <a:solidFill>
+                <a:srgbClr val="5F7078"/>
+              </a:solidFill>
+            </a:endParaRPr>
+          </a:p>
+          <a:p>
+            <a:pPr marL="171450" indent="-171450">
+              <a:buFont typeface="Arial" panose="020B0604020202020204" pitchFamily="34" charset="0"/>
+              <a:buChar char="•"/>
             </a:pPr>
             <a:r>
               <a:rPr lang="en-US" sz="1100" dirty="0">
@@ -4967,7 +5278,7 @@
                   <a:srgbClr val="5F7078"/>
                 </a:solidFill>
               </a:rPr>
-              <a:t>* Precision beror på vald threshold. I drift använder vi Top-X.</a:t>
+              <a:t>Precision beror på vald threshold. I drift använder vi Top-X</a:t>
             </a:r>
             <a:endParaRPr lang="en-US" sz="1100" dirty="0"/>
           </a:p>
@@ -5024,7 +5335,7 @@
           <p:nvPr>
             <p:extLst>
               <p:ext uri="{D42A27DB-BD31-4B8C-83A1-F6EECF244321}">
-                <p14:modId xmlns:p14="http://schemas.microsoft.com/office/powerpoint/2010/main" val="908140104"/>
+                <p14:modId xmlns:p14="http://schemas.microsoft.com/office/powerpoint/2010/main" val="1437058490"/>
               </p:ext>
             </p:extLst>
           </p:nvPr>
@@ -5382,10 +5693,9 @@
                             <a:srgbClr val="24323A"/>
                           </a:solidFill>
                           <a:latin typeface="Arial" pitchFamily="34" charset="0"/>
-                          <a:ea typeface="Arial" pitchFamily="34" charset="-122"/>
                           <a:cs typeface="Arial" pitchFamily="34" charset="-120"/>
                         </a:rPr>
-                        <a:t>–</a:t>
+                        <a:t>0.102</a:t>
                       </a:r>
                       <a:endParaRPr lang="en-US" sz="1800" dirty="0"/>
                     </a:p>
@@ -5941,18 +6251,27 @@
           <a:bodyPr wrap="square" lIns="0" tIns="0" rIns="0" bIns="0" rtlCol="0" anchor="ctr"/>
           <a:lstStyle/>
           <a:p>
-            <a:pPr marL="0" indent="0">
-              <a:buNone/>
-            </a:pPr>
+            <a:r>
+              <a:rPr lang="sv-SE" sz="2400" b="1" dirty="0"/>
+              <a:t>Vi finjusterade den valda modellen (</a:t>
+            </a:r>
+            <a:r>
+              <a:rPr lang="sv-SE" sz="2400" b="1" dirty="0" err="1"/>
+              <a:t>tuning</a:t>
+            </a:r>
+            <a:r>
+              <a:rPr lang="sv-SE" sz="2400" b="1" dirty="0"/>
+              <a:t>) utan att göra driften svår</a:t>
+            </a:r>
             <a:r>
               <a:rPr lang="en-US" sz="2200" b="1" dirty="0">
                 <a:solidFill>
                   <a:srgbClr val="24323A"/>
                 </a:solidFill>
               </a:rPr>
-              <a:t>Nästa steg är att finjustera den valda modellen utan att göra lösningen svår att drifta.</a:t>
-            </a:r>
-            <a:endParaRPr lang="en-US" sz="2200" dirty="0"/>
+              <a:t>.</a:t>
+            </a:r>
+            <a:endParaRPr lang="en-US" sz="2200" b="1" dirty="0"/>
           </a:p>
         </p:txBody>
       </p:sp>
@@ -6022,15 +6341,24 @@
               <a:buChar char="•"/>
             </a:pPr>
             <a:r>
-              <a:rPr lang="en-US" sz="1700" dirty="0">
-                <a:solidFill>
-                  <a:srgbClr val="24323A"/>
-                </a:solidFill>
-                <a:latin typeface="Arial" pitchFamily="34" charset="0"/>
-                <a:ea typeface="Arial" pitchFamily="34" charset="-122"/>
-                <a:cs typeface="Arial" pitchFamily="34" charset="-120"/>
-              </a:rPr>
-              <a:t>Tuning med GridSearchCV på 1–2 parametrar.</a:t>
+              <a:rPr lang="en-US" sz="1600" dirty="0"/>
+              <a:t>Tuning: </a:t>
+            </a:r>
+            <a:r>
+              <a:rPr lang="en-US" sz="1600" dirty="0" err="1"/>
+              <a:t>GridSearchCV</a:t>
+            </a:r>
+            <a:r>
+              <a:rPr lang="en-US" sz="1600" dirty="0"/>
+              <a:t> (</a:t>
+            </a:r>
+            <a:r>
+              <a:rPr lang="en-US" sz="1600" dirty="0" err="1"/>
+              <a:t>mål</a:t>
+            </a:r>
+            <a:r>
+              <a:rPr lang="en-US" sz="1600" dirty="0"/>
+              <a:t>: Average Precision / AP)</a:t>
             </a:r>
             <a:endParaRPr lang="en-US" sz="1700" dirty="0"/>
           </a:p>
@@ -6062,15 +6390,40 @@
               <a:buChar char="•"/>
             </a:pPr>
             <a:r>
-              <a:rPr lang="en-US" sz="1700" dirty="0">
-                <a:solidFill>
-                  <a:srgbClr val="24323A"/>
-                </a:solidFill>
-                <a:latin typeface="Arial" pitchFamily="34" charset="0"/>
-                <a:ea typeface="Arial" pitchFamily="34" charset="-122"/>
-                <a:cs typeface="Arial" pitchFamily="34" charset="-120"/>
-              </a:rPr>
-              <a:t>Planerade parametrar: C och eventuellt class_weight.</a:t>
+              <a:rPr lang="en-US" sz="1600" dirty="0" err="1"/>
+              <a:t>Bästa</a:t>
+            </a:r>
+            <a:r>
+              <a:rPr lang="en-US" sz="1600" dirty="0"/>
+              <a:t> </a:t>
+            </a:r>
+            <a:r>
+              <a:rPr lang="en-US" sz="1600" dirty="0" err="1"/>
+              <a:t>parametrar</a:t>
+            </a:r>
+            <a:r>
+              <a:rPr lang="en-US" sz="1600" dirty="0"/>
+              <a:t>: </a:t>
+            </a:r>
+            <a:r>
+              <a:rPr lang="en-US" dirty="0"/>
+              <a:t>C = 10</a:t>
+            </a:r>
+            <a:r>
+              <a:rPr lang="en-US" sz="1600" dirty="0"/>
+              <a:t>, </a:t>
+            </a:r>
+            <a:r>
+              <a:rPr lang="en-US" i="1" dirty="0" err="1"/>
+              <a:t>class_weight</a:t>
+            </a:r>
+            <a:r>
+              <a:rPr lang="en-US" i="1" dirty="0"/>
+              <a:t> </a:t>
+            </a:r>
+            <a:r>
+              <a:rPr lang="en-US" dirty="0"/>
+              <a:t>= None</a:t>
             </a:r>
             <a:endParaRPr lang="en-US" sz="1700" dirty="0"/>
           </a:p>
@@ -6102,15 +6455,12 @@
               <a:buChar char="•"/>
             </a:pPr>
             <a:r>
-              <a:rPr lang="en-US" sz="1700" dirty="0">
-                <a:solidFill>
-                  <a:srgbClr val="24323A"/>
-                </a:solidFill>
-                <a:latin typeface="Arial" pitchFamily="34" charset="0"/>
-                <a:ea typeface="Arial" pitchFamily="34" charset="-122"/>
-                <a:cs typeface="Arial" pitchFamily="34" charset="-120"/>
-              </a:rPr>
-              <a:t>Målet är bättre ranking och mer stabil kvalitet.</a:t>
+              <a:rPr lang="en-US" sz="1600" dirty="0" err="1"/>
+              <a:t>Resultat</a:t>
+            </a:r>
+            <a:r>
+              <a:rPr lang="en-US" sz="1600" dirty="0"/>
+              <a:t>: Best CV AP 0.284 → Test AP 0.276, Test ROC-AUC 0.740</a:t>
             </a:r>
             <a:endParaRPr lang="en-US" sz="1700" dirty="0"/>
           </a:p>
@@ -6124,8 +6474,8 @@
         </p:nvSpPr>
         <p:spPr>
           <a:xfrm>
-            <a:off x="4251960" y="5440680"/>
-            <a:ext cx="5943600" cy="201168"/>
+            <a:off x="4292301" y="6096069"/>
+            <a:ext cx="5897880" cy="496755"/>
           </a:xfrm>
           <a:prstGeom prst="rect">
             <a:avLst/>
@@ -6137,18 +6487,43 @@
           <a:bodyPr wrap="square" lIns="0" tIns="0" rIns="0" bIns="0" rtlCol="0" anchor="ctr"/>
           <a:lstStyle/>
           <a:p>
-            <a:pPr marL="0" indent="0">
-              <a:buNone/>
-            </a:pPr>
-            <a:r>
-              <a:rPr lang="en-US" sz="1250" i="1" dirty="0">
-                <a:solidFill>
-                  <a:srgbClr val="8A6A00"/>
-                </a:solidFill>
-              </a:rPr>
-              <a:t>Uppdatera denna slide med slutliga tuning-resultat innan redovisningen.</a:t>
-            </a:r>
-            <a:endParaRPr lang="en-US" sz="1250" dirty="0"/>
+            <a:r>
+              <a:rPr lang="sv-SE" sz="1100" dirty="0">
+                <a:solidFill>
+                  <a:schemeClr val="bg2">
+                    <a:lumMod val="25000"/>
+                  </a:schemeClr>
+                </a:solidFill>
+              </a:rPr>
+              <a:t>Vi </a:t>
+            </a:r>
+            <a:r>
+              <a:rPr lang="sv-SE" sz="1100" dirty="0" err="1">
+                <a:solidFill>
+                  <a:schemeClr val="bg2">
+                    <a:lumMod val="25000"/>
+                  </a:schemeClr>
+                </a:solidFill>
+              </a:rPr>
+              <a:t>tunade</a:t>
+            </a:r>
+            <a:r>
+              <a:rPr lang="sv-SE" sz="1100" dirty="0">
+                <a:solidFill>
+                  <a:schemeClr val="bg2">
+                    <a:lumMod val="25000"/>
+                  </a:schemeClr>
+                </a:solidFill>
+              </a:rPr>
+              <a:t> få parametrar för att hålla lösningen enkel att underhålla.</a:t>
+            </a:r>
+            <a:endParaRPr lang="en-US" sz="1100" dirty="0">
+              <a:solidFill>
+                <a:schemeClr val="bg2">
+                  <a:lumMod val="25000"/>
+                </a:schemeClr>
+              </a:solidFill>
+            </a:endParaRPr>
           </a:p>
         </p:txBody>
       </p:sp>
@@ -6203,14 +6578,14 @@
           <p:nvPr>
             <p:extLst>
               <p:ext uri="{D42A27DB-BD31-4B8C-83A1-F6EECF244321}">
-                <p14:modId xmlns:p14="http://schemas.microsoft.com/office/powerpoint/2010/main" val="1622214019"/>
+                <p14:modId xmlns:p14="http://schemas.microsoft.com/office/powerpoint/2010/main" val="696348534"/>
               </p:ext>
             </p:extLst>
           </p:nvPr>
         </p:nvGraphicFramePr>
         <p:xfrm>
-          <a:off x="4251961" y="3474721"/>
-          <a:ext cx="7660089" cy="1887440"/>
+          <a:off x="4297680" y="3528447"/>
+          <a:ext cx="6661207" cy="2539595"/>
         </p:xfrm>
         <a:graphic>
           <a:graphicData uri="http://schemas.openxmlformats.org/drawingml/2006/table">
@@ -6219,7 +6594,7 @@
                 <a:tableStyleId>{073A0DAA-6AF3-43AB-8588-CEC1D06C72B9}</a:tableStyleId>
               </a:tblPr>
               <a:tblGrid>
-                <a:gridCol w="2553363">
+                <a:gridCol w="1554481">
                   <a:extLst>
                     <a:ext uri="{9D8B030D-6E8A-4147-A177-3AD203B41FA5}">
                       <a16:colId xmlns:a16="http://schemas.microsoft.com/office/drawing/2014/main" val="1635972392"/>
@@ -6241,7 +6616,7 @@
                   </a:extLst>
                 </a:gridCol>
               </a:tblGrid>
-              <a:tr h="423948">
+              <a:tr h="422115">
                 <a:tc>
                   <a:txBody>
                     <a:bodyPr/>
@@ -6265,7 +6640,7 @@
                         <a:defRPr/>
                       </a:pPr>
                       <a:r>
-                        <a:rPr lang="en-US" sz="1800" b="1" dirty="0">
+                        <a:rPr lang="en-US" sz="1800" b="1">
                           <a:solidFill>
                             <a:srgbClr val="FFFFFF"/>
                           </a:solidFill>
@@ -6303,7 +6678,7 @@
                         <a:defRPr/>
                       </a:pPr>
                       <a:r>
-                        <a:rPr lang="en-US" sz="1800" b="1" dirty="0" err="1">
+                        <a:rPr lang="en-US" sz="1800" b="1">
                           <a:solidFill>
                             <a:srgbClr val="FFFFFF"/>
                           </a:solidFill>
@@ -6311,40 +6686,7 @@
                           <a:ea typeface="Arial" pitchFamily="34" charset="-122"/>
                           <a:cs typeface="Arial" pitchFamily="34" charset="-120"/>
                         </a:rPr>
-                        <a:t>Varför</a:t>
-                      </a:r>
-                      <a:r>
-                        <a:rPr lang="en-US" sz="1800" b="1" dirty="0">
-                          <a:solidFill>
-                            <a:srgbClr val="FFFFFF"/>
-                          </a:solidFill>
-                          <a:latin typeface="Arial" pitchFamily="34" charset="0"/>
-                          <a:ea typeface="Arial" pitchFamily="34" charset="-122"/>
-                          <a:cs typeface="Arial" pitchFamily="34" charset="-120"/>
-                        </a:rPr>
-                        <a:t> </a:t>
-                      </a:r>
-                      <a:r>
-                        <a:rPr lang="en-US" sz="1800" b="1" dirty="0" err="1">
-                          <a:solidFill>
-                            <a:srgbClr val="FFFFFF"/>
-                          </a:solidFill>
-                          <a:latin typeface="Arial" pitchFamily="34" charset="0"/>
-                          <a:ea typeface="Arial" pitchFamily="34" charset="-122"/>
-                          <a:cs typeface="Arial" pitchFamily="34" charset="-120"/>
-                        </a:rPr>
-                        <a:t>testas</a:t>
-                      </a:r>
-                      <a:r>
-                        <a:rPr lang="en-US" sz="1800" b="1" dirty="0">
-                          <a:solidFill>
-                            <a:srgbClr val="FFFFFF"/>
-                          </a:solidFill>
-                          <a:latin typeface="Arial" pitchFamily="34" charset="0"/>
-                          <a:ea typeface="Arial" pitchFamily="34" charset="-122"/>
-                          <a:cs typeface="Arial" pitchFamily="34" charset="-120"/>
-                        </a:rPr>
-                        <a:t> den?</a:t>
+                        <a:t>Varför testas den?</a:t>
                       </a:r>
                       <a:endParaRPr lang="en-US" sz="1800" dirty="0"/>
                     </a:p>
@@ -6374,15 +6716,8 @@
                         <a:defRPr/>
                       </a:pPr>
                       <a:r>
-                        <a:rPr lang="en-US" sz="1800" b="1" dirty="0">
-                          <a:solidFill>
-                            <a:srgbClr val="FFFFFF"/>
-                          </a:solidFill>
-                          <a:latin typeface="Arial" pitchFamily="34" charset="0"/>
-                          <a:ea typeface="Arial" pitchFamily="34" charset="-122"/>
-                          <a:cs typeface="Arial" pitchFamily="34" charset="-120"/>
-                        </a:rPr>
-                        <a:t>Status</a:t>
+                        <a:rPr lang="en-US" dirty="0"/>
+                        <a:t>Vald</a:t>
                       </a:r>
                       <a:endParaRPr lang="en-US" sz="1800" dirty="0"/>
                     </a:p>
@@ -6395,7 +6730,7 @@
                   </a:ext>
                 </a:extLst>
               </a:tr>
-              <a:tr h="731746">
+              <a:tr h="738700">
                 <a:tc>
                   <a:txBody>
                     <a:bodyPr/>
@@ -6419,7 +6754,7 @@
                         <a:defRPr/>
                       </a:pPr>
                       <a:r>
-                        <a:rPr lang="en-US" sz="1800" dirty="0">
+                        <a:rPr lang="en-US" sz="1800">
                           <a:solidFill>
                             <a:srgbClr val="24323A"/>
                           </a:solidFill>
@@ -6457,7 +6792,7 @@
                         <a:defRPr/>
                       </a:pPr>
                       <a:r>
-                        <a:rPr lang="en-US" sz="1800" dirty="0">
+                        <a:rPr lang="en-US" sz="1800">
                           <a:solidFill>
                             <a:srgbClr val="24323A"/>
                           </a:solidFill>
@@ -6465,95 +6800,7 @@
                           <a:ea typeface="Arial" pitchFamily="34" charset="-122"/>
                           <a:cs typeface="Arial" pitchFamily="34" charset="-120"/>
                         </a:rPr>
-                        <a:t>Styr </a:t>
-                      </a:r>
-                      <a:r>
-                        <a:rPr lang="en-US" sz="1800" dirty="0" err="1">
-                          <a:solidFill>
-                            <a:srgbClr val="24323A"/>
-                          </a:solidFill>
-                          <a:latin typeface="Arial" pitchFamily="34" charset="0"/>
-                          <a:ea typeface="Arial" pitchFamily="34" charset="-122"/>
-                          <a:cs typeface="Arial" pitchFamily="34" charset="-120"/>
-                        </a:rPr>
-                        <a:t>regularisering</a:t>
-                      </a:r>
-                      <a:r>
-                        <a:rPr lang="en-US" sz="1800" dirty="0">
-                          <a:solidFill>
-                            <a:srgbClr val="24323A"/>
-                          </a:solidFill>
-                          <a:latin typeface="Arial" pitchFamily="34" charset="0"/>
-                          <a:ea typeface="Arial" pitchFamily="34" charset="-122"/>
-                          <a:cs typeface="Arial" pitchFamily="34" charset="-120"/>
-                        </a:rPr>
-                        <a:t> / </a:t>
-                      </a:r>
-                      <a:r>
-                        <a:rPr lang="en-US" sz="1800" dirty="0" err="1">
-                          <a:solidFill>
-                            <a:srgbClr val="24323A"/>
-                          </a:solidFill>
-                          <a:latin typeface="Arial" pitchFamily="34" charset="0"/>
-                          <a:ea typeface="Arial" pitchFamily="34" charset="-122"/>
-                          <a:cs typeface="Arial" pitchFamily="34" charset="-120"/>
-                        </a:rPr>
-                        <a:t>hur</a:t>
-                      </a:r>
-                      <a:r>
-                        <a:rPr lang="en-US" sz="1800" dirty="0">
-                          <a:solidFill>
-                            <a:srgbClr val="24323A"/>
-                          </a:solidFill>
-                          <a:latin typeface="Arial" pitchFamily="34" charset="0"/>
-                          <a:ea typeface="Arial" pitchFamily="34" charset="-122"/>
-                          <a:cs typeface="Arial" pitchFamily="34" charset="-120"/>
-                        </a:rPr>
-                        <a:t> </a:t>
-                      </a:r>
-                      <a:r>
-                        <a:rPr lang="en-US" sz="1800" dirty="0" err="1">
-                          <a:solidFill>
-                            <a:srgbClr val="24323A"/>
-                          </a:solidFill>
-                          <a:latin typeface="Arial" pitchFamily="34" charset="0"/>
-                          <a:ea typeface="Arial" pitchFamily="34" charset="-122"/>
-                          <a:cs typeface="Arial" pitchFamily="34" charset="-120"/>
-                        </a:rPr>
-                        <a:t>flexibel</a:t>
-                      </a:r>
-                      <a:r>
-                        <a:rPr lang="en-US" sz="1800" dirty="0">
-                          <a:solidFill>
-                            <a:srgbClr val="24323A"/>
-                          </a:solidFill>
-                          <a:latin typeface="Arial" pitchFamily="34" charset="0"/>
-                          <a:ea typeface="Arial" pitchFamily="34" charset="-122"/>
-                          <a:cs typeface="Arial" pitchFamily="34" charset="-120"/>
-                        </a:rPr>
-                        <a:t> </a:t>
-                      </a:r>
-                      <a:r>
-                        <a:rPr lang="en-US" sz="1800" dirty="0" err="1">
-                          <a:solidFill>
-                            <a:srgbClr val="24323A"/>
-                          </a:solidFill>
-                          <a:latin typeface="Arial" pitchFamily="34" charset="0"/>
-                          <a:ea typeface="Arial" pitchFamily="34" charset="-122"/>
-                          <a:cs typeface="Arial" pitchFamily="34" charset="-120"/>
-                        </a:rPr>
-                        <a:t>modellen</a:t>
-                      </a:r>
-                      <a:r>
-                        <a:rPr lang="en-US" sz="1800" dirty="0">
-                          <a:solidFill>
-                            <a:srgbClr val="24323A"/>
-                          </a:solidFill>
-                          <a:latin typeface="Arial" pitchFamily="34" charset="0"/>
-                          <a:ea typeface="Arial" pitchFamily="34" charset="-122"/>
-                          <a:cs typeface="Arial" pitchFamily="34" charset="-120"/>
-                        </a:rPr>
-                        <a:t> är</a:t>
+                        <a:t>Styr regularisering / hur flexibel modellen är</a:t>
                       </a:r>
                       <a:endParaRPr lang="en-US" sz="1800" dirty="0"/>
                     </a:p>
@@ -6583,83 +6830,9 @@
                         <a:defRPr/>
                       </a:pPr>
                       <a:r>
-                        <a:rPr lang="en-US" sz="1800" dirty="0" err="1">
-                          <a:solidFill>
-                            <a:srgbClr val="24323A"/>
-                          </a:solidFill>
-                          <a:latin typeface="Arial" pitchFamily="34" charset="0"/>
-                          <a:ea typeface="Arial" pitchFamily="34" charset="-122"/>
-                          <a:cs typeface="Arial" pitchFamily="34" charset="-120"/>
-                        </a:rPr>
-                        <a:t>Fylls</a:t>
+                        <a:rPr lang="en-US" sz="1800" dirty="0"/>
+                        <a:t>10</a:t>
                       </a:r>
-                      <a:r>
-                        <a:rPr lang="en-US" sz="1800" dirty="0">
-                          <a:solidFill>
-                            <a:srgbClr val="24323A"/>
-                          </a:solidFill>
-                          <a:latin typeface="Arial" pitchFamily="34" charset="0"/>
-                          <a:ea typeface="Arial" pitchFamily="34" charset="-122"/>
-                          <a:cs typeface="Arial" pitchFamily="34" charset="-120"/>
-                        </a:rPr>
-                        <a:t> </a:t>
-                      </a:r>
-                      <a:r>
-                        <a:rPr lang="en-US" sz="1800" dirty="0" err="1">
-                          <a:solidFill>
-                            <a:srgbClr val="24323A"/>
-                          </a:solidFill>
-                          <a:latin typeface="Arial" pitchFamily="34" charset="0"/>
-                          <a:ea typeface="Arial" pitchFamily="34" charset="-122"/>
-                          <a:cs typeface="Arial" pitchFamily="34" charset="-120"/>
-                        </a:rPr>
-                        <a:t>i</a:t>
-                      </a:r>
-                      <a:r>
-                        <a:rPr lang="en-US" sz="1800" dirty="0">
-                          <a:solidFill>
-                            <a:srgbClr val="24323A"/>
-                          </a:solidFill>
-                          <a:latin typeface="Arial" pitchFamily="34" charset="0"/>
-                          <a:ea typeface="Arial" pitchFamily="34" charset="-122"/>
-                          <a:cs typeface="Arial" pitchFamily="34" charset="-120"/>
-                        </a:rPr>
-                        <a:t> </a:t>
-                      </a:r>
-                      <a:r>
-                        <a:rPr lang="en-US" sz="1800" dirty="0" err="1">
-                          <a:solidFill>
-                            <a:srgbClr val="24323A"/>
-                          </a:solidFill>
-                          <a:latin typeface="Arial" pitchFamily="34" charset="0"/>
-                          <a:ea typeface="Arial" pitchFamily="34" charset="-122"/>
-                          <a:cs typeface="Arial" pitchFamily="34" charset="-120"/>
-                        </a:rPr>
-                        <a:t>när</a:t>
-                      </a:r>
-                      <a:r>
-                        <a:rPr lang="en-US" sz="1800" dirty="0">
-                          <a:solidFill>
-                            <a:srgbClr val="24323A"/>
-                          </a:solidFill>
-                          <a:latin typeface="Arial" pitchFamily="34" charset="0"/>
-                          <a:ea typeface="Arial" pitchFamily="34" charset="-122"/>
-                          <a:cs typeface="Arial" pitchFamily="34" charset="-120"/>
-                        </a:rPr>
-                        <a:t> notebook 3 är </a:t>
-                      </a:r>
-                      <a:r>
-                        <a:rPr lang="en-US" sz="1800" dirty="0" err="1">
-                          <a:solidFill>
-                            <a:srgbClr val="24323A"/>
-                          </a:solidFill>
-                          <a:latin typeface="Arial" pitchFamily="34" charset="0"/>
-                          <a:ea typeface="Arial" pitchFamily="34" charset="-122"/>
-                          <a:cs typeface="Arial" pitchFamily="34" charset="-120"/>
-                        </a:rPr>
-                        <a:t>klar</a:t>
-                      </a:r>
-                      <a:endParaRPr lang="en-US" sz="1800" dirty="0"/>
                     </a:p>
                   </a:txBody>
                   <a:tcPr/>
@@ -6670,7 +6843,7 @@
                   </a:ext>
                 </a:extLst>
               </a:tr>
-              <a:tr h="731746">
+              <a:tr h="738700">
                 <a:tc>
                   <a:txBody>
                     <a:bodyPr/>
@@ -6694,7 +6867,7 @@
                         <a:defRPr/>
                       </a:pPr>
                       <a:r>
-                        <a:rPr lang="en-US" sz="1800" dirty="0" err="1">
+                        <a:rPr lang="en-US" sz="1800">
                           <a:solidFill>
                             <a:srgbClr val="24323A"/>
                           </a:solidFill>
@@ -6732,7 +6905,7 @@
                         <a:defRPr/>
                       </a:pPr>
                       <a:r>
-                        <a:rPr lang="en-US" sz="1800" dirty="0">
+                        <a:rPr lang="en-US" sz="1800">
                           <a:solidFill>
                             <a:srgbClr val="24323A"/>
                           </a:solidFill>
@@ -6740,51 +6913,7 @@
                           <a:ea typeface="Arial" pitchFamily="34" charset="-122"/>
                           <a:cs typeface="Arial" pitchFamily="34" charset="-120"/>
                         </a:rPr>
-                        <a:t>Kan </a:t>
-                      </a:r>
-                      <a:r>
-                        <a:rPr lang="en-US" sz="1800" dirty="0" err="1">
-                          <a:solidFill>
-                            <a:srgbClr val="24323A"/>
-                          </a:solidFill>
-                          <a:latin typeface="Arial" pitchFamily="34" charset="0"/>
-                          <a:ea typeface="Arial" pitchFamily="34" charset="-122"/>
-                          <a:cs typeface="Arial" pitchFamily="34" charset="-120"/>
-                        </a:rPr>
-                        <a:t>hjälpa</a:t>
-                      </a:r>
-                      <a:r>
-                        <a:rPr lang="en-US" sz="1800" dirty="0">
-                          <a:solidFill>
-                            <a:srgbClr val="24323A"/>
-                          </a:solidFill>
-                          <a:latin typeface="Arial" pitchFamily="34" charset="0"/>
-                          <a:ea typeface="Arial" pitchFamily="34" charset="-122"/>
-                          <a:cs typeface="Arial" pitchFamily="34" charset="-120"/>
-                        </a:rPr>
-                        <a:t> vid </a:t>
-                      </a:r>
-                      <a:r>
-                        <a:rPr lang="en-US" sz="1800" dirty="0" err="1">
-                          <a:solidFill>
-                            <a:srgbClr val="24323A"/>
-                          </a:solidFill>
-                          <a:latin typeface="Arial" pitchFamily="34" charset="0"/>
-                          <a:ea typeface="Arial" pitchFamily="34" charset="-122"/>
-                          <a:cs typeface="Arial" pitchFamily="34" charset="-120"/>
-                        </a:rPr>
-                        <a:t>obalanserad</a:t>
-                      </a:r>
-                      <a:r>
-                        <a:rPr lang="en-US" sz="1800" dirty="0">
-                          <a:solidFill>
-                            <a:srgbClr val="24323A"/>
-                          </a:solidFill>
-                          <a:latin typeface="Arial" pitchFamily="34" charset="0"/>
-                          <a:ea typeface="Arial" pitchFamily="34" charset="-122"/>
-                          <a:cs typeface="Arial" pitchFamily="34" charset="-120"/>
-                        </a:rPr>
-                        <a:t> target</a:t>
+                        <a:t>Kan hjälpa vid obalanserad target</a:t>
                       </a:r>
                       <a:endParaRPr lang="en-US" sz="1800" dirty="0"/>
                     </a:p>
@@ -6814,81 +6943,8 @@
                         <a:defRPr/>
                       </a:pPr>
                       <a:r>
-                        <a:rPr lang="en-US" sz="1800" dirty="0" err="1">
-                          <a:solidFill>
-                            <a:srgbClr val="24323A"/>
-                          </a:solidFill>
-                          <a:latin typeface="Arial" pitchFamily="34" charset="0"/>
-                          <a:ea typeface="Arial" pitchFamily="34" charset="-122"/>
-                          <a:cs typeface="Arial" pitchFamily="34" charset="-120"/>
-                        </a:rPr>
-                        <a:t>Fylls</a:t>
-                      </a:r>
-                      <a:r>
-                        <a:rPr lang="en-US" sz="1800" dirty="0">
-                          <a:solidFill>
-                            <a:srgbClr val="24323A"/>
-                          </a:solidFill>
-                          <a:latin typeface="Arial" pitchFamily="34" charset="0"/>
-                          <a:ea typeface="Arial" pitchFamily="34" charset="-122"/>
-                          <a:cs typeface="Arial" pitchFamily="34" charset="-120"/>
-                        </a:rPr>
-                        <a:t> </a:t>
-                      </a:r>
-                      <a:r>
-                        <a:rPr lang="en-US" sz="1800" dirty="0" err="1">
-                          <a:solidFill>
-                            <a:srgbClr val="24323A"/>
-                          </a:solidFill>
-                          <a:latin typeface="Arial" pitchFamily="34" charset="0"/>
-                          <a:ea typeface="Arial" pitchFamily="34" charset="-122"/>
-                          <a:cs typeface="Arial" pitchFamily="34" charset="-120"/>
-                        </a:rPr>
-                        <a:t>i</a:t>
-                      </a:r>
-                      <a:r>
-                        <a:rPr lang="en-US" sz="1800" dirty="0">
-                          <a:solidFill>
-                            <a:srgbClr val="24323A"/>
-                          </a:solidFill>
-                          <a:latin typeface="Arial" pitchFamily="34" charset="0"/>
-                          <a:ea typeface="Arial" pitchFamily="34" charset="-122"/>
-                          <a:cs typeface="Arial" pitchFamily="34" charset="-120"/>
-                        </a:rPr>
-                        <a:t> </a:t>
-                      </a:r>
-                      <a:r>
-                        <a:rPr lang="en-US" sz="1800" dirty="0" err="1">
-                          <a:solidFill>
-                            <a:srgbClr val="24323A"/>
-                          </a:solidFill>
-                          <a:latin typeface="Arial" pitchFamily="34" charset="0"/>
-                          <a:ea typeface="Arial" pitchFamily="34" charset="-122"/>
-                          <a:cs typeface="Arial" pitchFamily="34" charset="-120"/>
-                        </a:rPr>
-                        <a:t>när</a:t>
-                      </a:r>
-                      <a:r>
-                        <a:rPr lang="en-US" sz="1800" dirty="0">
-                          <a:solidFill>
-                            <a:srgbClr val="24323A"/>
-                          </a:solidFill>
-                          <a:latin typeface="Arial" pitchFamily="34" charset="0"/>
-                          <a:ea typeface="Arial" pitchFamily="34" charset="-122"/>
-                          <a:cs typeface="Arial" pitchFamily="34" charset="-120"/>
-                        </a:rPr>
-                        <a:t> notebook 3 är </a:t>
-                      </a:r>
-                      <a:r>
-                        <a:rPr lang="en-US" sz="1800" dirty="0" err="1">
-                          <a:solidFill>
-                            <a:srgbClr val="24323A"/>
-                          </a:solidFill>
-                          <a:latin typeface="Arial" pitchFamily="34" charset="0"/>
-                          <a:ea typeface="Arial" pitchFamily="34" charset="-122"/>
-                          <a:cs typeface="Arial" pitchFamily="34" charset="-120"/>
-                        </a:rPr>
-                        <a:t>klar</a:t>
+                        <a:rPr lang="en-US" dirty="0"/>
+                        <a:t>None</a:t>
                       </a:r>
                       <a:endParaRPr lang="en-US" sz="1800" dirty="0"/>
                     </a:p>
@@ -6901,10 +6957,173 @@
                   </a:ext>
                 </a:extLst>
               </a:tr>
+              <a:tr h="602296">
+                <a:tc>
+                  <a:txBody>
+                    <a:bodyPr/>
+                    <a:lstStyle/>
+                    <a:p>
+                      <a:pPr marL="0" marR="0" lvl="0" indent="0" algn="l" defTabSz="914400" rtl="0" eaLnBrk="1" fontAlgn="auto" latinLnBrk="0" hangingPunct="1">
+                        <a:lnSpc>
+                          <a:spcPct val="100000"/>
+                        </a:lnSpc>
+                        <a:spcBef>
+                          <a:spcPts val="0"/>
+                        </a:spcBef>
+                        <a:spcAft>
+                          <a:spcPts val="0"/>
+                        </a:spcAft>
+                        <a:buClrTx/>
+                        <a:buSzTx/>
+                        <a:buFontTx/>
+                        <a:buNone/>
+                        <a:tabLst/>
+                        <a:defRPr/>
+                      </a:pPr>
+                      <a:r>
+                        <a:rPr lang="en-US"/>
+                        <a:t>Metric</a:t>
+                      </a:r>
+                      <a:endParaRPr lang="en-US" sz="1800" dirty="0"/>
+                    </a:p>
+                  </a:txBody>
+                  <a:tcPr/>
+                </a:tc>
+                <a:tc>
+                  <a:txBody>
+                    <a:bodyPr/>
+                    <a:lstStyle/>
+                    <a:p>
+                      <a:pPr marL="0" marR="0" lvl="0" indent="0" algn="l" defTabSz="914400" rtl="0" eaLnBrk="1" fontAlgn="auto" latinLnBrk="0" hangingPunct="1">
+                        <a:lnSpc>
+                          <a:spcPct val="100000"/>
+                        </a:lnSpc>
+                        <a:spcBef>
+                          <a:spcPts val="0"/>
+                        </a:spcBef>
+                        <a:spcAft>
+                          <a:spcPts val="0"/>
+                        </a:spcAft>
+                        <a:buClrTx/>
+                        <a:buSzTx/>
+                        <a:buFontTx/>
+                        <a:buNone/>
+                        <a:tabLst/>
+                        <a:defRPr/>
+                      </a:pPr>
+                      <a:r>
+                        <a:rPr lang="sv-SE"/>
+                        <a:t>Vad vi optimerar i GridSearchCV</a:t>
+                      </a:r>
+                      <a:endParaRPr lang="en-US" sz="1800" dirty="0"/>
+                    </a:p>
+                  </a:txBody>
+                  <a:tcPr/>
+                </a:tc>
+                <a:tc>
+                  <a:txBody>
+                    <a:bodyPr/>
+                    <a:lstStyle/>
+                    <a:p>
+                      <a:pPr marL="0" marR="0" lvl="0" indent="0" algn="l" defTabSz="914400" rtl="0" eaLnBrk="1" fontAlgn="auto" latinLnBrk="0" hangingPunct="1">
+                        <a:lnSpc>
+                          <a:spcPct val="100000"/>
+                        </a:lnSpc>
+                        <a:spcBef>
+                          <a:spcPts val="0"/>
+                        </a:spcBef>
+                        <a:spcAft>
+                          <a:spcPts val="0"/>
+                        </a:spcAft>
+                        <a:buClrTx/>
+                        <a:buSzTx/>
+                        <a:buFontTx/>
+                        <a:buNone/>
+                        <a:tabLst/>
+                        <a:defRPr/>
+                      </a:pPr>
+                      <a:r>
+                        <a:rPr lang="en-US" dirty="0"/>
+                        <a:t>Average Precision (AP)</a:t>
+                      </a:r>
+                      <a:endParaRPr lang="en-US" sz="1800" dirty="0"/>
+                    </a:p>
+                  </a:txBody>
+                  <a:tcPr/>
+                </a:tc>
+                <a:extLst>
+                  <a:ext uri="{0D108BD9-81ED-4DB2-BD59-A6C34878D82A}">
+                    <a16:rowId xmlns:a16="http://schemas.microsoft.com/office/drawing/2014/main" val="2229036348"/>
+                  </a:ext>
+                </a:extLst>
+              </a:tr>
             </a:tbl>
           </a:graphicData>
         </a:graphic>
       </p:graphicFrame>
+      <p:sp>
+        <p:nvSpPr>
+          <p:cNvPr id="10" name="Text 25">
+            <a:extLst>
+              <a:ext uri="{FF2B5EF4-FFF2-40B4-BE49-F238E27FC236}">
+                <a16:creationId xmlns:a16="http://schemas.microsoft.com/office/drawing/2014/main" id="{79CD0458-E099-CD06-A7F2-682930136BD9}"/>
+              </a:ext>
+            </a:extLst>
+          </p:cNvPr>
+          <p:cNvSpPr/>
+          <p:nvPr/>
+        </p:nvSpPr>
+        <p:spPr>
+          <a:xfrm>
+            <a:off x="430306" y="3528447"/>
+            <a:ext cx="3246120" cy="985417"/>
+          </a:xfrm>
+          <a:prstGeom prst="rect">
+            <a:avLst/>
+          </a:prstGeom>
+          <a:noFill/>
+          <a:ln/>
+        </p:spPr>
+        <p:txBody>
+          <a:bodyPr wrap="square" lIns="0" tIns="0" rIns="0" bIns="0" rtlCol="0" anchor="ctr"/>
+          <a:lstStyle/>
+          <a:p>
+            <a:pPr marL="171450" indent="-171450">
+              <a:buFont typeface="Arial" panose="020B0604020202020204" pitchFamily="34" charset="0"/>
+              <a:buChar char="•"/>
+            </a:pPr>
+            <a:r>
+              <a:rPr lang="en-US" sz="1400" b="1" dirty="0"/>
+              <a:t>Best CV AP:</a:t>
+            </a:r>
+            <a:r>
+              <a:rPr lang="en-US" sz="1400" dirty="0"/>
+              <a:t> 0.284</a:t>
+            </a:r>
+          </a:p>
+          <a:p>
+            <a:pPr marL="171450" indent="-171450">
+              <a:buFont typeface="Arial" panose="020B0604020202020204" pitchFamily="34" charset="0"/>
+              <a:buChar char="•"/>
+            </a:pPr>
+            <a:r>
+              <a:rPr lang="en-US" sz="1400" b="1" dirty="0"/>
+              <a:t>Test AP / ROC-AUC:</a:t>
+            </a:r>
+            <a:r>
+              <a:rPr lang="en-US" sz="1400" dirty="0"/>
+              <a:t> 0.276 / 0.740</a:t>
+            </a:r>
+            <a:endParaRPr lang="en-US" sz="1400" dirty="0">
+              <a:solidFill>
+                <a:schemeClr val="bg2">
+                  <a:lumMod val="25000"/>
+                </a:schemeClr>
+              </a:solidFill>
+            </a:endParaRPr>
+          </a:p>
+        </p:txBody>
+      </p:sp>
     </p:spTree>
   </p:cSld>
   <p:clrMapOvr>
@@ -7097,33 +7316,30 @@
               <a:buChar char="•"/>
             </a:pPr>
             <a:r>
-              <a:rPr lang="en-US" sz="1550" dirty="0">
-                <a:solidFill>
-                  <a:srgbClr val="24323A"/>
-                </a:solidFill>
-                <a:latin typeface="Arial" pitchFamily="34" charset="0"/>
+              <a:rPr lang="en-US" sz="1400" dirty="0">
+                <a:solidFill>
+                  <a:srgbClr val="24323A"/>
+                </a:solidFill>
                 <a:ea typeface="Arial" pitchFamily="34" charset="-122"/>
                 <a:cs typeface="Arial" pitchFamily="34" charset="-120"/>
               </a:rPr>
               <a:t>Ali vill ha en hanterbar mängd som är värd att </a:t>
             </a:r>
             <a:r>
-              <a:rPr lang="en-US" sz="1550" dirty="0" err="1">
-                <a:solidFill>
-                  <a:srgbClr val="24323A"/>
-                </a:solidFill>
-                <a:latin typeface="Arial" pitchFamily="34" charset="0"/>
+              <a:rPr lang="en-US" sz="1400" dirty="0" err="1">
+                <a:solidFill>
+                  <a:srgbClr val="24323A"/>
+                </a:solidFill>
                 <a:ea typeface="Arial" pitchFamily="34" charset="-122"/>
                 <a:cs typeface="Arial" pitchFamily="34" charset="-120"/>
               </a:rPr>
               <a:t>granska</a:t>
             </a:r>
             <a:r>
-              <a:rPr lang="en-US" sz="1550" dirty="0">
-                <a:solidFill>
-                  <a:srgbClr val="24323A"/>
-                </a:solidFill>
-                <a:latin typeface="Arial" pitchFamily="34" charset="0"/>
+              <a:rPr lang="en-US" sz="1400" dirty="0">
+                <a:solidFill>
+                  <a:srgbClr val="24323A"/>
+                </a:solidFill>
                 <a:ea typeface="Arial" pitchFamily="34" charset="-122"/>
                 <a:cs typeface="Arial" pitchFamily="34" charset="-120"/>
               </a:rPr>
@@ -7135,11 +7351,10 @@
               <a:buSzPct val="100000"/>
               <a:buChar char="•"/>
             </a:pPr>
-            <a:endParaRPr lang="en-US" sz="1550" dirty="0">
+            <a:endParaRPr lang="en-US" sz="1400" dirty="0">
               <a:solidFill>
                 <a:srgbClr val="24323A"/>
               </a:solidFill>
-              <a:latin typeface="Arial" pitchFamily="34" charset="0"/>
               <a:ea typeface="Arial" pitchFamily="34" charset="-122"/>
               <a:cs typeface="Arial" pitchFamily="34" charset="-120"/>
             </a:endParaRPr>
@@ -7151,143 +7366,130 @@
               <a:buChar char="•"/>
             </a:pPr>
             <a:r>
-              <a:rPr lang="en-US" sz="1550" dirty="0">
-                <a:solidFill>
-                  <a:srgbClr val="24323A"/>
-                </a:solidFill>
-                <a:latin typeface="Arial" pitchFamily="34" charset="0"/>
+              <a:rPr lang="en-US" sz="1400" dirty="0">
+                <a:solidFill>
+                  <a:srgbClr val="24323A"/>
+                </a:solidFill>
                 <a:ea typeface="Arial" pitchFamily="34" charset="-122"/>
                 <a:cs typeface="Arial" pitchFamily="34" charset="-120"/>
               </a:rPr>
               <a:t>Vi </a:t>
             </a:r>
             <a:r>
-              <a:rPr lang="en-US" sz="1550" dirty="0" err="1">
-                <a:solidFill>
-                  <a:srgbClr val="24323A"/>
-                </a:solidFill>
-                <a:latin typeface="Arial" pitchFamily="34" charset="0"/>
+              <a:rPr lang="en-US" sz="1400" dirty="0" err="1">
+                <a:solidFill>
+                  <a:srgbClr val="24323A"/>
+                </a:solidFill>
                 <a:ea typeface="Arial" pitchFamily="34" charset="-122"/>
                 <a:cs typeface="Arial" pitchFamily="34" charset="-120"/>
               </a:rPr>
               <a:t>sorterar</a:t>
             </a:r>
             <a:r>
-              <a:rPr lang="en-US" sz="1550" dirty="0">
-                <a:solidFill>
-                  <a:srgbClr val="24323A"/>
-                </a:solidFill>
-                <a:latin typeface="Arial" pitchFamily="34" charset="0"/>
+              <a:rPr lang="en-US" sz="1400" dirty="0">
+                <a:solidFill>
+                  <a:srgbClr val="24323A"/>
+                </a:solidFill>
                 <a:ea typeface="Arial" pitchFamily="34" charset="-122"/>
                 <a:cs typeface="Arial" pitchFamily="34" charset="-120"/>
               </a:rPr>
               <a:t> </a:t>
             </a:r>
             <a:r>
-              <a:rPr lang="en-US" sz="1550" dirty="0" err="1">
-                <a:solidFill>
-                  <a:srgbClr val="24323A"/>
-                </a:solidFill>
-                <a:latin typeface="Arial" pitchFamily="34" charset="0"/>
+              <a:rPr lang="en-US" sz="1400" dirty="0" err="1">
+                <a:solidFill>
+                  <a:srgbClr val="24323A"/>
+                </a:solidFill>
                 <a:ea typeface="Arial" pitchFamily="34" charset="-122"/>
                 <a:cs typeface="Arial" pitchFamily="34" charset="-120"/>
               </a:rPr>
               <a:t>efter</a:t>
             </a:r>
             <a:r>
-              <a:rPr lang="en-US" sz="1550" dirty="0">
-                <a:solidFill>
-                  <a:srgbClr val="24323A"/>
-                </a:solidFill>
-                <a:latin typeface="Arial" pitchFamily="34" charset="0"/>
+              <a:rPr lang="en-US" sz="1400" dirty="0">
+                <a:solidFill>
+                  <a:srgbClr val="24323A"/>
+                </a:solidFill>
                 <a:ea typeface="Arial" pitchFamily="34" charset="-122"/>
                 <a:cs typeface="Arial" pitchFamily="34" charset="-120"/>
               </a:rPr>
               <a:t> </a:t>
             </a:r>
             <a:r>
-              <a:rPr lang="en-US" sz="1550" dirty="0" err="1">
-                <a:solidFill>
-                  <a:srgbClr val="24323A"/>
-                </a:solidFill>
-                <a:latin typeface="Arial" pitchFamily="34" charset="0"/>
+              <a:rPr lang="en-US" sz="1400" dirty="0" err="1">
+                <a:solidFill>
+                  <a:srgbClr val="24323A"/>
+                </a:solidFill>
                 <a:ea typeface="Arial" pitchFamily="34" charset="-122"/>
                 <a:cs typeface="Arial" pitchFamily="34" charset="-120"/>
               </a:rPr>
               <a:t>riskpoäng</a:t>
             </a:r>
             <a:r>
-              <a:rPr lang="en-US" sz="1550" dirty="0">
-                <a:solidFill>
-                  <a:srgbClr val="24323A"/>
-                </a:solidFill>
-                <a:latin typeface="Arial" pitchFamily="34" charset="0"/>
+              <a:rPr lang="en-US" sz="1400" dirty="0">
+                <a:solidFill>
+                  <a:srgbClr val="24323A"/>
+                </a:solidFill>
                 <a:ea typeface="Arial" pitchFamily="34" charset="-122"/>
                 <a:cs typeface="Arial" pitchFamily="34" charset="-120"/>
               </a:rPr>
               <a:t> och </a:t>
             </a:r>
             <a:r>
-              <a:rPr lang="en-US" sz="1550" dirty="0" err="1">
-                <a:solidFill>
-                  <a:srgbClr val="24323A"/>
-                </a:solidFill>
-                <a:latin typeface="Arial" pitchFamily="34" charset="0"/>
+              <a:rPr lang="en-US" sz="1400" dirty="0" err="1">
+                <a:solidFill>
+                  <a:srgbClr val="24323A"/>
+                </a:solidFill>
                 <a:ea typeface="Arial" pitchFamily="34" charset="-122"/>
                 <a:cs typeface="Arial" pitchFamily="34" charset="-120"/>
               </a:rPr>
               <a:t>skickar</a:t>
             </a:r>
             <a:r>
-              <a:rPr lang="en-US" sz="1550" dirty="0">
-                <a:solidFill>
-                  <a:srgbClr val="24323A"/>
-                </a:solidFill>
-                <a:latin typeface="Arial" pitchFamily="34" charset="0"/>
+              <a:rPr lang="en-US" sz="1400" dirty="0">
+                <a:solidFill>
+                  <a:srgbClr val="24323A"/>
+                </a:solidFill>
                 <a:ea typeface="Arial" pitchFamily="34" charset="-122"/>
                 <a:cs typeface="Arial" pitchFamily="34" charset="-120"/>
               </a:rPr>
               <a:t> bara de X% </a:t>
             </a:r>
             <a:r>
-              <a:rPr lang="en-US" sz="1550" dirty="0" err="1">
-                <a:solidFill>
-                  <a:srgbClr val="24323A"/>
-                </a:solidFill>
-                <a:latin typeface="Arial" pitchFamily="34" charset="0"/>
+              <a:rPr lang="en-US" sz="1400" dirty="0" err="1">
+                <a:solidFill>
+                  <a:srgbClr val="24323A"/>
+                </a:solidFill>
                 <a:ea typeface="Arial" pitchFamily="34" charset="-122"/>
                 <a:cs typeface="Arial" pitchFamily="34" charset="-120"/>
               </a:rPr>
               <a:t>högst</a:t>
             </a:r>
             <a:r>
-              <a:rPr lang="en-US" sz="1550" dirty="0">
-                <a:solidFill>
-                  <a:srgbClr val="24323A"/>
-                </a:solidFill>
-                <a:latin typeface="Arial" pitchFamily="34" charset="0"/>
+              <a:rPr lang="en-US" sz="1400" dirty="0">
+                <a:solidFill>
+                  <a:srgbClr val="24323A"/>
+                </a:solidFill>
                 <a:ea typeface="Arial" pitchFamily="34" charset="-122"/>
                 <a:cs typeface="Arial" pitchFamily="34" charset="-120"/>
               </a:rPr>
               <a:t> risk till </a:t>
             </a:r>
             <a:r>
-              <a:rPr lang="en-US" sz="1550" dirty="0" err="1">
-                <a:solidFill>
-                  <a:srgbClr val="24323A"/>
-                </a:solidFill>
-                <a:latin typeface="Arial" pitchFamily="34" charset="0"/>
+              <a:rPr lang="en-US" sz="1400" dirty="0" err="1">
+                <a:solidFill>
+                  <a:srgbClr val="24323A"/>
+                </a:solidFill>
                 <a:ea typeface="Arial" pitchFamily="34" charset="-122"/>
                 <a:cs typeface="Arial" pitchFamily="34" charset="-120"/>
               </a:rPr>
               <a:t>granskning</a:t>
             </a:r>
             <a:r>
-              <a:rPr lang="en-US" sz="1550" dirty="0">
-                <a:solidFill>
-                  <a:srgbClr val="24323A"/>
-                </a:solidFill>
-                <a:latin typeface="Arial" pitchFamily="34" charset="0"/>
+              <a:rPr lang="en-US" sz="1400" dirty="0">
+                <a:solidFill>
+                  <a:srgbClr val="24323A"/>
+                </a:solidFill>
                 <a:ea typeface="Arial" pitchFamily="34" charset="-122"/>
                 <a:cs typeface="Arial" pitchFamily="34" charset="-120"/>
               </a:rPr>
@@ -7300,11 +7502,10 @@
               <a:buFontTx/>
               <a:buChar char="•"/>
             </a:pPr>
-            <a:endParaRPr lang="en-US" sz="1550" dirty="0">
+            <a:endParaRPr lang="en-US" sz="1400" dirty="0">
               <a:solidFill>
                 <a:srgbClr val="24323A"/>
               </a:solidFill>
-              <a:latin typeface="Arial" pitchFamily="34" charset="0"/>
               <a:ea typeface="Arial" pitchFamily="34" charset="-122"/>
               <a:cs typeface="Arial" pitchFamily="34" charset="-120"/>
             </a:endParaRPr>
@@ -7316,99 +7517,90 @@
               <a:buChar char="•"/>
             </a:pPr>
             <a:r>
-              <a:rPr lang="en-US" sz="1550" dirty="0">
-                <a:solidFill>
-                  <a:srgbClr val="24323A"/>
-                </a:solidFill>
-                <a:latin typeface="Arial" pitchFamily="34" charset="0"/>
+              <a:rPr lang="en-US" sz="1400" dirty="0">
+                <a:solidFill>
+                  <a:srgbClr val="24323A"/>
+                </a:solidFill>
                 <a:ea typeface="Arial" pitchFamily="34" charset="-122"/>
                 <a:cs typeface="Arial" pitchFamily="34" charset="-120"/>
               </a:rPr>
               <a:t>Vi </a:t>
             </a:r>
             <a:r>
-              <a:rPr lang="en-US" sz="1550" dirty="0" err="1">
-                <a:solidFill>
-                  <a:srgbClr val="24323A"/>
-                </a:solidFill>
-                <a:latin typeface="Arial" pitchFamily="34" charset="0"/>
+              <a:rPr lang="en-US" sz="1400" dirty="0" err="1">
+                <a:solidFill>
+                  <a:srgbClr val="24323A"/>
+                </a:solidFill>
                 <a:ea typeface="Arial" pitchFamily="34" charset="-122"/>
                 <a:cs typeface="Arial" pitchFamily="34" charset="-120"/>
               </a:rPr>
               <a:t>jämför</a:t>
             </a:r>
             <a:r>
-              <a:rPr lang="en-US" sz="1550" dirty="0">
-                <a:solidFill>
-                  <a:srgbClr val="24323A"/>
-                </a:solidFill>
-                <a:latin typeface="Arial" pitchFamily="34" charset="0"/>
+              <a:rPr lang="en-US" sz="1400" dirty="0">
+                <a:solidFill>
+                  <a:srgbClr val="24323A"/>
+                </a:solidFill>
                 <a:ea typeface="Arial" pitchFamily="34" charset="-122"/>
                 <a:cs typeface="Arial" pitchFamily="34" charset="-120"/>
               </a:rPr>
               <a:t> top 3%, 5% och 10% </a:t>
             </a:r>
             <a:r>
-              <a:rPr lang="en-US" sz="1550" dirty="0" err="1">
-                <a:solidFill>
-                  <a:srgbClr val="24323A"/>
-                </a:solidFill>
-                <a:latin typeface="Arial" pitchFamily="34" charset="0"/>
+              <a:rPr lang="en-US" sz="1400" dirty="0" err="1">
+                <a:solidFill>
+                  <a:srgbClr val="24323A"/>
+                </a:solidFill>
                 <a:ea typeface="Arial" pitchFamily="34" charset="-122"/>
                 <a:cs typeface="Arial" pitchFamily="34" charset="-120"/>
               </a:rPr>
               <a:t>utifrån</a:t>
             </a:r>
             <a:r>
-              <a:rPr lang="en-US" sz="1550" dirty="0">
-                <a:solidFill>
-                  <a:srgbClr val="24323A"/>
-                </a:solidFill>
-                <a:latin typeface="Arial" pitchFamily="34" charset="0"/>
+              <a:rPr lang="en-US" sz="1400" dirty="0">
+                <a:solidFill>
+                  <a:srgbClr val="24323A"/>
+                </a:solidFill>
                 <a:ea typeface="Arial" pitchFamily="34" charset="-122"/>
                 <a:cs typeface="Arial" pitchFamily="34" charset="-120"/>
               </a:rPr>
               <a:t> </a:t>
             </a:r>
             <a:r>
-              <a:rPr lang="en-US" sz="1550" dirty="0" err="1">
-                <a:solidFill>
-                  <a:srgbClr val="24323A"/>
-                </a:solidFill>
-                <a:latin typeface="Arial" pitchFamily="34" charset="0"/>
+              <a:rPr lang="en-US" sz="1400" dirty="0" err="1">
+                <a:solidFill>
+                  <a:srgbClr val="24323A"/>
+                </a:solidFill>
                 <a:ea typeface="Arial" pitchFamily="34" charset="-122"/>
                 <a:cs typeface="Arial" pitchFamily="34" charset="-120"/>
               </a:rPr>
               <a:t>antal</a:t>
             </a:r>
             <a:r>
-              <a:rPr lang="en-US" sz="1550" dirty="0">
-                <a:solidFill>
-                  <a:srgbClr val="24323A"/>
-                </a:solidFill>
-                <a:latin typeface="Arial" pitchFamily="34" charset="0"/>
+              <a:rPr lang="en-US" sz="1400" dirty="0">
+                <a:solidFill>
+                  <a:srgbClr val="24323A"/>
+                </a:solidFill>
                 <a:ea typeface="Arial" pitchFamily="34" charset="-122"/>
                 <a:cs typeface="Arial" pitchFamily="34" charset="-120"/>
               </a:rPr>
               <a:t> </a:t>
             </a:r>
             <a:r>
-              <a:rPr lang="en-US" sz="1550" dirty="0" err="1">
-                <a:solidFill>
-                  <a:srgbClr val="24323A"/>
-                </a:solidFill>
-                <a:latin typeface="Arial" pitchFamily="34" charset="0"/>
+              <a:rPr lang="en-US" sz="1400" dirty="0" err="1">
+                <a:solidFill>
+                  <a:srgbClr val="24323A"/>
+                </a:solidFill>
                 <a:ea typeface="Arial" pitchFamily="34" charset="-122"/>
                 <a:cs typeface="Arial" pitchFamily="34" charset="-120"/>
               </a:rPr>
               <a:t>flaggade</a:t>
             </a:r>
             <a:r>
-              <a:rPr lang="en-US" sz="1550" dirty="0">
-                <a:solidFill>
-                  <a:srgbClr val="24323A"/>
-                </a:solidFill>
-                <a:latin typeface="Arial" pitchFamily="34" charset="0"/>
+              <a:rPr lang="en-US" sz="1400" dirty="0">
+                <a:solidFill>
+                  <a:srgbClr val="24323A"/>
+                </a:solidFill>
                 <a:ea typeface="Arial" pitchFamily="34" charset="-122"/>
                 <a:cs typeface="Arial" pitchFamily="34" charset="-120"/>
               </a:rPr>
@@ -7421,11 +7613,10 @@
               <a:buFontTx/>
               <a:buChar char="•"/>
             </a:pPr>
-            <a:endParaRPr lang="en-US" sz="1550" dirty="0">
+            <a:endParaRPr lang="en-US" sz="1400" dirty="0">
               <a:solidFill>
                 <a:srgbClr val="24323A"/>
               </a:solidFill>
-              <a:latin typeface="Arial" pitchFamily="34" charset="0"/>
               <a:ea typeface="Arial" pitchFamily="34" charset="-122"/>
               <a:cs typeface="Arial" pitchFamily="34" charset="-120"/>
             </a:endParaRPr>
@@ -7437,105 +7628,20 @@
               <a:buChar char="•"/>
             </a:pPr>
             <a:r>
-              <a:rPr lang="en-US" sz="1550" dirty="0">
-                <a:solidFill>
-                  <a:srgbClr val="24323A"/>
-                </a:solidFill>
-                <a:latin typeface="Arial" pitchFamily="34" charset="0"/>
-                <a:ea typeface="Arial" pitchFamily="34" charset="-122"/>
-                <a:cs typeface="Arial" pitchFamily="34" charset="-120"/>
-              </a:rPr>
-              <a:t>Detta </a:t>
-            </a:r>
-            <a:r>
-              <a:rPr lang="en-US" sz="1550" dirty="0" err="1">
-                <a:solidFill>
-                  <a:srgbClr val="24323A"/>
-                </a:solidFill>
-                <a:latin typeface="Arial" pitchFamily="34" charset="0"/>
-                <a:ea typeface="Arial" pitchFamily="34" charset="-122"/>
-                <a:cs typeface="Arial" pitchFamily="34" charset="-120"/>
-              </a:rPr>
-              <a:t>hjälper</a:t>
-            </a:r>
-            <a:r>
-              <a:rPr lang="en-US" sz="1550" dirty="0">
-                <a:solidFill>
-                  <a:srgbClr val="24323A"/>
-                </a:solidFill>
-                <a:latin typeface="Arial" pitchFamily="34" charset="0"/>
-                <a:ea typeface="Arial" pitchFamily="34" charset="-122"/>
-                <a:cs typeface="Arial" pitchFamily="34" charset="-120"/>
-              </a:rPr>
-              <a:t> </a:t>
-            </a:r>
-            <a:r>
-              <a:rPr lang="en-US" sz="1550" dirty="0" err="1">
-                <a:solidFill>
-                  <a:srgbClr val="24323A"/>
-                </a:solidFill>
-                <a:latin typeface="Arial" pitchFamily="34" charset="0"/>
-                <a:ea typeface="Arial" pitchFamily="34" charset="-122"/>
-                <a:cs typeface="Arial" pitchFamily="34" charset="-120"/>
-              </a:rPr>
-              <a:t>planering</a:t>
-            </a:r>
-            <a:r>
-              <a:rPr lang="en-US" sz="1550" dirty="0">
-                <a:solidFill>
-                  <a:srgbClr val="24323A"/>
-                </a:solidFill>
-                <a:latin typeface="Arial" pitchFamily="34" charset="0"/>
-                <a:ea typeface="Arial" pitchFamily="34" charset="-122"/>
-                <a:cs typeface="Arial" pitchFamily="34" charset="-120"/>
-              </a:rPr>
-              <a:t> av </a:t>
-            </a:r>
-            <a:r>
-              <a:rPr lang="en-US" sz="1550" dirty="0" err="1">
-                <a:solidFill>
-                  <a:srgbClr val="24323A"/>
-                </a:solidFill>
-                <a:latin typeface="Arial" pitchFamily="34" charset="0"/>
-                <a:ea typeface="Arial" pitchFamily="34" charset="-122"/>
-                <a:cs typeface="Arial" pitchFamily="34" charset="-120"/>
-              </a:rPr>
-              <a:t>arbetsbelastning</a:t>
-            </a:r>
-            <a:r>
-              <a:rPr lang="en-US" sz="1550" dirty="0">
-                <a:solidFill>
-                  <a:srgbClr val="24323A"/>
-                </a:solidFill>
-                <a:latin typeface="Arial" pitchFamily="34" charset="0"/>
-                <a:ea typeface="Arial" pitchFamily="34" charset="-122"/>
-                <a:cs typeface="Arial" pitchFamily="34" charset="-120"/>
-              </a:rPr>
-              <a:t> och </a:t>
-            </a:r>
-            <a:r>
-              <a:rPr lang="en-US" sz="1550" dirty="0" err="1">
-                <a:solidFill>
-                  <a:srgbClr val="24323A"/>
-                </a:solidFill>
-                <a:latin typeface="Arial" pitchFamily="34" charset="0"/>
-                <a:ea typeface="Arial" pitchFamily="34" charset="-122"/>
-                <a:cs typeface="Arial" pitchFamily="34" charset="-120"/>
-              </a:rPr>
-              <a:t>bemanning</a:t>
-            </a:r>
-            <a:r>
-              <a:rPr lang="en-US" sz="1550" dirty="0">
-                <a:solidFill>
-                  <a:srgbClr val="24323A"/>
-                </a:solidFill>
-                <a:latin typeface="Arial" pitchFamily="34" charset="0"/>
+              <a:rPr lang="sv-SE" sz="1400" dirty="0"/>
+              <a:t>Top-X ger stabil volym → lättare planera arbetsbelastning och bemanning</a:t>
+            </a:r>
+            <a:r>
+              <a:rPr lang="en-US" sz="1400" dirty="0">
+                <a:solidFill>
+                  <a:srgbClr val="24323A"/>
+                </a:solidFill>
                 <a:ea typeface="Arial" pitchFamily="34" charset="-122"/>
                 <a:cs typeface="Arial" pitchFamily="34" charset="-120"/>
               </a:rPr>
               <a:t>.</a:t>
             </a:r>
-            <a:endParaRPr lang="en-US" sz="1550" dirty="0"/>
+            <a:endParaRPr lang="en-US" sz="1400" dirty="0"/>
           </a:p>
           <a:p>
             <a:pPr marL="228600" indent="-228600">
@@ -7593,9 +7699,6 @@
             </a:endParaRPr>
           </a:p>
           <a:p>
-            <a:pPr marL="0" indent="0">
-              <a:buNone/>
-            </a:pPr>
             <a:r>
               <a:rPr lang="en-US" sz="1800" b="1" dirty="0" err="1">
                 <a:solidFill>
@@ -7610,63 +7713,65 @@
                   <a:srgbClr val="24323A"/>
                 </a:solidFill>
               </a:rPr>
-              <a:t>: Vi väljer Top ___% eftersom det ger ___ flaggningar och precision ___.</a:t>
+              <a:t>: Vi väljer Top </a:t>
+            </a:r>
+            <a:r>
+              <a:rPr lang="en-US" b="1" dirty="0">
+                <a:solidFill>
+                  <a:srgbClr val="24323A"/>
+                </a:solidFill>
+              </a:rPr>
+              <a:t>5</a:t>
+            </a:r>
+            <a:r>
+              <a:rPr lang="en-US" sz="1800" b="1" dirty="0">
+                <a:solidFill>
+                  <a:srgbClr val="24323A"/>
+                </a:solidFill>
+              </a:rPr>
+              <a:t>% eftersom det ger </a:t>
+            </a:r>
+            <a:r>
+              <a:rPr lang="en-US" b="1" dirty="0">
+                <a:solidFill>
+                  <a:srgbClr val="24323A"/>
+                </a:solidFill>
+              </a:rPr>
+              <a:t>ca 120</a:t>
+            </a:r>
+            <a:r>
+              <a:rPr lang="en-US" sz="1800" b="1" dirty="0">
+                <a:solidFill>
+                  <a:srgbClr val="24323A"/>
+                </a:solidFill>
+              </a:rPr>
+              <a:t> flaggningar och precision </a:t>
+            </a:r>
+            <a:r>
+              <a:rPr lang="en-SE" b="1" dirty="0"/>
+              <a:t>0.375</a:t>
+            </a:r>
+            <a:r>
+              <a:rPr lang="en-SE" dirty="0"/>
+              <a:t> (≈ </a:t>
+            </a:r>
+            <a:r>
+              <a:rPr lang="en-SE" b="1" dirty="0"/>
+              <a:t>38%</a:t>
+            </a:r>
+            <a:r>
+              <a:rPr lang="en-SE" dirty="0"/>
+              <a:t>)</a:t>
+            </a:r>
+            <a:r>
+              <a:rPr lang="en-US" sz="1800" b="1" dirty="0">
+                <a:solidFill>
+                  <a:srgbClr val="24323A"/>
+                </a:solidFill>
+              </a:rPr>
+              <a:t>.</a:t>
             </a:r>
             <a:endParaRPr lang="en-US" sz="1800" dirty="0"/>
-          </a:p>
-        </p:txBody>
-      </p:sp>
-      <p:sp>
-        <p:nvSpPr>
-          <p:cNvPr id="34" name="Text 32"/>
-          <p:cNvSpPr/>
-          <p:nvPr/>
-        </p:nvSpPr>
-        <p:spPr>
-          <a:xfrm>
-            <a:off x="4251960" y="4224528"/>
-            <a:ext cx="6583680" cy="310896"/>
-          </a:xfrm>
-          <a:prstGeom prst="rect">
-            <a:avLst/>
-          </a:prstGeom>
-          <a:noFill/>
-          <a:ln/>
-        </p:spPr>
-        <p:txBody>
-          <a:bodyPr wrap="square" lIns="254" tIns="254" rIns="254" bIns="254" rtlCol="0" anchor="ctr"/>
-          <a:lstStyle/>
-          <a:p>
-            <a:pPr marL="228600" indent="-228600">
-              <a:buSzPct val="100000"/>
-              <a:buChar char="•"/>
-            </a:pPr>
-            <a:endParaRPr lang="en-US" sz="1600" dirty="0">
-              <a:solidFill>
-                <a:srgbClr val="24323A"/>
-              </a:solidFill>
-              <a:latin typeface="Arial" pitchFamily="34" charset="0"/>
-              <a:ea typeface="Arial" pitchFamily="34" charset="-122"/>
-              <a:cs typeface="Arial" pitchFamily="34" charset="-120"/>
-            </a:endParaRPr>
-          </a:p>
-          <a:p>
-            <a:pPr marL="228600" indent="-228600">
-              <a:buSzPct val="100000"/>
-              <a:buChar char="•"/>
-            </a:pPr>
-            <a:r>
-              <a:rPr lang="en-US" sz="1600" dirty="0">
-                <a:solidFill>
-                  <a:srgbClr val="24323A"/>
-                </a:solidFill>
-                <a:latin typeface="Arial" pitchFamily="34" charset="0"/>
-                <a:ea typeface="Arial" pitchFamily="34" charset="-122"/>
-                <a:cs typeface="Arial" pitchFamily="34" charset="-120"/>
-              </a:rPr>
-              <a:t>FP: onödiga granskningar och mer kö.</a:t>
-            </a:r>
-            <a:endParaRPr lang="en-US" sz="1600" dirty="0"/>
           </a:p>
         </p:txBody>
       </p:sp>
@@ -7695,84 +7800,13 @@
               <a:buSzPct val="100000"/>
               <a:buChar char="•"/>
             </a:pPr>
-            <a:endParaRPr lang="en-US" sz="1600" dirty="0">
-              <a:solidFill>
-                <a:srgbClr val="24323A"/>
-              </a:solidFill>
-              <a:latin typeface="Arial" pitchFamily="34" charset="0"/>
-              <a:ea typeface="Arial" pitchFamily="34" charset="-122"/>
-              <a:cs typeface="Arial" pitchFamily="34" charset="-120"/>
-            </a:endParaRPr>
-          </a:p>
-          <a:p>
-            <a:pPr marL="228600" indent="-228600">
-              <a:buSzPct val="100000"/>
-              <a:buChar char="•"/>
-            </a:pPr>
-            <a:r>
-              <a:rPr lang="en-US" sz="1600" dirty="0">
-                <a:solidFill>
-                  <a:srgbClr val="24323A"/>
-                </a:solidFill>
-                <a:latin typeface="Arial" pitchFamily="34" charset="0"/>
-                <a:ea typeface="Arial" pitchFamily="34" charset="-122"/>
-                <a:cs typeface="Arial" pitchFamily="34" charset="-120"/>
-              </a:rPr>
-              <a:t>FN: vissa misstänkta fall missas.</a:t>
-            </a:r>
-            <a:endParaRPr lang="en-US" sz="1600" dirty="0"/>
-          </a:p>
-        </p:txBody>
-      </p:sp>
-      <p:sp>
-        <p:nvSpPr>
-          <p:cNvPr id="36" name="Text 34"/>
-          <p:cNvSpPr/>
-          <p:nvPr/>
-        </p:nvSpPr>
-        <p:spPr>
-          <a:xfrm>
-            <a:off x="4251960" y="4992624"/>
-            <a:ext cx="6583680" cy="310896"/>
-          </a:xfrm>
-          <a:prstGeom prst="rect">
-            <a:avLst/>
-          </a:prstGeom>
-          <a:noFill/>
-          <a:ln/>
-        </p:spPr>
-        <p:txBody>
-          <a:bodyPr wrap="square" lIns="254" tIns="254" rIns="254" bIns="254" rtlCol="0" anchor="ctr"/>
-          <a:lstStyle/>
-          <a:p>
-            <a:pPr marL="228600" indent="-228600">
-              <a:buSzPct val="100000"/>
-              <a:buChar char="•"/>
-            </a:pPr>
-            <a:endParaRPr lang="en-US" sz="1600" dirty="0">
-              <a:solidFill>
-                <a:srgbClr val="24323A"/>
-              </a:solidFill>
-              <a:latin typeface="Arial" pitchFamily="34" charset="0"/>
-              <a:ea typeface="Arial" pitchFamily="34" charset="-122"/>
-              <a:cs typeface="Arial" pitchFamily="34" charset="-120"/>
-            </a:endParaRPr>
-          </a:p>
-          <a:p>
-            <a:pPr marL="228600" indent="-228600">
-              <a:buSzPct val="100000"/>
-              <a:buChar char="•"/>
-            </a:pPr>
-            <a:r>
-              <a:rPr lang="en-US" sz="1600" dirty="0">
-                <a:solidFill>
-                  <a:srgbClr val="24323A"/>
-                </a:solidFill>
-                <a:latin typeface="Arial" pitchFamily="34" charset="0"/>
-                <a:ea typeface="Arial" pitchFamily="34" charset="-122"/>
-                <a:cs typeface="Arial" pitchFamily="34" charset="-120"/>
-              </a:rPr>
-              <a:t>För Operations är det viktigast att hålla volymen hanterbar.</a:t>
+            <a:r>
+              <a:rPr lang="sv-SE" sz="1600" dirty="0" err="1"/>
+              <a:t>Trade</a:t>
+            </a:r>
+            <a:r>
+              <a:rPr lang="sv-SE" sz="1600" dirty="0"/>
+              <a:t>-off: vi missar vissa fall (FN) men kön hålls hanterbar.</a:t>
             </a:r>
             <a:endParaRPr lang="en-US" sz="1600" dirty="0"/>
           </a:p>
@@ -7829,7 +7863,7 @@
           <p:nvPr>
             <p:extLst>
               <p:ext uri="{D42A27DB-BD31-4B8C-83A1-F6EECF244321}">
-                <p14:modId xmlns:p14="http://schemas.microsoft.com/office/powerpoint/2010/main" val="15418493"/>
+                <p14:modId xmlns:p14="http://schemas.microsoft.com/office/powerpoint/2010/main" val="3889306615"/>
               </p:ext>
             </p:extLst>
           </p:nvPr>
@@ -7972,6 +8006,10 @@
                     <a:lstStyle/>
                     <a:p>
                       <a:pPr algn="ctr"/>
+                      <a:r>
+                        <a:rPr lang="sv-SE" dirty="0"/>
+                        <a:t>72</a:t>
+                      </a:r>
                       <a:endParaRPr lang="en-SE" dirty="0"/>
                     </a:p>
                   </a:txBody>
@@ -7983,7 +8021,10 @@
                     <a:lstStyle/>
                     <a:p>
                       <a:pPr algn="ctr"/>
-                      <a:endParaRPr lang="en-SE" dirty="0"/>
+                      <a:r>
+                        <a:rPr lang="en-SE" dirty="0"/>
+                        <a:t>43%</a:t>
+                      </a:r>
                     </a:p>
                   </a:txBody>
                   <a:tcPr/>
@@ -8039,7 +8080,11 @@
                     <a:lstStyle/>
                     <a:p>
                       <a:pPr algn="ctr"/>
-                      <a:endParaRPr lang="en-SE"/>
+                      <a:r>
+                        <a:rPr lang="sv-SE" dirty="0"/>
+                        <a:t>120</a:t>
+                      </a:r>
+                      <a:endParaRPr lang="en-SE" dirty="0"/>
                     </a:p>
                   </a:txBody>
                   <a:tcPr/>
@@ -8050,7 +8095,10 @@
                     <a:lstStyle/>
                     <a:p>
                       <a:pPr algn="ctr"/>
-                      <a:endParaRPr lang="en-SE" dirty="0"/>
+                      <a:r>
+                        <a:rPr lang="en-SE" dirty="0"/>
+                        <a:t>38%</a:t>
+                      </a:r>
                     </a:p>
                   </a:txBody>
                   <a:tcPr/>
@@ -8106,7 +8154,11 @@
                     <a:lstStyle/>
                     <a:p>
                       <a:pPr algn="ctr"/>
-                      <a:endParaRPr lang="en-SE" dirty="0"/>
+                      <a:r>
+                        <a:rPr lang="sv-SE" b="0" dirty="0"/>
+                        <a:t>240</a:t>
+                      </a:r>
+                      <a:endParaRPr lang="en-SE" b="0" dirty="0"/>
                     </a:p>
                   </a:txBody>
                   <a:tcPr/>
@@ -8117,7 +8169,10 @@
                     <a:lstStyle/>
                     <a:p>
                       <a:pPr algn="ctr"/>
-                      <a:endParaRPr lang="en-SE" dirty="0"/>
+                      <a:r>
+                        <a:rPr lang="en-SE" b="0" dirty="0"/>
+                        <a:t>30%</a:t>
+                      </a:r>
                     </a:p>
                   </a:txBody>
                   <a:tcPr/>
@@ -8323,6 +8378,17 @@
               <a:buNone/>
             </a:pPr>
             <a:r>
+              <a:rPr lang="en-US" sz="1600" b="1" dirty="0" err="1">
+                <a:solidFill>
+                  <a:srgbClr val="24323A"/>
+                </a:solidFill>
+                <a:latin typeface="Arial" pitchFamily="34" charset="0"/>
+                <a:ea typeface="Arial" pitchFamily="34" charset="-122"/>
+                <a:cs typeface="Arial" pitchFamily="34" charset="-120"/>
+              </a:rPr>
+              <a:t>När</a:t>
+            </a:r>
+            <a:r>
               <a:rPr lang="en-US" sz="1600" b="1" dirty="0">
                 <a:solidFill>
                   <a:srgbClr val="24323A"/>
@@ -8331,7 +8397,7 @@
                 <a:ea typeface="Arial" pitchFamily="34" charset="-122"/>
                 <a:cs typeface="Arial" pitchFamily="34" charset="-120"/>
               </a:rPr>
-              <a:t>När new_data kommer</a:t>
+              <a:t> new data kommer</a:t>
             </a:r>
             <a:endParaRPr lang="en-US" sz="1600" dirty="0"/>
           </a:p>
@@ -8411,7 +8477,7 @@
                 <a:ea typeface="Arial" pitchFamily="34" charset="-122"/>
                 <a:cs typeface="Arial" pitchFamily="34" charset="-120"/>
               </a:rPr>
-              <a:t>Vi flaggar Top ___% → ___ ärenden till granskning.</a:t>
+              <a:t>Vi flaggar Top  5% → ___ ärenden till granskning.</a:t>
             </a:r>
             <a:endParaRPr lang="en-US" sz="1580" dirty="0"/>
           </a:p>
@@ -8443,15 +8509,8 @@
               <a:buChar char="•"/>
             </a:pPr>
             <a:r>
-              <a:rPr lang="en-US" sz="1580" dirty="0">
-                <a:solidFill>
-                  <a:srgbClr val="24323A"/>
-                </a:solidFill>
-                <a:latin typeface="Arial" pitchFamily="34" charset="0"/>
-                <a:ea typeface="Arial" pitchFamily="34" charset="-122"/>
-                <a:cs typeface="Arial" pitchFamily="34" charset="-120"/>
-              </a:rPr>
-              <a:t>Reflektion: volymen ska kännas hanterbar och ge en tydlig kö.</a:t>
+              <a:rPr lang="sv-SE" sz="1600" dirty="0"/>
+              <a:t>Reflektion: Top-5% ska ge en tydlig och hanterbar kö för teamet</a:t>
             </a:r>
             <a:endParaRPr lang="en-US" sz="1580" dirty="0"/>
           </a:p>
@@ -8562,15 +8621,8 @@
               <a:buChar char="•"/>
             </a:pPr>
             <a:r>
-              <a:rPr lang="en-US" sz="1580" dirty="0">
-                <a:solidFill>
-                  <a:srgbClr val="24323A"/>
-                </a:solidFill>
-                <a:latin typeface="Arial" pitchFamily="34" charset="0"/>
-                <a:ea typeface="Arial" pitchFamily="34" charset="-122"/>
-                <a:cs typeface="Arial" pitchFamily="34" charset="-120"/>
-              </a:rPr>
-              <a:t>Beteenden kan ändras över tid (drift).</a:t>
+              <a:rPr lang="sv-SE" sz="1600"/>
+              <a:t>Beteenden kan ändras över tid (drift) → kvalitet kan sjunka</a:t>
             </a:r>
             <a:endParaRPr lang="en-US" sz="1580" dirty="0"/>
           </a:p>

</xml_diff>